<commit_message>
Fix alignment: tensions x-overlap + S5-01 subtitle gap
- S4-02: pushed 'vs' and secondary words further right to avoid x-overlap
  with large 100px primary words that overflow their textboxes
- S5-01: moved subtitle from y=306 to y=335 to add proper gap after
  80px 'FOUR TOOLS.' headline (was only 4px clearance, now 25px+)

Co-authored-by: Copilot <223556219+Copilot@users.noreply.github.com>
</commit_message>
<xml_diff>
--- a/presentation.pptx
+++ b/presentation.pptx
@@ -13945,7 +13945,7 @@
         <p:spPr>
           <a:xfrm>
             <a:off x="1051560" y="3135630"/>
-            <a:ext cx="6095999" cy="857250"/>
+            <a:ext cx="7238999" cy="857250"/>
           </a:xfrm>
           <a:prstGeom prst="rect">
             <a:avLst/>
@@ -13984,7 +13984,7 @@
         </p:nvSpPr>
         <p:spPr>
           <a:xfrm>
-            <a:off x="7261860" y="3583304"/>
+            <a:off x="8481060" y="3583304"/>
             <a:ext cx="761999" cy="380999"/>
           </a:xfrm>
           <a:prstGeom prst="rect">
@@ -14024,8 +14024,8 @@
         </p:nvSpPr>
         <p:spPr>
           <a:xfrm>
-            <a:off x="8100060" y="3373755"/>
-            <a:ext cx="5715000" cy="619124"/>
+            <a:off x="9357360" y="3373755"/>
+            <a:ext cx="4762500" cy="619124"/>
           </a:xfrm>
           <a:prstGeom prst="rect">
             <a:avLst/>
@@ -14148,7 +14148,7 @@
         <p:spPr>
           <a:xfrm>
             <a:off x="1051560" y="4745355"/>
-            <a:ext cx="6477000" cy="857250"/>
+            <a:ext cx="7238999" cy="857250"/>
           </a:xfrm>
           <a:prstGeom prst="rect">
             <a:avLst/>
@@ -14187,7 +14187,7 @@
         </p:nvSpPr>
         <p:spPr>
           <a:xfrm>
-            <a:off x="7642859" y="5193030"/>
+            <a:off x="8290560" y="5193030"/>
             <a:ext cx="761999" cy="380999"/>
           </a:xfrm>
           <a:prstGeom prst="rect">
@@ -14227,8 +14227,8 @@
         </p:nvSpPr>
         <p:spPr>
           <a:xfrm>
-            <a:off x="8481060" y="4983480"/>
-            <a:ext cx="5334000" cy="619124"/>
+            <a:off x="9166859" y="4983480"/>
+            <a:ext cx="4762500" cy="619124"/>
           </a:xfrm>
           <a:prstGeom prst="rect">
             <a:avLst/>
@@ -14351,7 +14351,7 @@
         <p:spPr>
           <a:xfrm>
             <a:off x="1051560" y="6355080"/>
-            <a:ext cx="4381500" cy="857250"/>
+            <a:ext cx="5524499" cy="857250"/>
           </a:xfrm>
           <a:prstGeom prst="rect">
             <a:avLst/>
@@ -14390,7 +14390,7 @@
         </p:nvSpPr>
         <p:spPr>
           <a:xfrm>
-            <a:off x="5547360" y="6802755"/>
+            <a:off x="6690360" y="6802755"/>
             <a:ext cx="761999" cy="380999"/>
           </a:xfrm>
           <a:prstGeom prst="rect">
@@ -14430,8 +14430,8 @@
         </p:nvSpPr>
         <p:spPr>
           <a:xfrm>
-            <a:off x="6385560" y="6593205"/>
-            <a:ext cx="4000500" cy="619124"/>
+            <a:off x="7566660" y="6593205"/>
+            <a:ext cx="3619499" cy="619124"/>
           </a:xfrm>
           <a:prstGeom prst="rect">
             <a:avLst/>
@@ -17708,7 +17708,7 @@
         </p:nvSpPr>
         <p:spPr>
           <a:xfrm>
-            <a:off x="1051560" y="2821305"/>
+            <a:off x="1051560" y="3097530"/>
             <a:ext cx="12382500" cy="228600"/>
           </a:xfrm>
           <a:prstGeom prst="rect">

</xml_diff>

<commit_message>
Fix slide 21 headline position, slide 24 box height, slide 25 icon/bar sizing
- S3-08: shift all content +67px (headline was at y=117 overlapping the tag)
- S4-03: increase callout box height 62→90px, center text vertically
- S4-04: enlarge tool icon circles 40→56px; K8s/Argo layer bars 93→120px,
  Argo shifted to y=798, diagram border extended to h=540

Co-authored-by: Copilot <223556219+Copilot@users.noreply.github.com>
</commit_message>
<xml_diff>
--- a/presentation.pptx
+++ b/presentation.pptx
@@ -11900,7 +11900,7 @@
         </p:nvSpPr>
         <p:spPr>
           <a:xfrm>
-            <a:off x="1051560" y="1068705"/>
+            <a:off x="1051560" y="1706880"/>
             <a:ext cx="11430000" cy="714375"/>
           </a:xfrm>
           <a:prstGeom prst="rect">
@@ -11940,7 +11940,7 @@
         </p:nvSpPr>
         <p:spPr>
           <a:xfrm>
-            <a:off x="1051560" y="1783079"/>
+            <a:off x="1051560" y="2421255"/>
             <a:ext cx="11430000" cy="714375"/>
           </a:xfrm>
           <a:prstGeom prst="rect">
@@ -11980,7 +11980,7 @@
         </p:nvSpPr>
         <p:spPr>
           <a:xfrm>
-            <a:off x="1051560" y="2659379"/>
+            <a:off x="1051560" y="3297554"/>
             <a:ext cx="3810000" cy="257175"/>
           </a:xfrm>
           <a:prstGeom prst="rect">
@@ -12020,7 +12020,7 @@
         </p:nvSpPr>
         <p:spPr>
           <a:xfrm>
-            <a:off x="3743325" y="3124200"/>
+            <a:off x="3743325" y="3762375"/>
             <a:ext cx="2667000" cy="666750"/>
           </a:xfrm>
           <a:prstGeom prst="rect">
@@ -12063,7 +12063,7 @@
         </p:nvSpPr>
         <p:spPr>
           <a:xfrm>
-            <a:off x="4156709" y="3278505"/>
+            <a:off x="4156709" y="3916680"/>
             <a:ext cx="1657350" cy="180975"/>
           </a:xfrm>
           <a:prstGeom prst="rect">
@@ -12103,7 +12103,7 @@
         </p:nvSpPr>
         <p:spPr>
           <a:xfrm>
-            <a:off x="5067300" y="3790949"/>
+            <a:off x="5067300" y="4429125"/>
             <a:ext cx="19050" cy="476249"/>
           </a:xfrm>
           <a:prstGeom prst="rect">
@@ -12146,7 +12146,7 @@
         </p:nvSpPr>
         <p:spPr>
           <a:xfrm>
-            <a:off x="2047875" y="4267200"/>
+            <a:off x="2047875" y="4905375"/>
             <a:ext cx="6057900" cy="19050"/>
           </a:xfrm>
           <a:prstGeom prst="rect">
@@ -12189,7 +12189,7 @@
         </p:nvSpPr>
         <p:spPr>
           <a:xfrm>
-            <a:off x="2047875" y="4286250"/>
+            <a:off x="2047875" y="4924424"/>
             <a:ext cx="19050" cy="266700"/>
           </a:xfrm>
           <a:prstGeom prst="rect">
@@ -12232,7 +12232,7 @@
         </p:nvSpPr>
         <p:spPr>
           <a:xfrm>
-            <a:off x="5067300" y="4286250"/>
+            <a:off x="5067300" y="4924424"/>
             <a:ext cx="19050" cy="266700"/>
           </a:xfrm>
           <a:prstGeom prst="rect">
@@ -12275,7 +12275,7 @@
         </p:nvSpPr>
         <p:spPr>
           <a:xfrm>
-            <a:off x="8086725" y="4286250"/>
+            <a:off x="8086725" y="4924424"/>
             <a:ext cx="19050" cy="266700"/>
           </a:xfrm>
           <a:prstGeom prst="rect">
@@ -12318,7 +12318,7 @@
         </p:nvSpPr>
         <p:spPr>
           <a:xfrm>
-            <a:off x="1143000" y="4552950"/>
+            <a:off x="1143000" y="5191125"/>
             <a:ext cx="1828800" cy="571500"/>
           </a:xfrm>
           <a:prstGeom prst="rect">
@@ -12363,7 +12363,7 @@
         </p:nvSpPr>
         <p:spPr>
           <a:xfrm>
-            <a:off x="4152900" y="4552950"/>
+            <a:off x="4152900" y="5191125"/>
             <a:ext cx="1828800" cy="571500"/>
           </a:xfrm>
           <a:prstGeom prst="rect">
@@ -12408,7 +12408,7 @@
         </p:nvSpPr>
         <p:spPr>
           <a:xfrm>
-            <a:off x="7181849" y="4552950"/>
+            <a:off x="7181849" y="5191125"/>
             <a:ext cx="1828800" cy="571500"/>
           </a:xfrm>
           <a:prstGeom prst="rect">
@@ -12453,7 +12453,7 @@
         </p:nvSpPr>
         <p:spPr>
           <a:xfrm>
-            <a:off x="1280160" y="4669155"/>
+            <a:off x="1280160" y="5307330"/>
             <a:ext cx="1371600" cy="161924"/>
           </a:xfrm>
           <a:prstGeom prst="rect">
@@ -12493,7 +12493,7 @@
         </p:nvSpPr>
         <p:spPr>
           <a:xfrm>
-            <a:off x="4137659" y="4669155"/>
+            <a:off x="4137659" y="5307330"/>
             <a:ext cx="1676400" cy="161924"/>
           </a:xfrm>
           <a:prstGeom prst="rect">
@@ -12533,7 +12533,7 @@
         </p:nvSpPr>
         <p:spPr>
           <a:xfrm>
-            <a:off x="7319010" y="4669155"/>
+            <a:off x="7319010" y="5307330"/>
             <a:ext cx="1371600" cy="161924"/>
           </a:xfrm>
           <a:prstGeom prst="rect">
@@ -12573,8 +12573,8 @@
         </p:nvSpPr>
         <p:spPr>
           <a:xfrm>
-            <a:off x="9105900" y="2733674"/>
-            <a:ext cx="19050" cy="2476499"/>
+            <a:off x="9105900" y="3371850"/>
+            <a:ext cx="19050" cy="2809875"/>
           </a:xfrm>
           <a:prstGeom prst="rect">
             <a:avLst/>
@@ -12616,7 +12616,7 @@
         </p:nvSpPr>
         <p:spPr>
           <a:xfrm>
-            <a:off x="9262110" y="2659379"/>
+            <a:off x="9262110" y="3297554"/>
             <a:ext cx="5715000" cy="257175"/>
           </a:xfrm>
           <a:prstGeom prst="rect">
@@ -12656,7 +12656,7 @@
         </p:nvSpPr>
         <p:spPr>
           <a:xfrm>
-            <a:off x="9353550" y="4114800"/>
+            <a:off x="9353550" y="4752974"/>
             <a:ext cx="2667000" cy="761999"/>
           </a:xfrm>
           <a:prstGeom prst="rect">
@@ -12699,7 +12699,7 @@
         </p:nvSpPr>
         <p:spPr>
           <a:xfrm>
-            <a:off x="9490710" y="4307205"/>
+            <a:off x="9490710" y="4945380"/>
             <a:ext cx="2209800" cy="180975"/>
           </a:xfrm>
           <a:prstGeom prst="rect">
@@ -12739,7 +12739,7 @@
         </p:nvSpPr>
         <p:spPr>
           <a:xfrm>
-            <a:off x="11976735" y="4259580"/>
+            <a:off x="11976735" y="4897755"/>
             <a:ext cx="571500" cy="476249"/>
           </a:xfrm>
           <a:prstGeom prst="rect">
@@ -12779,7 +12779,7 @@
         </p:nvSpPr>
         <p:spPr>
           <a:xfrm>
-            <a:off x="12782550" y="3352800"/>
+            <a:off x="12782550" y="3990974"/>
             <a:ext cx="1905000" cy="666750"/>
           </a:xfrm>
           <a:prstGeom prst="rect">
@@ -12824,7 +12824,7 @@
         </p:nvSpPr>
         <p:spPr>
           <a:xfrm>
-            <a:off x="12919710" y="3507105"/>
+            <a:off x="12919710" y="4145280"/>
             <a:ext cx="1447800" cy="161924"/>
           </a:xfrm>
           <a:prstGeom prst="rect">
@@ -12864,7 +12864,7 @@
         </p:nvSpPr>
         <p:spPr>
           <a:xfrm>
-            <a:off x="12782550" y="4114800"/>
+            <a:off x="12782550" y="4752974"/>
             <a:ext cx="1905000" cy="666750"/>
           </a:xfrm>
           <a:prstGeom prst="rect">
@@ -12909,7 +12909,7 @@
         </p:nvSpPr>
         <p:spPr>
           <a:xfrm>
-            <a:off x="12919710" y="4269105"/>
+            <a:off x="12919710" y="4907280"/>
             <a:ext cx="1447800" cy="161924"/>
           </a:xfrm>
           <a:prstGeom prst="rect">
@@ -12949,7 +12949,7 @@
         </p:nvSpPr>
         <p:spPr>
           <a:xfrm>
-            <a:off x="12782550" y="4876800"/>
+            <a:off x="12782550" y="5514975"/>
             <a:ext cx="1905000" cy="666750"/>
           </a:xfrm>
           <a:prstGeom prst="rect">
@@ -12994,7 +12994,7 @@
         </p:nvSpPr>
         <p:spPr>
           <a:xfrm>
-            <a:off x="12919710" y="5031105"/>
+            <a:off x="12919710" y="5669280"/>
             <a:ext cx="1447800" cy="161924"/>
           </a:xfrm>
           <a:prstGeom prst="rect">
@@ -13034,7 +13034,7 @@
         </p:nvSpPr>
         <p:spPr>
           <a:xfrm>
-            <a:off x="1143000" y="7496175"/>
+            <a:off x="1143000" y="8134350"/>
             <a:ext cx="16002000" cy="476249"/>
           </a:xfrm>
           <a:prstGeom prst="rect">
@@ -13077,7 +13077,7 @@
         </p:nvSpPr>
         <p:spPr>
           <a:xfrm>
-            <a:off x="3280409" y="7593330"/>
+            <a:off x="3280409" y="8231505"/>
             <a:ext cx="11553825" cy="180975"/>
           </a:xfrm>
           <a:prstGeom prst="rect">
@@ -14863,7 +14863,7 @@
         <p:spPr>
           <a:xfrm>
             <a:off x="1143000" y="6581775"/>
-            <a:ext cx="5334000" cy="590550"/>
+            <a:ext cx="5334000" cy="857250"/>
           </a:xfrm>
           <a:prstGeom prst="rect">
             <a:avLst/>
@@ -14905,7 +14905,7 @@
         </p:nvSpPr>
         <p:spPr>
           <a:xfrm>
-            <a:off x="1280160" y="6678930"/>
+            <a:off x="1280160" y="6831330"/>
             <a:ext cx="4762500" cy="209550"/>
           </a:xfrm>
           <a:prstGeom prst="rect">
@@ -14946,7 +14946,7 @@
         <p:spPr>
           <a:xfrm>
             <a:off x="6477000" y="6581775"/>
-            <a:ext cx="5334000" cy="590550"/>
+            <a:ext cx="5334000" cy="857250"/>
           </a:xfrm>
           <a:prstGeom prst="rect">
             <a:avLst/>
@@ -14988,7 +14988,7 @@
         </p:nvSpPr>
         <p:spPr>
           <a:xfrm>
-            <a:off x="6614159" y="6678930"/>
+            <a:off x="6614159" y="6831330"/>
             <a:ext cx="4762500" cy="209550"/>
           </a:xfrm>
           <a:prstGeom prst="rect">
@@ -15029,7 +15029,7 @@
         <p:spPr>
           <a:xfrm>
             <a:off x="11811000" y="6581775"/>
-            <a:ext cx="5334000" cy="590550"/>
+            <a:ext cx="5334000" cy="857250"/>
           </a:xfrm>
           <a:prstGeom prst="rect">
             <a:avLst/>
@@ -15071,7 +15071,7 @@
         </p:nvSpPr>
         <p:spPr>
           <a:xfrm>
-            <a:off x="11948160" y="6678930"/>
+            <a:off x="11948160" y="6831330"/>
             <a:ext cx="4762500" cy="209550"/>
           </a:xfrm>
           <a:prstGeom prst="rect">
@@ -15505,7 +15505,7 @@
         <p:spPr>
           <a:xfrm>
             <a:off x="1143000" y="3724275"/>
-            <a:ext cx="16002000" cy="4619625"/>
+            <a:ext cx="16002000" cy="5143500"/>
           </a:xfrm>
           <a:prstGeom prst="rect">
             <a:avLst/>
@@ -15673,8 +15673,8 @@
         </p:nvSpPr>
         <p:spPr>
           <a:xfrm>
-            <a:off x="3009900" y="4067175"/>
-            <a:ext cx="380999" cy="380999"/>
+            <a:off x="2933700" y="3990974"/>
+            <a:ext cx="533400" cy="533400"/>
           </a:xfrm>
           <a:prstGeom prst="ellipse">
             <a:avLst/>
@@ -15716,8 +15716,8 @@
         </p:nvSpPr>
         <p:spPr>
           <a:xfrm>
-            <a:off x="3023235" y="4059555"/>
-            <a:ext cx="190499" cy="209550"/>
+            <a:off x="2937510" y="4078605"/>
+            <a:ext cx="209550" cy="209550"/>
           </a:xfrm>
           <a:prstGeom prst="rect">
             <a:avLst/>
@@ -15962,8 +15962,8 @@
         </p:nvSpPr>
         <p:spPr>
           <a:xfrm>
-            <a:off x="6972300" y="4067175"/>
-            <a:ext cx="380999" cy="380999"/>
+            <a:off x="6896099" y="3990974"/>
+            <a:ext cx="533400" cy="533400"/>
           </a:xfrm>
           <a:prstGeom prst="ellipse">
             <a:avLst/>
@@ -16005,8 +16005,8 @@
         </p:nvSpPr>
         <p:spPr>
           <a:xfrm>
-            <a:off x="6985634" y="4059555"/>
-            <a:ext cx="190499" cy="209550"/>
+            <a:off x="6899909" y="4078605"/>
+            <a:ext cx="209550" cy="209550"/>
           </a:xfrm>
           <a:prstGeom prst="rect">
             <a:avLst/>
@@ -16251,8 +16251,8 @@
         </p:nvSpPr>
         <p:spPr>
           <a:xfrm>
-            <a:off x="10934699" y="4067175"/>
-            <a:ext cx="380999" cy="380999"/>
+            <a:off x="10858500" y="3990974"/>
+            <a:ext cx="533400" cy="533400"/>
           </a:xfrm>
           <a:prstGeom prst="ellipse">
             <a:avLst/>
@@ -16294,8 +16294,8 @@
         </p:nvSpPr>
         <p:spPr>
           <a:xfrm>
-            <a:off x="10948035" y="4059555"/>
-            <a:ext cx="190499" cy="209550"/>
+            <a:off x="10862310" y="4078605"/>
+            <a:ext cx="209550" cy="209550"/>
           </a:xfrm>
           <a:prstGeom prst="rect">
             <a:avLst/>
@@ -16540,8 +16540,8 @@
         </p:nvSpPr>
         <p:spPr>
           <a:xfrm>
-            <a:off x="14897100" y="4067175"/>
-            <a:ext cx="380999" cy="380999"/>
+            <a:off x="14820899" y="3990974"/>
+            <a:ext cx="533400" cy="533400"/>
           </a:xfrm>
           <a:prstGeom prst="ellipse">
             <a:avLst/>
@@ -16583,8 +16583,8 @@
         </p:nvSpPr>
         <p:spPr>
           <a:xfrm>
-            <a:off x="14910434" y="4059555"/>
-            <a:ext cx="190499" cy="209550"/>
+            <a:off x="14824710" y="4078605"/>
+            <a:ext cx="209550" cy="209550"/>
           </a:xfrm>
           <a:prstGeom prst="rect">
             <a:avLst/>
@@ -16947,7 +16947,7 @@
         <p:spPr>
           <a:xfrm>
             <a:off x="1257300" y="6019800"/>
-            <a:ext cx="15773400" cy="885825"/>
+            <a:ext cx="15773400" cy="1143000"/>
           </a:xfrm>
           <a:prstGeom prst="rect">
             <a:avLst/>
@@ -16989,8 +16989,8 @@
         </p:nvSpPr>
         <p:spPr>
           <a:xfrm>
-            <a:off x="6334125" y="6276975"/>
-            <a:ext cx="380999" cy="380999"/>
+            <a:off x="6257925" y="6324600"/>
+            <a:ext cx="533400" cy="533400"/>
           </a:xfrm>
           <a:prstGeom prst="ellipse">
             <a:avLst/>
@@ -17032,7 +17032,7 @@
         </p:nvSpPr>
         <p:spPr>
           <a:xfrm>
-            <a:off x="6318885" y="6259830"/>
+            <a:off x="6271259" y="6374130"/>
             <a:ext cx="285750" cy="152400"/>
           </a:xfrm>
           <a:prstGeom prst="rect">
@@ -17072,7 +17072,7 @@
         </p:nvSpPr>
         <p:spPr>
           <a:xfrm>
-            <a:off x="6776085" y="6069330"/>
+            <a:off x="6861810" y="6202680"/>
             <a:ext cx="5715000" cy="323849"/>
           </a:xfrm>
           <a:prstGeom prst="rect">
@@ -17112,7 +17112,7 @@
         </p:nvSpPr>
         <p:spPr>
           <a:xfrm>
-            <a:off x="6776085" y="6374130"/>
+            <a:off x="6861810" y="6507480"/>
             <a:ext cx="7620000" cy="161924"/>
           </a:xfrm>
           <a:prstGeom prst="rect">
@@ -17152,7 +17152,7 @@
         </p:nvSpPr>
         <p:spPr>
           <a:xfrm>
-            <a:off x="8938259" y="6888480"/>
+            <a:off x="8938259" y="7145655"/>
             <a:ext cx="285750" cy="323849"/>
           </a:xfrm>
           <a:prstGeom prst="rect">
@@ -17192,8 +17192,8 @@
         </p:nvSpPr>
         <p:spPr>
           <a:xfrm>
-            <a:off x="1257300" y="7343775"/>
-            <a:ext cx="15773400" cy="885825"/>
+            <a:off x="1257300" y="7600950"/>
+            <a:ext cx="15773400" cy="1143000"/>
           </a:xfrm>
           <a:prstGeom prst="rect">
             <a:avLst/>
@@ -17235,8 +17235,8 @@
         </p:nvSpPr>
         <p:spPr>
           <a:xfrm>
-            <a:off x="6657975" y="7591424"/>
-            <a:ext cx="380999" cy="380999"/>
+            <a:off x="6581775" y="7905749"/>
+            <a:ext cx="533400" cy="533400"/>
           </a:xfrm>
           <a:prstGeom prst="ellipse">
             <a:avLst/>
@@ -17278,8 +17278,8 @@
         </p:nvSpPr>
         <p:spPr>
           <a:xfrm>
-            <a:off x="6709410" y="7593330"/>
-            <a:ext cx="114300" cy="180975"/>
+            <a:off x="6671310" y="7974330"/>
+            <a:ext cx="133350" cy="190499"/>
           </a:xfrm>
           <a:prstGeom prst="rect">
             <a:avLst/>
@@ -17318,7 +17318,7 @@
         </p:nvSpPr>
         <p:spPr>
           <a:xfrm>
-            <a:off x="7099935" y="7393305"/>
+            <a:off x="7166609" y="7650480"/>
             <a:ext cx="3810000" cy="323849"/>
           </a:xfrm>
           <a:prstGeom prst="rect">
@@ -17358,7 +17358,7 @@
         </p:nvSpPr>
         <p:spPr>
           <a:xfrm>
-            <a:off x="7099935" y="7698105"/>
+            <a:off x="7166609" y="7955280"/>
             <a:ext cx="6667499" cy="161924"/>
           </a:xfrm>
           <a:prstGeom prst="rect">

</xml_diff>

<commit_message>
Add S6-01 ASO Intro, S6-02 Architecture/Demo, S6-03 Takeaway, S7-01 Crossplane Intro
5 new slides (slides 29-33):
- S6-01 ASO Intro: dark intro with watermark, nav dots, bottom-anchored headline
- S6-02 Architecture: 4-card flow diagram Git→ArgoCD→ASO→Azure
- S6-02 Demo: APPLY YAML/GET AZURE headlines + 3-step pills
- S6-03 Takeaway: light slide, 3 feature cards + dark bottom note bar
- S7-01 Crossplane Intro: same pattern as S6-01

Co-authored-by: Copilot <223556219+Copilot@users.noreply.github.com>
</commit_message>
<xml_diff>
--- a/presentation.pptx
+++ b/presentation.pptx
@@ -33,6 +33,11 @@
     <p:sldId id="281" r:id="rId32"/>
     <p:sldId id="282" r:id="rId33"/>
     <p:sldId id="283" r:id="rId34"/>
+    <p:sldId id="284" r:id="rId35"/>
+    <p:sldId id="285" r:id="rId36"/>
+    <p:sldId id="286" r:id="rId37"/>
+    <p:sldId id="287" r:id="rId38"/>
+    <p:sldId id="288" r:id="rId39"/>
   </p:sldIdLst>
   <p:sldSz cx="18288000" cy="10287000" type="screen4x3"/>
   <p:notesSz cx="6858000" cy="9144000"/>
@@ -21963,6 +21968,491 @@
 </p:sld>
 </file>
 
+<file path=ppt/slides/slide29.xml><?xml version="1.0" encoding="utf-8"?>
+<p:sld xmlns:a="http://schemas.openxmlformats.org/drawingml/2006/main" xmlns:p="http://schemas.openxmlformats.org/presentationml/2006/main" xmlns:r="http://schemas.openxmlformats.org/officeDocument/2006/relationships">
+  <p:cSld>
+    <p:spTree>
+      <p:nvGrpSpPr>
+        <p:cNvPr id="1" name=""/>
+        <p:cNvGrpSpPr/>
+        <p:nvPr/>
+      </p:nvGrpSpPr>
+      <p:grpSpPr/>
+      <p:sp>
+        <p:nvSpPr>
+          <p:cNvPr id="2" name="Rectangle 1"/>
+          <p:cNvSpPr/>
+          <p:nvPr/>
+        </p:nvSpPr>
+        <p:spPr>
+          <a:xfrm>
+            <a:off x="0" y="0"/>
+            <a:ext cx="18288000" cy="10287000"/>
+          </a:xfrm>
+          <a:prstGeom prst="rect">
+            <a:avLst/>
+          </a:prstGeom>
+          <a:solidFill>
+            <a:srgbClr val="000000"/>
+          </a:solidFill>
+          <a:ln>
+            <a:noFill/>
+          </a:ln>
+        </p:spPr>
+        <p:style>
+          <a:lnRef idx="1">
+            <a:schemeClr val="accent1"/>
+          </a:lnRef>
+          <a:fillRef idx="3">
+            <a:schemeClr val="accent1"/>
+          </a:fillRef>
+          <a:effectRef idx="2">
+            <a:schemeClr val="accent1"/>
+          </a:effectRef>
+          <a:fontRef idx="minor">
+            <a:schemeClr val="lt1"/>
+          </a:fontRef>
+        </p:style>
+        <p:txBody>
+          <a:bodyPr rtlCol="0" anchor="ctr"/>
+          <a:lstStyle/>
+          <a:p>
+            <a:pPr algn="ctr"/>
+          </a:p>
+        </p:txBody>
+      </p:sp>
+      <p:sp>
+        <p:nvSpPr>
+          <p:cNvPr id="3" name="Rectangle 2"/>
+          <p:cNvSpPr/>
+          <p:nvPr/>
+        </p:nvSpPr>
+        <p:spPr>
+          <a:xfrm>
+            <a:off x="0" y="0"/>
+            <a:ext cx="76200" cy="10287000"/>
+          </a:xfrm>
+          <a:prstGeom prst="rect">
+            <a:avLst/>
+          </a:prstGeom>
+          <a:solidFill>
+            <a:srgbClr val="FFFFFF"/>
+          </a:solidFill>
+          <a:ln>
+            <a:noFill/>
+          </a:ln>
+        </p:spPr>
+        <p:style>
+          <a:lnRef idx="1">
+            <a:schemeClr val="accent1"/>
+          </a:lnRef>
+          <a:fillRef idx="3">
+            <a:schemeClr val="accent1"/>
+          </a:fillRef>
+          <a:effectRef idx="2">
+            <a:schemeClr val="accent1"/>
+          </a:effectRef>
+          <a:fontRef idx="minor">
+            <a:schemeClr val="lt1"/>
+          </a:fontRef>
+        </p:style>
+        <p:txBody>
+          <a:bodyPr rtlCol="0" anchor="ctr"/>
+          <a:lstStyle/>
+          <a:p>
+            <a:pPr algn="ctr"/>
+          </a:p>
+        </p:txBody>
+      </p:sp>
+      <p:sp>
+        <p:nvSpPr>
+          <p:cNvPr id="4" name="Rectangle 3"/>
+          <p:cNvSpPr/>
+          <p:nvPr/>
+        </p:nvSpPr>
+        <p:spPr>
+          <a:xfrm>
+            <a:off x="16383000" y="10096500"/>
+            <a:ext cx="1905000" cy="76200"/>
+          </a:xfrm>
+          <a:prstGeom prst="rect">
+            <a:avLst/>
+          </a:prstGeom>
+          <a:solidFill>
+            <a:srgbClr val="FFFFFF"/>
+          </a:solidFill>
+          <a:ln>
+            <a:noFill/>
+          </a:ln>
+        </p:spPr>
+        <p:style>
+          <a:lnRef idx="1">
+            <a:schemeClr val="accent1"/>
+          </a:lnRef>
+          <a:fillRef idx="3">
+            <a:schemeClr val="accent1"/>
+          </a:fillRef>
+          <a:effectRef idx="2">
+            <a:schemeClr val="accent1"/>
+          </a:effectRef>
+          <a:fontRef idx="minor">
+            <a:schemeClr val="lt1"/>
+          </a:fontRef>
+        </p:style>
+        <p:txBody>
+          <a:bodyPr rtlCol="0" anchor="ctr"/>
+          <a:lstStyle/>
+          <a:p>
+            <a:pPr algn="ctr"/>
+          </a:p>
+        </p:txBody>
+      </p:sp>
+      <p:sp>
+        <p:nvSpPr>
+          <p:cNvPr id="5" name="Oval 4"/>
+          <p:cNvSpPr/>
+          <p:nvPr/>
+        </p:nvSpPr>
+        <p:spPr>
+          <a:xfrm>
+            <a:off x="16954500" y="1523999"/>
+            <a:ext cx="133350" cy="133350"/>
+          </a:xfrm>
+          <a:prstGeom prst="ellipse">
+            <a:avLst/>
+          </a:prstGeom>
+          <a:solidFill>
+            <a:srgbClr val="FFFFFF"/>
+          </a:solidFill>
+          <a:ln>
+            <a:noFill/>
+          </a:ln>
+        </p:spPr>
+        <p:style>
+          <a:lnRef idx="1">
+            <a:schemeClr val="accent1"/>
+          </a:lnRef>
+          <a:fillRef idx="3">
+            <a:schemeClr val="accent1"/>
+          </a:fillRef>
+          <a:effectRef idx="2">
+            <a:schemeClr val="accent1"/>
+          </a:effectRef>
+          <a:fontRef idx="minor">
+            <a:schemeClr val="lt1"/>
+          </a:fontRef>
+        </p:style>
+        <p:txBody>
+          <a:bodyPr rtlCol="0" anchor="ctr"/>
+          <a:lstStyle/>
+          <a:p>
+            <a:pPr algn="ctr"/>
+          </a:p>
+        </p:txBody>
+      </p:sp>
+      <p:sp>
+        <p:nvSpPr>
+          <p:cNvPr id="6" name="Oval 5"/>
+          <p:cNvSpPr/>
+          <p:nvPr/>
+        </p:nvSpPr>
+        <p:spPr>
+          <a:xfrm>
+            <a:off x="17335500" y="1523999"/>
+            <a:ext cx="133350" cy="133350"/>
+          </a:xfrm>
+          <a:prstGeom prst="ellipse">
+            <a:avLst/>
+          </a:prstGeom>
+          <a:solidFill>
+            <a:srgbClr val="FFFFFF">
+              <a:alpha val="40000"/>
+            </a:srgbClr>
+          </a:solidFill>
+          <a:ln>
+            <a:noFill/>
+          </a:ln>
+        </p:spPr>
+        <p:style>
+          <a:lnRef idx="1">
+            <a:schemeClr val="accent1"/>
+          </a:lnRef>
+          <a:fillRef idx="3">
+            <a:schemeClr val="accent1"/>
+          </a:fillRef>
+          <a:effectRef idx="2">
+            <a:schemeClr val="accent1"/>
+          </a:effectRef>
+          <a:fontRef idx="minor">
+            <a:schemeClr val="lt1"/>
+          </a:fontRef>
+        </p:style>
+        <p:txBody>
+          <a:bodyPr rtlCol="0" anchor="ctr"/>
+          <a:lstStyle/>
+          <a:p>
+            <a:pPr algn="ctr"/>
+          </a:p>
+        </p:txBody>
+      </p:sp>
+      <p:sp>
+        <p:nvSpPr>
+          <p:cNvPr id="7" name="Oval 6"/>
+          <p:cNvSpPr/>
+          <p:nvPr/>
+        </p:nvSpPr>
+        <p:spPr>
+          <a:xfrm>
+            <a:off x="17716500" y="1523999"/>
+            <a:ext cx="133350" cy="133350"/>
+          </a:xfrm>
+          <a:prstGeom prst="ellipse">
+            <a:avLst/>
+          </a:prstGeom>
+          <a:solidFill>
+            <a:srgbClr val="FFFFFF">
+              <a:alpha val="20000"/>
+            </a:srgbClr>
+          </a:solidFill>
+          <a:ln>
+            <a:noFill/>
+          </a:ln>
+        </p:spPr>
+        <p:style>
+          <a:lnRef idx="1">
+            <a:schemeClr val="accent1"/>
+          </a:lnRef>
+          <a:fillRef idx="3">
+            <a:schemeClr val="accent1"/>
+          </a:fillRef>
+          <a:effectRef idx="2">
+            <a:schemeClr val="accent1"/>
+          </a:effectRef>
+          <a:fontRef idx="minor">
+            <a:schemeClr val="lt1"/>
+          </a:fontRef>
+        </p:style>
+        <p:txBody>
+          <a:bodyPr rtlCol="0" anchor="ctr"/>
+          <a:lstStyle/>
+          <a:p>
+            <a:pPr algn="ctr"/>
+          </a:p>
+        </p:txBody>
+      </p:sp>
+      <p:sp>
+        <p:nvSpPr>
+          <p:cNvPr id="8" name="TextBox 7"/>
+          <p:cNvSpPr txBox="1"/>
+          <p:nvPr/>
+        </p:nvSpPr>
+        <p:spPr>
+          <a:xfrm>
+            <a:off x="5433060" y="2049780"/>
+            <a:ext cx="9953625" cy="5762625"/>
+          </a:xfrm>
+          <a:prstGeom prst="rect">
+            <a:avLst/>
+          </a:prstGeom>
+          <a:noFill/>
+        </p:spPr>
+        <p:txBody>
+          <a:bodyPr wrap="none"/>
+          <a:lstStyle/>
+          <a:p>
+            <a:pPr algn="l">
+              <a:spcBef>
+                <a:spcPts val="0"/>
+              </a:spcBef>
+              <a:spcAft>
+                <a:spcPts val="0"/>
+              </a:spcAft>
+            </a:pPr>
+            <a:r>
+              <a:rPr sz="37500" b="1">
+                <a:solidFill>
+                  <a:srgbClr val="FFFFFF">
+                    <a:alpha val="5000"/>
+                  </a:srgbClr>
+                </a:solidFill>
+                <a:latin typeface="Inter Black"/>
+              </a:rPr>
+              <a:t>ASO</a:t>
+            </a:r>
+          </a:p>
+        </p:txBody>
+      </p:sp>
+      <p:sp>
+        <p:nvSpPr>
+          <p:cNvPr id="9" name="Rectangle 8"/>
+          <p:cNvSpPr/>
+          <p:nvPr/>
+        </p:nvSpPr>
+        <p:spPr>
+          <a:xfrm>
+            <a:off x="1143000" y="1143000"/>
+            <a:ext cx="133350" cy="133350"/>
+          </a:xfrm>
+          <a:prstGeom prst="rect">
+            <a:avLst/>
+          </a:prstGeom>
+          <a:solidFill>
+            <a:srgbClr val="FFFFFF"/>
+          </a:solidFill>
+          <a:ln>
+            <a:noFill/>
+          </a:ln>
+        </p:spPr>
+        <p:style>
+          <a:lnRef idx="1">
+            <a:schemeClr val="accent1"/>
+          </a:lnRef>
+          <a:fillRef idx="3">
+            <a:schemeClr val="accent1"/>
+          </a:fillRef>
+          <a:effectRef idx="2">
+            <a:schemeClr val="accent1"/>
+          </a:effectRef>
+          <a:fontRef idx="minor">
+            <a:schemeClr val="lt1"/>
+          </a:fontRef>
+        </p:style>
+        <p:txBody>
+          <a:bodyPr rtlCol="0" anchor="ctr"/>
+          <a:lstStyle/>
+          <a:p>
+            <a:pPr algn="ctr"/>
+          </a:p>
+        </p:txBody>
+      </p:sp>
+      <p:sp>
+        <p:nvSpPr>
+          <p:cNvPr id="10" name="TextBox 9"/>
+          <p:cNvSpPr txBox="1"/>
+          <p:nvPr/>
+        </p:nvSpPr>
+        <p:spPr>
+          <a:xfrm>
+            <a:off x="1337310" y="1049655"/>
+            <a:ext cx="3810000" cy="228600"/>
+          </a:xfrm>
+          <a:prstGeom prst="rect">
+            <a:avLst/>
+          </a:prstGeom>
+          <a:noFill/>
+        </p:spPr>
+        <p:txBody>
+          <a:bodyPr wrap="none"/>
+          <a:lstStyle/>
+          <a:p>
+            <a:pPr algn="l">
+              <a:spcBef>
+                <a:spcPts val="0"/>
+              </a:spcBef>
+              <a:spcAft>
+                <a:spcPts val="0"/>
+              </a:spcAft>
+            </a:pPr>
+            <a:r>
+              <a:rPr sz="1500" b="0" spc="300">
+                <a:solidFill>
+                  <a:srgbClr val="FFFFFF"/>
+                </a:solidFill>
+                <a:latin typeface="Inter SemiBold"/>
+              </a:rPr>
+              <a:t>06 / ASO</a:t>
+            </a:r>
+          </a:p>
+        </p:txBody>
+      </p:sp>
+      <p:sp>
+        <p:nvSpPr>
+          <p:cNvPr id="11" name="TextBox 10"/>
+          <p:cNvSpPr txBox="1"/>
+          <p:nvPr/>
+        </p:nvSpPr>
+        <p:spPr>
+          <a:xfrm>
+            <a:off x="1051560" y="6812280"/>
+            <a:ext cx="16002000" cy="1676400"/>
+          </a:xfrm>
+          <a:prstGeom prst="rect">
+            <a:avLst/>
+          </a:prstGeom>
+          <a:noFill/>
+        </p:spPr>
+        <p:txBody>
+          <a:bodyPr wrap="none"/>
+          <a:lstStyle/>
+          <a:p>
+            <a:pPr algn="l">
+              <a:spcBef>
+                <a:spcPts val="0"/>
+              </a:spcBef>
+              <a:spcAft>
+                <a:spcPts val="0"/>
+              </a:spcAft>
+            </a:pPr>
+            <a:r>
+              <a:rPr sz="15000" b="1">
+                <a:solidFill>
+                  <a:srgbClr val="FFFFFF"/>
+                </a:solidFill>
+                <a:latin typeface="Inter Black"/>
+              </a:rPr>
+              <a:t>ASO.</a:t>
+            </a:r>
+          </a:p>
+        </p:txBody>
+      </p:sp>
+      <p:sp>
+        <p:nvSpPr>
+          <p:cNvPr id="12" name="TextBox 11"/>
+          <p:cNvSpPr txBox="1"/>
+          <p:nvPr/>
+        </p:nvSpPr>
+        <p:spPr>
+          <a:xfrm>
+            <a:off x="1051560" y="8564880"/>
+            <a:ext cx="16002000" cy="723900"/>
+          </a:xfrm>
+          <a:prstGeom prst="rect">
+            <a:avLst/>
+          </a:prstGeom>
+          <a:noFill/>
+        </p:spPr>
+        <p:txBody>
+          <a:bodyPr wrap="none"/>
+          <a:lstStyle/>
+          <a:p>
+            <a:pPr algn="l">
+              <a:spcBef>
+                <a:spcPts val="0"/>
+              </a:spcBef>
+              <a:spcAft>
+                <a:spcPts val="0"/>
+              </a:spcAft>
+            </a:pPr>
+            <a:r>
+              <a:rPr sz="6300" b="1">
+                <a:solidFill>
+                  <a:srgbClr val="666666"/>
+                </a:solidFill>
+                <a:latin typeface="Inter Black"/>
+              </a:rPr>
+              <a:t>YOUR AZURE. YAML-DRIVEN.</a:t>
+            </a:r>
+          </a:p>
+        </p:txBody>
+      </p:sp>
+    </p:spTree>
+  </p:cSld>
+  <p:clrMapOvr>
+    <a:masterClrMapping/>
+  </p:clrMapOvr>
+</p:sld>
+</file>
+
 <file path=ppt/slides/slide3.xml><?xml version="1.0" encoding="utf-8"?>
 <p:sld xmlns:a="http://schemas.openxmlformats.org/drawingml/2006/main" xmlns:p="http://schemas.openxmlformats.org/presentationml/2006/main" xmlns:r="http://schemas.openxmlformats.org/officeDocument/2006/relationships">
   <p:cSld>
@@ -22629,6 +23119,3810 @@
                 <a:latin typeface="Inter ExtraBold"/>
               </a:rPr>
               <a:t>PIPELINE.</a:t>
+            </a:r>
+          </a:p>
+        </p:txBody>
+      </p:sp>
+    </p:spTree>
+  </p:cSld>
+  <p:clrMapOvr>
+    <a:masterClrMapping/>
+  </p:clrMapOvr>
+</p:sld>
+</file>
+
+<file path=ppt/slides/slide30.xml><?xml version="1.0" encoding="utf-8"?>
+<p:sld xmlns:a="http://schemas.openxmlformats.org/drawingml/2006/main" xmlns:p="http://schemas.openxmlformats.org/presentationml/2006/main" xmlns:r="http://schemas.openxmlformats.org/officeDocument/2006/relationships">
+  <p:cSld>
+    <p:spTree>
+      <p:nvGrpSpPr>
+        <p:cNvPr id="1" name=""/>
+        <p:cNvGrpSpPr/>
+        <p:nvPr/>
+      </p:nvGrpSpPr>
+      <p:grpSpPr/>
+      <p:sp>
+        <p:nvSpPr>
+          <p:cNvPr id="2" name="Rectangle 1"/>
+          <p:cNvSpPr/>
+          <p:nvPr/>
+        </p:nvSpPr>
+        <p:spPr>
+          <a:xfrm>
+            <a:off x="0" y="0"/>
+            <a:ext cx="18288000" cy="10287000"/>
+          </a:xfrm>
+          <a:prstGeom prst="rect">
+            <a:avLst/>
+          </a:prstGeom>
+          <a:solidFill>
+            <a:srgbClr val="000000"/>
+          </a:solidFill>
+          <a:ln>
+            <a:noFill/>
+          </a:ln>
+        </p:spPr>
+        <p:style>
+          <a:lnRef idx="1">
+            <a:schemeClr val="accent1"/>
+          </a:lnRef>
+          <a:fillRef idx="3">
+            <a:schemeClr val="accent1"/>
+          </a:fillRef>
+          <a:effectRef idx="2">
+            <a:schemeClr val="accent1"/>
+          </a:effectRef>
+          <a:fontRef idx="minor">
+            <a:schemeClr val="lt1"/>
+          </a:fontRef>
+        </p:style>
+        <p:txBody>
+          <a:bodyPr rtlCol="0" anchor="ctr"/>
+          <a:lstStyle/>
+          <a:p>
+            <a:pPr algn="ctr"/>
+          </a:p>
+        </p:txBody>
+      </p:sp>
+      <p:sp>
+        <p:nvSpPr>
+          <p:cNvPr id="3" name="Rectangle 2"/>
+          <p:cNvSpPr/>
+          <p:nvPr/>
+        </p:nvSpPr>
+        <p:spPr>
+          <a:xfrm>
+            <a:off x="0" y="0"/>
+            <a:ext cx="76200" cy="10287000"/>
+          </a:xfrm>
+          <a:prstGeom prst="rect">
+            <a:avLst/>
+          </a:prstGeom>
+          <a:solidFill>
+            <a:srgbClr val="FFFFFF"/>
+          </a:solidFill>
+          <a:ln>
+            <a:noFill/>
+          </a:ln>
+        </p:spPr>
+        <p:style>
+          <a:lnRef idx="1">
+            <a:schemeClr val="accent1"/>
+          </a:lnRef>
+          <a:fillRef idx="3">
+            <a:schemeClr val="accent1"/>
+          </a:fillRef>
+          <a:effectRef idx="2">
+            <a:schemeClr val="accent1"/>
+          </a:effectRef>
+          <a:fontRef idx="minor">
+            <a:schemeClr val="lt1"/>
+          </a:fontRef>
+        </p:style>
+        <p:txBody>
+          <a:bodyPr rtlCol="0" anchor="ctr"/>
+          <a:lstStyle/>
+          <a:p>
+            <a:pPr algn="ctr"/>
+          </a:p>
+        </p:txBody>
+      </p:sp>
+      <p:sp>
+        <p:nvSpPr>
+          <p:cNvPr id="4" name="Rectangle 3"/>
+          <p:cNvSpPr/>
+          <p:nvPr/>
+        </p:nvSpPr>
+        <p:spPr>
+          <a:xfrm>
+            <a:off x="16383000" y="10096500"/>
+            <a:ext cx="1905000" cy="76200"/>
+          </a:xfrm>
+          <a:prstGeom prst="rect">
+            <a:avLst/>
+          </a:prstGeom>
+          <a:solidFill>
+            <a:srgbClr val="FFFFFF"/>
+          </a:solidFill>
+          <a:ln>
+            <a:noFill/>
+          </a:ln>
+        </p:spPr>
+        <p:style>
+          <a:lnRef idx="1">
+            <a:schemeClr val="accent1"/>
+          </a:lnRef>
+          <a:fillRef idx="3">
+            <a:schemeClr val="accent1"/>
+          </a:fillRef>
+          <a:effectRef idx="2">
+            <a:schemeClr val="accent1"/>
+          </a:effectRef>
+          <a:fontRef idx="minor">
+            <a:schemeClr val="lt1"/>
+          </a:fontRef>
+        </p:style>
+        <p:txBody>
+          <a:bodyPr rtlCol="0" anchor="ctr"/>
+          <a:lstStyle/>
+          <a:p>
+            <a:pPr algn="ctr"/>
+          </a:p>
+        </p:txBody>
+      </p:sp>
+      <p:sp>
+        <p:nvSpPr>
+          <p:cNvPr id="5" name="Rectangle 4"/>
+          <p:cNvSpPr/>
+          <p:nvPr/>
+        </p:nvSpPr>
+        <p:spPr>
+          <a:xfrm>
+            <a:off x="1143000" y="1143000"/>
+            <a:ext cx="133350" cy="133350"/>
+          </a:xfrm>
+          <a:prstGeom prst="rect">
+            <a:avLst/>
+          </a:prstGeom>
+          <a:solidFill>
+            <a:srgbClr val="FFFFFF"/>
+          </a:solidFill>
+          <a:ln>
+            <a:noFill/>
+          </a:ln>
+        </p:spPr>
+        <p:style>
+          <a:lnRef idx="1">
+            <a:schemeClr val="accent1"/>
+          </a:lnRef>
+          <a:fillRef idx="3">
+            <a:schemeClr val="accent1"/>
+          </a:fillRef>
+          <a:effectRef idx="2">
+            <a:schemeClr val="accent1"/>
+          </a:effectRef>
+          <a:fontRef idx="minor">
+            <a:schemeClr val="lt1"/>
+          </a:fontRef>
+        </p:style>
+        <p:txBody>
+          <a:bodyPr rtlCol="0" anchor="ctr"/>
+          <a:lstStyle/>
+          <a:p>
+            <a:pPr algn="ctr"/>
+          </a:p>
+        </p:txBody>
+      </p:sp>
+      <p:sp>
+        <p:nvSpPr>
+          <p:cNvPr id="6" name="TextBox 5"/>
+          <p:cNvSpPr txBox="1"/>
+          <p:nvPr/>
+        </p:nvSpPr>
+        <p:spPr>
+          <a:xfrm>
+            <a:off x="1337310" y="1049655"/>
+            <a:ext cx="3810000" cy="228600"/>
+          </a:xfrm>
+          <a:prstGeom prst="rect">
+            <a:avLst/>
+          </a:prstGeom>
+          <a:noFill/>
+        </p:spPr>
+        <p:txBody>
+          <a:bodyPr wrap="none"/>
+          <a:lstStyle/>
+          <a:p>
+            <a:pPr algn="l">
+              <a:spcBef>
+                <a:spcPts val="0"/>
+              </a:spcBef>
+              <a:spcAft>
+                <a:spcPts val="0"/>
+              </a:spcAft>
+            </a:pPr>
+            <a:r>
+              <a:rPr sz="1500" b="0" spc="300">
+                <a:solidFill>
+                  <a:srgbClr val="FFFFFF"/>
+                </a:solidFill>
+                <a:latin typeface="Inter SemiBold"/>
+              </a:rPr>
+              <a:t>06 / ASO</a:t>
+            </a:r>
+          </a:p>
+        </p:txBody>
+      </p:sp>
+      <p:sp>
+        <p:nvSpPr>
+          <p:cNvPr id="7" name="TextBox 6"/>
+          <p:cNvSpPr txBox="1"/>
+          <p:nvPr/>
+        </p:nvSpPr>
+        <p:spPr>
+          <a:xfrm>
+            <a:off x="1051560" y="3354704"/>
+            <a:ext cx="16002000" cy="619124"/>
+          </a:xfrm>
+          <a:prstGeom prst="rect">
+            <a:avLst/>
+          </a:prstGeom>
+          <a:noFill/>
+        </p:spPr>
+        <p:txBody>
+          <a:bodyPr wrap="none"/>
+          <a:lstStyle/>
+          <a:p>
+            <a:pPr algn="l">
+              <a:spcBef>
+                <a:spcPts val="0"/>
+              </a:spcBef>
+              <a:spcAft>
+                <a:spcPts val="0"/>
+              </a:spcAft>
+            </a:pPr>
+            <a:r>
+              <a:rPr sz="5400" b="1">
+                <a:solidFill>
+                  <a:srgbClr val="FFFFFF"/>
+                </a:solidFill>
+                <a:latin typeface="Inter Black"/>
+              </a:rPr>
+              <a:t>WHAT WE'RE BUILDING.</a:t>
+            </a:r>
+          </a:p>
+        </p:txBody>
+      </p:sp>
+      <p:sp>
+        <p:nvSpPr>
+          <p:cNvPr id="8" name="TextBox 7"/>
+          <p:cNvSpPr txBox="1"/>
+          <p:nvPr/>
+        </p:nvSpPr>
+        <p:spPr>
+          <a:xfrm>
+            <a:off x="1051560" y="3983354"/>
+            <a:ext cx="16002000" cy="228600"/>
+          </a:xfrm>
+          <a:prstGeom prst="rect">
+            <a:avLst/>
+          </a:prstGeom>
+          <a:noFill/>
+        </p:spPr>
+        <p:txBody>
+          <a:bodyPr wrap="none"/>
+          <a:lstStyle/>
+          <a:p>
+            <a:pPr algn="l">
+              <a:spcBef>
+                <a:spcPts val="0"/>
+              </a:spcBef>
+              <a:spcAft>
+                <a:spcPts val="0"/>
+              </a:spcAft>
+            </a:pPr>
+            <a:r>
+              <a:rPr sz="1200" b="0" spc="150">
+                <a:solidFill>
+                  <a:srgbClr val="555555"/>
+                </a:solidFill>
+                <a:latin typeface="Inter SemiBold"/>
+              </a:rPr>
+              <a:t>GIT COMMIT  →  ARGO CD  →  ASO CONTROLLER  →  AZURE RESOURCE</a:t>
+            </a:r>
+          </a:p>
+        </p:txBody>
+      </p:sp>
+      <p:sp>
+        <p:nvSpPr>
+          <p:cNvPr id="9" name="Rectangle 8"/>
+          <p:cNvSpPr/>
+          <p:nvPr/>
+        </p:nvSpPr>
+        <p:spPr>
+          <a:xfrm>
+            <a:off x="1143000" y="6477000"/>
+            <a:ext cx="3524250" cy="2857500"/>
+          </a:xfrm>
+          <a:prstGeom prst="rect">
+            <a:avLst/>
+          </a:prstGeom>
+          <a:solidFill>
+            <a:srgbClr val="111111"/>
+          </a:solidFill>
+          <a:ln>
+            <a:noFill/>
+          </a:ln>
+        </p:spPr>
+        <p:style>
+          <a:lnRef idx="1">
+            <a:schemeClr val="accent1"/>
+          </a:lnRef>
+          <a:fillRef idx="3">
+            <a:schemeClr val="accent1"/>
+          </a:fillRef>
+          <a:effectRef idx="2">
+            <a:schemeClr val="accent1"/>
+          </a:effectRef>
+          <a:fontRef idx="minor">
+            <a:schemeClr val="lt1"/>
+          </a:fontRef>
+        </p:style>
+        <p:txBody>
+          <a:bodyPr rtlCol="0" anchor="ctr"/>
+          <a:lstStyle/>
+          <a:p>
+            <a:pPr algn="ctr"/>
+          </a:p>
+        </p:txBody>
+      </p:sp>
+      <p:sp>
+        <p:nvSpPr>
+          <p:cNvPr id="10" name="Rectangle 9"/>
+          <p:cNvSpPr/>
+          <p:nvPr/>
+        </p:nvSpPr>
+        <p:spPr>
+          <a:xfrm>
+            <a:off x="1143000" y="6477000"/>
+            <a:ext cx="3524250" cy="47624"/>
+          </a:xfrm>
+          <a:prstGeom prst="rect">
+            <a:avLst/>
+          </a:prstGeom>
+          <a:solidFill>
+            <a:srgbClr val="555555"/>
+          </a:solidFill>
+          <a:ln>
+            <a:noFill/>
+          </a:ln>
+        </p:spPr>
+        <p:style>
+          <a:lnRef idx="1">
+            <a:schemeClr val="accent1"/>
+          </a:lnRef>
+          <a:fillRef idx="3">
+            <a:schemeClr val="accent1"/>
+          </a:fillRef>
+          <a:effectRef idx="2">
+            <a:schemeClr val="accent1"/>
+          </a:effectRef>
+          <a:fontRef idx="minor">
+            <a:schemeClr val="lt1"/>
+          </a:fontRef>
+        </p:style>
+        <p:txBody>
+          <a:bodyPr rtlCol="0" anchor="ctr"/>
+          <a:lstStyle/>
+          <a:p>
+            <a:pPr algn="ctr"/>
+          </a:p>
+        </p:txBody>
+      </p:sp>
+      <p:sp>
+        <p:nvSpPr>
+          <p:cNvPr id="11" name="TextBox 10"/>
+          <p:cNvSpPr txBox="1"/>
+          <p:nvPr/>
+        </p:nvSpPr>
+        <p:spPr>
+          <a:xfrm>
+            <a:off x="1242060" y="6621780"/>
+            <a:ext cx="3143250" cy="152400"/>
+          </a:xfrm>
+          <a:prstGeom prst="rect">
+            <a:avLst/>
+          </a:prstGeom>
+          <a:noFill/>
+        </p:spPr>
+        <p:txBody>
+          <a:bodyPr wrap="none"/>
+          <a:lstStyle/>
+          <a:p>
+            <a:pPr algn="l">
+              <a:spcBef>
+                <a:spcPts val="0"/>
+              </a:spcBef>
+              <a:spcAft>
+                <a:spcPts val="0"/>
+              </a:spcAft>
+            </a:pPr>
+            <a:r>
+              <a:rPr sz="825" b="1" spc="225">
+                <a:solidFill>
+                  <a:srgbClr val="888888"/>
+                </a:solidFill>
+                <a:latin typeface="Inter Bold"/>
+              </a:rPr>
+              <a:t>GIT REPO</a:t>
+            </a:r>
+          </a:p>
+        </p:txBody>
+      </p:sp>
+      <p:sp>
+        <p:nvSpPr>
+          <p:cNvPr id="12" name="TextBox 11"/>
+          <p:cNvSpPr txBox="1"/>
+          <p:nvPr/>
+        </p:nvSpPr>
+        <p:spPr>
+          <a:xfrm>
+            <a:off x="1242060" y="6850380"/>
+            <a:ext cx="3143250" cy="266700"/>
+          </a:xfrm>
+          <a:prstGeom prst="rect">
+            <a:avLst/>
+          </a:prstGeom>
+          <a:noFill/>
+        </p:spPr>
+        <p:txBody>
+          <a:bodyPr wrap="none"/>
+          <a:lstStyle/>
+          <a:p>
+            <a:pPr algn="l">
+              <a:spcBef>
+                <a:spcPts val="0"/>
+              </a:spcBef>
+              <a:spcAft>
+                <a:spcPts val="0"/>
+              </a:spcAft>
+            </a:pPr>
+            <a:r>
+              <a:rPr sz="1500" b="1">
+                <a:solidFill>
+                  <a:srgbClr val="FFFFFF"/>
+                </a:solidFill>
+                <a:latin typeface="Inter ExtraBold"/>
+              </a:rPr>
+              <a:t>storageaccount.yaml</a:t>
+            </a:r>
+          </a:p>
+        </p:txBody>
+      </p:sp>
+      <p:sp>
+        <p:nvSpPr>
+          <p:cNvPr id="13" name="TextBox 12"/>
+          <p:cNvSpPr txBox="1"/>
+          <p:nvPr/>
+        </p:nvSpPr>
+        <p:spPr>
+          <a:xfrm>
+            <a:off x="1242060" y="7231380"/>
+            <a:ext cx="3143250" cy="1904999"/>
+          </a:xfrm>
+          <a:prstGeom prst="rect">
+            <a:avLst/>
+          </a:prstGeom>
+          <a:noFill/>
+        </p:spPr>
+        <p:txBody>
+          <a:bodyPr wrap="square"/>
+          <a:lstStyle/>
+          <a:p>
+            <a:pPr algn="l">
+              <a:spcBef>
+                <a:spcPts val="0"/>
+              </a:spcBef>
+              <a:spcAft>
+                <a:spcPts val="0"/>
+              </a:spcAft>
+            </a:pPr>
+            <a:r>
+              <a:rPr sz="975" b="0">
+                <a:solidFill>
+                  <a:srgbClr val="555555"/>
+                </a:solidFill>
+                <a:latin typeface="Inter"/>
+              </a:rPr>
+              <a:t>Developer commits a Kubernetes manifest to the main branch</a:t>
+            </a:r>
+          </a:p>
+        </p:txBody>
+      </p:sp>
+      <p:sp>
+        <p:nvSpPr>
+          <p:cNvPr id="14" name="Rectangle 13"/>
+          <p:cNvSpPr/>
+          <p:nvPr/>
+        </p:nvSpPr>
+        <p:spPr>
+          <a:xfrm>
+            <a:off x="5305425" y="6477000"/>
+            <a:ext cx="3524250" cy="2857500"/>
+          </a:xfrm>
+          <a:prstGeom prst="rect">
+            <a:avLst/>
+          </a:prstGeom>
+          <a:solidFill>
+            <a:srgbClr val="111111"/>
+          </a:solidFill>
+          <a:ln>
+            <a:noFill/>
+          </a:ln>
+        </p:spPr>
+        <p:style>
+          <a:lnRef idx="1">
+            <a:schemeClr val="accent1"/>
+          </a:lnRef>
+          <a:fillRef idx="3">
+            <a:schemeClr val="accent1"/>
+          </a:fillRef>
+          <a:effectRef idx="2">
+            <a:schemeClr val="accent1"/>
+          </a:effectRef>
+          <a:fontRef idx="minor">
+            <a:schemeClr val="lt1"/>
+          </a:fontRef>
+        </p:style>
+        <p:txBody>
+          <a:bodyPr rtlCol="0" anchor="ctr"/>
+          <a:lstStyle/>
+          <a:p>
+            <a:pPr algn="ctr"/>
+          </a:p>
+        </p:txBody>
+      </p:sp>
+      <p:sp>
+        <p:nvSpPr>
+          <p:cNvPr id="15" name="Rectangle 14"/>
+          <p:cNvSpPr/>
+          <p:nvPr/>
+        </p:nvSpPr>
+        <p:spPr>
+          <a:xfrm>
+            <a:off x="5305425" y="6477000"/>
+            <a:ext cx="3524250" cy="47624"/>
+          </a:xfrm>
+          <a:prstGeom prst="rect">
+            <a:avLst/>
+          </a:prstGeom>
+          <a:solidFill>
+            <a:srgbClr val="EF7B4D"/>
+          </a:solidFill>
+          <a:ln>
+            <a:noFill/>
+          </a:ln>
+        </p:spPr>
+        <p:style>
+          <a:lnRef idx="1">
+            <a:schemeClr val="accent1"/>
+          </a:lnRef>
+          <a:fillRef idx="3">
+            <a:schemeClr val="accent1"/>
+          </a:fillRef>
+          <a:effectRef idx="2">
+            <a:schemeClr val="accent1"/>
+          </a:effectRef>
+          <a:fontRef idx="minor">
+            <a:schemeClr val="lt1"/>
+          </a:fontRef>
+        </p:style>
+        <p:txBody>
+          <a:bodyPr rtlCol="0" anchor="ctr"/>
+          <a:lstStyle/>
+          <a:p>
+            <a:pPr algn="ctr"/>
+          </a:p>
+        </p:txBody>
+      </p:sp>
+      <p:sp>
+        <p:nvSpPr>
+          <p:cNvPr id="16" name="TextBox 15"/>
+          <p:cNvSpPr txBox="1"/>
+          <p:nvPr/>
+        </p:nvSpPr>
+        <p:spPr>
+          <a:xfrm>
+            <a:off x="5404485" y="6621780"/>
+            <a:ext cx="3143250" cy="152400"/>
+          </a:xfrm>
+          <a:prstGeom prst="rect">
+            <a:avLst/>
+          </a:prstGeom>
+          <a:noFill/>
+        </p:spPr>
+        <p:txBody>
+          <a:bodyPr wrap="none"/>
+          <a:lstStyle/>
+          <a:p>
+            <a:pPr algn="l">
+              <a:spcBef>
+                <a:spcPts val="0"/>
+              </a:spcBef>
+              <a:spcAft>
+                <a:spcPts val="0"/>
+              </a:spcAft>
+            </a:pPr>
+            <a:r>
+              <a:rPr sz="825" b="1" spc="225">
+                <a:solidFill>
+                  <a:srgbClr val="EF7B4D"/>
+                </a:solidFill>
+                <a:latin typeface="Inter Bold"/>
+              </a:rPr>
+              <a:t>ARGO CD</a:t>
+            </a:r>
+          </a:p>
+        </p:txBody>
+      </p:sp>
+      <p:sp>
+        <p:nvSpPr>
+          <p:cNvPr id="17" name="TextBox 16"/>
+          <p:cNvSpPr txBox="1"/>
+          <p:nvPr/>
+        </p:nvSpPr>
+        <p:spPr>
+          <a:xfrm>
+            <a:off x="5404485" y="6850380"/>
+            <a:ext cx="3143250" cy="266700"/>
+          </a:xfrm>
+          <a:prstGeom prst="rect">
+            <a:avLst/>
+          </a:prstGeom>
+          <a:noFill/>
+        </p:spPr>
+        <p:txBody>
+          <a:bodyPr wrap="none"/>
+          <a:lstStyle/>
+          <a:p>
+            <a:pPr algn="l">
+              <a:spcBef>
+                <a:spcPts val="0"/>
+              </a:spcBef>
+              <a:spcAft>
+                <a:spcPts val="0"/>
+              </a:spcAft>
+            </a:pPr>
+            <a:r>
+              <a:rPr sz="1500" b="1">
+                <a:solidFill>
+                  <a:srgbClr val="FFFFFF"/>
+                </a:solidFill>
+                <a:latin typeface="Inter ExtraBold"/>
+              </a:rPr>
+              <a:t>Detects &amp; deploys</a:t>
+            </a:r>
+          </a:p>
+        </p:txBody>
+      </p:sp>
+      <p:sp>
+        <p:nvSpPr>
+          <p:cNvPr id="18" name="TextBox 17"/>
+          <p:cNvSpPr txBox="1"/>
+          <p:nvPr/>
+        </p:nvSpPr>
+        <p:spPr>
+          <a:xfrm>
+            <a:off x="5404485" y="7231380"/>
+            <a:ext cx="3143250" cy="1904999"/>
+          </a:xfrm>
+          <a:prstGeom prst="rect">
+            <a:avLst/>
+          </a:prstGeom>
+          <a:noFill/>
+        </p:spPr>
+        <p:txBody>
+          <a:bodyPr wrap="square"/>
+          <a:lstStyle/>
+          <a:p>
+            <a:pPr algn="l">
+              <a:spcBef>
+                <a:spcPts val="0"/>
+              </a:spcBef>
+              <a:spcAft>
+                <a:spcPts val="0"/>
+              </a:spcAft>
+            </a:pPr>
+            <a:r>
+              <a:rPr sz="975" b="0">
+                <a:solidFill>
+                  <a:srgbClr val="555555"/>
+                </a:solidFill>
+                <a:latin typeface="Inter"/>
+              </a:rPr>
+              <a:t>Watches the Git repo and applies the manifest to the cluster on every push</a:t>
+            </a:r>
+          </a:p>
+        </p:txBody>
+      </p:sp>
+      <p:sp>
+        <p:nvSpPr>
+          <p:cNvPr id="19" name="Rectangle 18"/>
+          <p:cNvSpPr/>
+          <p:nvPr/>
+        </p:nvSpPr>
+        <p:spPr>
+          <a:xfrm>
+            <a:off x="9467850" y="6477000"/>
+            <a:ext cx="3524250" cy="2857500"/>
+          </a:xfrm>
+          <a:prstGeom prst="rect">
+            <a:avLst/>
+          </a:prstGeom>
+          <a:solidFill>
+            <a:srgbClr val="111111"/>
+          </a:solidFill>
+          <a:ln>
+            <a:noFill/>
+          </a:ln>
+        </p:spPr>
+        <p:style>
+          <a:lnRef idx="1">
+            <a:schemeClr val="accent1"/>
+          </a:lnRef>
+          <a:fillRef idx="3">
+            <a:schemeClr val="accent1"/>
+          </a:fillRef>
+          <a:effectRef idx="2">
+            <a:schemeClr val="accent1"/>
+          </a:effectRef>
+          <a:fontRef idx="minor">
+            <a:schemeClr val="lt1"/>
+          </a:fontRef>
+        </p:style>
+        <p:txBody>
+          <a:bodyPr rtlCol="0" anchor="ctr"/>
+          <a:lstStyle/>
+          <a:p>
+            <a:pPr algn="ctr"/>
+          </a:p>
+        </p:txBody>
+      </p:sp>
+      <p:sp>
+        <p:nvSpPr>
+          <p:cNvPr id="20" name="Rectangle 19"/>
+          <p:cNvSpPr/>
+          <p:nvPr/>
+        </p:nvSpPr>
+        <p:spPr>
+          <a:xfrm>
+            <a:off x="9467850" y="6477000"/>
+            <a:ext cx="3524250" cy="47624"/>
+          </a:xfrm>
+          <a:prstGeom prst="rect">
+            <a:avLst/>
+          </a:prstGeom>
+          <a:solidFill>
+            <a:srgbClr val="0078D4"/>
+          </a:solidFill>
+          <a:ln>
+            <a:noFill/>
+          </a:ln>
+        </p:spPr>
+        <p:style>
+          <a:lnRef idx="1">
+            <a:schemeClr val="accent1"/>
+          </a:lnRef>
+          <a:fillRef idx="3">
+            <a:schemeClr val="accent1"/>
+          </a:fillRef>
+          <a:effectRef idx="2">
+            <a:schemeClr val="accent1"/>
+          </a:effectRef>
+          <a:fontRef idx="minor">
+            <a:schemeClr val="lt1"/>
+          </a:fontRef>
+        </p:style>
+        <p:txBody>
+          <a:bodyPr rtlCol="0" anchor="ctr"/>
+          <a:lstStyle/>
+          <a:p>
+            <a:pPr algn="ctr"/>
+          </a:p>
+        </p:txBody>
+      </p:sp>
+      <p:sp>
+        <p:nvSpPr>
+          <p:cNvPr id="21" name="TextBox 20"/>
+          <p:cNvSpPr txBox="1"/>
+          <p:nvPr/>
+        </p:nvSpPr>
+        <p:spPr>
+          <a:xfrm>
+            <a:off x="9566909" y="6621780"/>
+            <a:ext cx="3143250" cy="152400"/>
+          </a:xfrm>
+          <a:prstGeom prst="rect">
+            <a:avLst/>
+          </a:prstGeom>
+          <a:noFill/>
+        </p:spPr>
+        <p:txBody>
+          <a:bodyPr wrap="none"/>
+          <a:lstStyle/>
+          <a:p>
+            <a:pPr algn="l">
+              <a:spcBef>
+                <a:spcPts val="0"/>
+              </a:spcBef>
+              <a:spcAft>
+                <a:spcPts val="0"/>
+              </a:spcAft>
+            </a:pPr>
+            <a:r>
+              <a:rPr sz="825" b="1" spc="225">
+                <a:solidFill>
+                  <a:srgbClr val="0078D4"/>
+                </a:solidFill>
+                <a:latin typeface="Inter Bold"/>
+              </a:rPr>
+              <a:t>ASO CONTROLLER</a:t>
+            </a:r>
+          </a:p>
+        </p:txBody>
+      </p:sp>
+      <p:sp>
+        <p:nvSpPr>
+          <p:cNvPr id="22" name="TextBox 21"/>
+          <p:cNvSpPr txBox="1"/>
+          <p:nvPr/>
+        </p:nvSpPr>
+        <p:spPr>
+          <a:xfrm>
+            <a:off x="9566909" y="6850380"/>
+            <a:ext cx="3143250" cy="266700"/>
+          </a:xfrm>
+          <a:prstGeom prst="rect">
+            <a:avLst/>
+          </a:prstGeom>
+          <a:noFill/>
+        </p:spPr>
+        <p:txBody>
+          <a:bodyPr wrap="none"/>
+          <a:lstStyle/>
+          <a:p>
+            <a:pPr algn="l">
+              <a:spcBef>
+                <a:spcPts val="0"/>
+              </a:spcBef>
+              <a:spcAft>
+                <a:spcPts val="0"/>
+              </a:spcAft>
+            </a:pPr>
+            <a:r>
+              <a:rPr sz="1500" b="1">
+                <a:solidFill>
+                  <a:srgbClr val="FFFFFF"/>
+                </a:solidFill>
+                <a:latin typeface="Inter ExtraBold"/>
+              </a:rPr>
+              <a:t>Reads CRD, calls API</a:t>
+            </a:r>
+          </a:p>
+        </p:txBody>
+      </p:sp>
+      <p:sp>
+        <p:nvSpPr>
+          <p:cNvPr id="23" name="TextBox 22"/>
+          <p:cNvSpPr txBox="1"/>
+          <p:nvPr/>
+        </p:nvSpPr>
+        <p:spPr>
+          <a:xfrm>
+            <a:off x="9566909" y="7231380"/>
+            <a:ext cx="3143250" cy="1904999"/>
+          </a:xfrm>
+          <a:prstGeom prst="rect">
+            <a:avLst/>
+          </a:prstGeom>
+          <a:noFill/>
+        </p:spPr>
+        <p:txBody>
+          <a:bodyPr wrap="square"/>
+          <a:lstStyle/>
+          <a:p>
+            <a:pPr algn="l">
+              <a:spcBef>
+                <a:spcPts val="0"/>
+              </a:spcBef>
+              <a:spcAft>
+                <a:spcPts val="0"/>
+              </a:spcAft>
+            </a:pPr>
+            <a:r>
+              <a:rPr sz="975" b="0">
+                <a:solidFill>
+                  <a:srgbClr val="555555"/>
+                </a:solidFill>
+                <a:latin typeface="Inter"/>
+              </a:rPr>
+              <a:t>Azure Service Operator reconciles the StorageAccount CRD via Azure ARM API</a:t>
+            </a:r>
+          </a:p>
+        </p:txBody>
+      </p:sp>
+      <p:sp>
+        <p:nvSpPr>
+          <p:cNvPr id="24" name="Rectangle 23"/>
+          <p:cNvSpPr/>
+          <p:nvPr/>
+        </p:nvSpPr>
+        <p:spPr>
+          <a:xfrm>
+            <a:off x="13630275" y="6477000"/>
+            <a:ext cx="3524250" cy="2857500"/>
+          </a:xfrm>
+          <a:prstGeom prst="rect">
+            <a:avLst/>
+          </a:prstGeom>
+          <a:solidFill>
+            <a:srgbClr val="111111"/>
+          </a:solidFill>
+          <a:ln>
+            <a:noFill/>
+          </a:ln>
+        </p:spPr>
+        <p:style>
+          <a:lnRef idx="1">
+            <a:schemeClr val="accent1"/>
+          </a:lnRef>
+          <a:fillRef idx="3">
+            <a:schemeClr val="accent1"/>
+          </a:fillRef>
+          <a:effectRef idx="2">
+            <a:schemeClr val="accent1"/>
+          </a:effectRef>
+          <a:fontRef idx="minor">
+            <a:schemeClr val="lt1"/>
+          </a:fontRef>
+        </p:style>
+        <p:txBody>
+          <a:bodyPr rtlCol="0" anchor="ctr"/>
+          <a:lstStyle/>
+          <a:p>
+            <a:pPr algn="ctr"/>
+          </a:p>
+        </p:txBody>
+      </p:sp>
+      <p:sp>
+        <p:nvSpPr>
+          <p:cNvPr id="25" name="Rectangle 24"/>
+          <p:cNvSpPr/>
+          <p:nvPr/>
+        </p:nvSpPr>
+        <p:spPr>
+          <a:xfrm>
+            <a:off x="13630275" y="6477000"/>
+            <a:ext cx="3524250" cy="47624"/>
+          </a:xfrm>
+          <a:prstGeom prst="rect">
+            <a:avLst/>
+          </a:prstGeom>
+          <a:solidFill>
+            <a:srgbClr val="10B981"/>
+          </a:solidFill>
+          <a:ln>
+            <a:noFill/>
+          </a:ln>
+        </p:spPr>
+        <p:style>
+          <a:lnRef idx="1">
+            <a:schemeClr val="accent1"/>
+          </a:lnRef>
+          <a:fillRef idx="3">
+            <a:schemeClr val="accent1"/>
+          </a:fillRef>
+          <a:effectRef idx="2">
+            <a:schemeClr val="accent1"/>
+          </a:effectRef>
+          <a:fontRef idx="minor">
+            <a:schemeClr val="lt1"/>
+          </a:fontRef>
+        </p:style>
+        <p:txBody>
+          <a:bodyPr rtlCol="0" anchor="ctr"/>
+          <a:lstStyle/>
+          <a:p>
+            <a:pPr algn="ctr"/>
+          </a:p>
+        </p:txBody>
+      </p:sp>
+      <p:sp>
+        <p:nvSpPr>
+          <p:cNvPr id="26" name="TextBox 25"/>
+          <p:cNvSpPr txBox="1"/>
+          <p:nvPr/>
+        </p:nvSpPr>
+        <p:spPr>
+          <a:xfrm>
+            <a:off x="13729335" y="6621780"/>
+            <a:ext cx="3143250" cy="152400"/>
+          </a:xfrm>
+          <a:prstGeom prst="rect">
+            <a:avLst/>
+          </a:prstGeom>
+          <a:noFill/>
+        </p:spPr>
+        <p:txBody>
+          <a:bodyPr wrap="none"/>
+          <a:lstStyle/>
+          <a:p>
+            <a:pPr algn="l">
+              <a:spcBef>
+                <a:spcPts val="0"/>
+              </a:spcBef>
+              <a:spcAft>
+                <a:spcPts val="0"/>
+              </a:spcAft>
+            </a:pPr>
+            <a:r>
+              <a:rPr sz="825" b="1" spc="225">
+                <a:solidFill>
+                  <a:srgbClr val="10B981"/>
+                </a:solidFill>
+                <a:latin typeface="Inter Bold"/>
+              </a:rPr>
+              <a:t>AZURE RESOURCE</a:t>
+            </a:r>
+          </a:p>
+        </p:txBody>
+      </p:sp>
+      <p:sp>
+        <p:nvSpPr>
+          <p:cNvPr id="27" name="TextBox 26"/>
+          <p:cNvSpPr txBox="1"/>
+          <p:nvPr/>
+        </p:nvSpPr>
+        <p:spPr>
+          <a:xfrm>
+            <a:off x="13729335" y="6850380"/>
+            <a:ext cx="3143250" cy="266700"/>
+          </a:xfrm>
+          <a:prstGeom prst="rect">
+            <a:avLst/>
+          </a:prstGeom>
+          <a:noFill/>
+        </p:spPr>
+        <p:txBody>
+          <a:bodyPr wrap="none"/>
+          <a:lstStyle/>
+          <a:p>
+            <a:pPr algn="l">
+              <a:spcBef>
+                <a:spcPts val="0"/>
+              </a:spcBef>
+              <a:spcAft>
+                <a:spcPts val="0"/>
+              </a:spcAft>
+            </a:pPr>
+            <a:r>
+              <a:rPr sz="1500" b="1">
+                <a:solidFill>
+                  <a:srgbClr val="FFFFFF"/>
+                </a:solidFill>
+                <a:latin typeface="Inter ExtraBold"/>
+              </a:rPr>
+              <a:t>Storage Account ready</a:t>
+            </a:r>
+          </a:p>
+        </p:txBody>
+      </p:sp>
+      <p:sp>
+        <p:nvSpPr>
+          <p:cNvPr id="28" name="TextBox 27"/>
+          <p:cNvSpPr txBox="1"/>
+          <p:nvPr/>
+        </p:nvSpPr>
+        <p:spPr>
+          <a:xfrm>
+            <a:off x="13729335" y="7231380"/>
+            <a:ext cx="3143250" cy="1904999"/>
+          </a:xfrm>
+          <a:prstGeom prst="rect">
+            <a:avLst/>
+          </a:prstGeom>
+          <a:noFill/>
+        </p:spPr>
+        <p:txBody>
+          <a:bodyPr wrap="square"/>
+          <a:lstStyle/>
+          <a:p>
+            <a:pPr algn="l">
+              <a:spcBef>
+                <a:spcPts val="0"/>
+              </a:spcBef>
+              <a:spcAft>
+                <a:spcPts val="0"/>
+              </a:spcAft>
+            </a:pPr>
+            <a:r>
+              <a:rPr sz="975" b="0">
+                <a:solidFill>
+                  <a:srgbClr val="555555"/>
+                </a:solidFill>
+                <a:latin typeface="Inter"/>
+              </a:rPr>
+              <a:t>Azure Storage Account is provisioned and managed through the GitOps loop</a:t>
+            </a:r>
+          </a:p>
+        </p:txBody>
+      </p:sp>
+      <p:sp>
+        <p:nvSpPr>
+          <p:cNvPr id="29" name="TextBox 28"/>
+          <p:cNvSpPr txBox="1"/>
+          <p:nvPr/>
+        </p:nvSpPr>
+        <p:spPr>
+          <a:xfrm>
+            <a:off x="4766310" y="7698105"/>
+            <a:ext cx="257175" cy="323849"/>
+          </a:xfrm>
+          <a:prstGeom prst="rect">
+            <a:avLst/>
+          </a:prstGeom>
+          <a:noFill/>
+        </p:spPr>
+        <p:txBody>
+          <a:bodyPr wrap="none"/>
+          <a:lstStyle/>
+          <a:p>
+            <a:pPr algn="l">
+              <a:spcBef>
+                <a:spcPts val="0"/>
+              </a:spcBef>
+              <a:spcAft>
+                <a:spcPts val="0"/>
+              </a:spcAft>
+            </a:pPr>
+            <a:r>
+              <a:rPr sz="2100" b="1">
+                <a:solidFill>
+                  <a:srgbClr val="333333"/>
+                </a:solidFill>
+                <a:latin typeface="Inter Bold"/>
+              </a:rPr>
+              <a:t>→</a:t>
+            </a:r>
+          </a:p>
+        </p:txBody>
+      </p:sp>
+      <p:sp>
+        <p:nvSpPr>
+          <p:cNvPr id="30" name="TextBox 29"/>
+          <p:cNvSpPr txBox="1"/>
+          <p:nvPr/>
+        </p:nvSpPr>
+        <p:spPr>
+          <a:xfrm>
+            <a:off x="8928735" y="7698105"/>
+            <a:ext cx="257175" cy="323849"/>
+          </a:xfrm>
+          <a:prstGeom prst="rect">
+            <a:avLst/>
+          </a:prstGeom>
+          <a:noFill/>
+        </p:spPr>
+        <p:txBody>
+          <a:bodyPr wrap="none"/>
+          <a:lstStyle/>
+          <a:p>
+            <a:pPr algn="l">
+              <a:spcBef>
+                <a:spcPts val="0"/>
+              </a:spcBef>
+              <a:spcAft>
+                <a:spcPts val="0"/>
+              </a:spcAft>
+            </a:pPr>
+            <a:r>
+              <a:rPr sz="2100" b="1">
+                <a:solidFill>
+                  <a:srgbClr val="333333"/>
+                </a:solidFill>
+                <a:latin typeface="Inter Bold"/>
+              </a:rPr>
+              <a:t>→</a:t>
+            </a:r>
+          </a:p>
+        </p:txBody>
+      </p:sp>
+      <p:sp>
+        <p:nvSpPr>
+          <p:cNvPr id="31" name="TextBox 30"/>
+          <p:cNvSpPr txBox="1"/>
+          <p:nvPr/>
+        </p:nvSpPr>
+        <p:spPr>
+          <a:xfrm>
+            <a:off x="13091160" y="7698105"/>
+            <a:ext cx="257175" cy="323849"/>
+          </a:xfrm>
+          <a:prstGeom prst="rect">
+            <a:avLst/>
+          </a:prstGeom>
+          <a:noFill/>
+        </p:spPr>
+        <p:txBody>
+          <a:bodyPr wrap="none"/>
+          <a:lstStyle/>
+          <a:p>
+            <a:pPr algn="l">
+              <a:spcBef>
+                <a:spcPts val="0"/>
+              </a:spcBef>
+              <a:spcAft>
+                <a:spcPts val="0"/>
+              </a:spcAft>
+            </a:pPr>
+            <a:r>
+              <a:rPr sz="2100" b="1">
+                <a:solidFill>
+                  <a:srgbClr val="333333"/>
+                </a:solidFill>
+                <a:latin typeface="Inter Bold"/>
+              </a:rPr>
+              <a:t>→</a:t>
+            </a:r>
+          </a:p>
+        </p:txBody>
+      </p:sp>
+    </p:spTree>
+  </p:cSld>
+  <p:clrMapOvr>
+    <a:masterClrMapping/>
+  </p:clrMapOvr>
+</p:sld>
+</file>
+
+<file path=ppt/slides/slide31.xml><?xml version="1.0" encoding="utf-8"?>
+<p:sld xmlns:a="http://schemas.openxmlformats.org/drawingml/2006/main" xmlns:p="http://schemas.openxmlformats.org/presentationml/2006/main" xmlns:r="http://schemas.openxmlformats.org/officeDocument/2006/relationships">
+  <p:cSld>
+    <p:spTree>
+      <p:nvGrpSpPr>
+        <p:cNvPr id="1" name=""/>
+        <p:cNvGrpSpPr/>
+        <p:nvPr/>
+      </p:nvGrpSpPr>
+      <p:grpSpPr/>
+      <p:sp>
+        <p:nvSpPr>
+          <p:cNvPr id="2" name="Rectangle 1"/>
+          <p:cNvSpPr/>
+          <p:nvPr/>
+        </p:nvSpPr>
+        <p:spPr>
+          <a:xfrm>
+            <a:off x="0" y="0"/>
+            <a:ext cx="18288000" cy="10287000"/>
+          </a:xfrm>
+          <a:prstGeom prst="rect">
+            <a:avLst/>
+          </a:prstGeom>
+          <a:solidFill>
+            <a:srgbClr val="000000"/>
+          </a:solidFill>
+          <a:ln>
+            <a:noFill/>
+          </a:ln>
+        </p:spPr>
+        <p:style>
+          <a:lnRef idx="1">
+            <a:schemeClr val="accent1"/>
+          </a:lnRef>
+          <a:fillRef idx="3">
+            <a:schemeClr val="accent1"/>
+          </a:fillRef>
+          <a:effectRef idx="2">
+            <a:schemeClr val="accent1"/>
+          </a:effectRef>
+          <a:fontRef idx="minor">
+            <a:schemeClr val="lt1"/>
+          </a:fontRef>
+        </p:style>
+        <p:txBody>
+          <a:bodyPr rtlCol="0" anchor="ctr"/>
+          <a:lstStyle/>
+          <a:p>
+            <a:pPr algn="ctr"/>
+          </a:p>
+        </p:txBody>
+      </p:sp>
+      <p:sp>
+        <p:nvSpPr>
+          <p:cNvPr id="3" name="TextBox 2"/>
+          <p:cNvSpPr txBox="1"/>
+          <p:nvPr/>
+        </p:nvSpPr>
+        <p:spPr>
+          <a:xfrm>
+            <a:off x="4671060" y="716280"/>
+            <a:ext cx="12506324" cy="5305425"/>
+          </a:xfrm>
+          <a:prstGeom prst="rect">
+            <a:avLst/>
+          </a:prstGeom>
+          <a:noFill/>
+        </p:spPr>
+        <p:txBody>
+          <a:bodyPr wrap="none"/>
+          <a:lstStyle/>
+          <a:p>
+            <a:pPr algn="l">
+              <a:spcBef>
+                <a:spcPts val="0"/>
+              </a:spcBef>
+              <a:spcAft>
+                <a:spcPts val="0"/>
+              </a:spcAft>
+            </a:pPr>
+            <a:r>
+              <a:rPr sz="34500" b="1">
+                <a:solidFill>
+                  <a:srgbClr val="FFFFFF">
+                    <a:alpha val="5000"/>
+                  </a:srgbClr>
+                </a:solidFill>
+                <a:latin typeface="Inter Black"/>
+              </a:rPr>
+              <a:t>YAML</a:t>
+            </a:r>
+          </a:p>
+        </p:txBody>
+      </p:sp>
+      <p:sp>
+        <p:nvSpPr>
+          <p:cNvPr id="4" name="Rectangle 3"/>
+          <p:cNvSpPr/>
+          <p:nvPr/>
+        </p:nvSpPr>
+        <p:spPr>
+          <a:xfrm>
+            <a:off x="0" y="0"/>
+            <a:ext cx="76200" cy="10287000"/>
+          </a:xfrm>
+          <a:prstGeom prst="rect">
+            <a:avLst/>
+          </a:prstGeom>
+          <a:solidFill>
+            <a:srgbClr val="FFFFFF"/>
+          </a:solidFill>
+          <a:ln>
+            <a:noFill/>
+          </a:ln>
+        </p:spPr>
+        <p:style>
+          <a:lnRef idx="1">
+            <a:schemeClr val="accent1"/>
+          </a:lnRef>
+          <a:fillRef idx="3">
+            <a:schemeClr val="accent1"/>
+          </a:fillRef>
+          <a:effectRef idx="2">
+            <a:schemeClr val="accent1"/>
+          </a:effectRef>
+          <a:fontRef idx="minor">
+            <a:schemeClr val="lt1"/>
+          </a:fontRef>
+        </p:style>
+        <p:txBody>
+          <a:bodyPr rtlCol="0" anchor="ctr"/>
+          <a:lstStyle/>
+          <a:p>
+            <a:pPr algn="ctr"/>
+          </a:p>
+        </p:txBody>
+      </p:sp>
+      <p:sp>
+        <p:nvSpPr>
+          <p:cNvPr id="5" name="Rectangle 4"/>
+          <p:cNvSpPr/>
+          <p:nvPr/>
+        </p:nvSpPr>
+        <p:spPr>
+          <a:xfrm>
+            <a:off x="16383000" y="10096500"/>
+            <a:ext cx="1905000" cy="76200"/>
+          </a:xfrm>
+          <a:prstGeom prst="rect">
+            <a:avLst/>
+          </a:prstGeom>
+          <a:solidFill>
+            <a:srgbClr val="FFFFFF"/>
+          </a:solidFill>
+          <a:ln>
+            <a:noFill/>
+          </a:ln>
+        </p:spPr>
+        <p:style>
+          <a:lnRef idx="1">
+            <a:schemeClr val="accent1"/>
+          </a:lnRef>
+          <a:fillRef idx="3">
+            <a:schemeClr val="accent1"/>
+          </a:fillRef>
+          <a:effectRef idx="2">
+            <a:schemeClr val="accent1"/>
+          </a:effectRef>
+          <a:fontRef idx="minor">
+            <a:schemeClr val="lt1"/>
+          </a:fontRef>
+        </p:style>
+        <p:txBody>
+          <a:bodyPr rtlCol="0" anchor="ctr"/>
+          <a:lstStyle/>
+          <a:p>
+            <a:pPr algn="ctr"/>
+          </a:p>
+        </p:txBody>
+      </p:sp>
+      <p:sp>
+        <p:nvSpPr>
+          <p:cNvPr id="6" name="Rectangle 5"/>
+          <p:cNvSpPr/>
+          <p:nvPr/>
+        </p:nvSpPr>
+        <p:spPr>
+          <a:xfrm>
+            <a:off x="1143000" y="1143000"/>
+            <a:ext cx="133350" cy="133350"/>
+          </a:xfrm>
+          <a:prstGeom prst="rect">
+            <a:avLst/>
+          </a:prstGeom>
+          <a:solidFill>
+            <a:srgbClr val="FFFFFF"/>
+          </a:solidFill>
+          <a:ln>
+            <a:noFill/>
+          </a:ln>
+        </p:spPr>
+        <p:style>
+          <a:lnRef idx="1">
+            <a:schemeClr val="accent1"/>
+          </a:lnRef>
+          <a:fillRef idx="3">
+            <a:schemeClr val="accent1"/>
+          </a:fillRef>
+          <a:effectRef idx="2">
+            <a:schemeClr val="accent1"/>
+          </a:effectRef>
+          <a:fontRef idx="minor">
+            <a:schemeClr val="lt1"/>
+          </a:fontRef>
+        </p:style>
+        <p:txBody>
+          <a:bodyPr rtlCol="0" anchor="ctr"/>
+          <a:lstStyle/>
+          <a:p>
+            <a:pPr algn="ctr"/>
+          </a:p>
+        </p:txBody>
+      </p:sp>
+      <p:sp>
+        <p:nvSpPr>
+          <p:cNvPr id="7" name="TextBox 6"/>
+          <p:cNvSpPr txBox="1"/>
+          <p:nvPr/>
+        </p:nvSpPr>
+        <p:spPr>
+          <a:xfrm>
+            <a:off x="1337310" y="1049655"/>
+            <a:ext cx="4762500" cy="228600"/>
+          </a:xfrm>
+          <a:prstGeom prst="rect">
+            <a:avLst/>
+          </a:prstGeom>
+          <a:noFill/>
+        </p:spPr>
+        <p:txBody>
+          <a:bodyPr wrap="none"/>
+          <a:lstStyle/>
+          <a:p>
+            <a:pPr algn="l">
+              <a:spcBef>
+                <a:spcPts val="0"/>
+              </a:spcBef>
+              <a:spcAft>
+                <a:spcPts val="0"/>
+              </a:spcAft>
+            </a:pPr>
+            <a:r>
+              <a:rPr sz="1500" b="0" spc="300">
+                <a:solidFill>
+                  <a:srgbClr val="FFFFFF"/>
+                </a:solidFill>
+                <a:latin typeface="Inter SemiBold"/>
+              </a:rPr>
+              <a:t>06 / ASO · DEMO</a:t>
+            </a:r>
+          </a:p>
+        </p:txBody>
+      </p:sp>
+      <p:sp>
+        <p:nvSpPr>
+          <p:cNvPr id="8" name="TextBox 7"/>
+          <p:cNvSpPr txBox="1"/>
+          <p:nvPr/>
+        </p:nvSpPr>
+        <p:spPr>
+          <a:xfrm>
+            <a:off x="1051560" y="3488055"/>
+            <a:ext cx="16002000" cy="1171575"/>
+          </a:xfrm>
+          <a:prstGeom prst="rect">
+            <a:avLst/>
+          </a:prstGeom>
+          <a:noFill/>
+        </p:spPr>
+        <p:txBody>
+          <a:bodyPr wrap="none"/>
+          <a:lstStyle/>
+          <a:p>
+            <a:pPr algn="l">
+              <a:spcBef>
+                <a:spcPts val="0"/>
+              </a:spcBef>
+              <a:spcAft>
+                <a:spcPts val="0"/>
+              </a:spcAft>
+            </a:pPr>
+            <a:r>
+              <a:rPr sz="10500" b="1">
+                <a:solidFill>
+                  <a:srgbClr val="FFFFFF"/>
+                </a:solidFill>
+                <a:latin typeface="Inter Black"/>
+              </a:rPr>
+              <a:t>APPLY YAML.</a:t>
+            </a:r>
+          </a:p>
+        </p:txBody>
+      </p:sp>
+      <p:sp>
+        <p:nvSpPr>
+          <p:cNvPr id="9" name="TextBox 8"/>
+          <p:cNvSpPr txBox="1"/>
+          <p:nvPr/>
+        </p:nvSpPr>
+        <p:spPr>
+          <a:xfrm>
+            <a:off x="1051560" y="4735830"/>
+            <a:ext cx="16002000" cy="1171575"/>
+          </a:xfrm>
+          <a:prstGeom prst="rect">
+            <a:avLst/>
+          </a:prstGeom>
+          <a:noFill/>
+        </p:spPr>
+        <p:txBody>
+          <a:bodyPr wrap="none"/>
+          <a:lstStyle/>
+          <a:p>
+            <a:pPr algn="l">
+              <a:spcBef>
+                <a:spcPts val="0"/>
+              </a:spcBef>
+              <a:spcAft>
+                <a:spcPts val="0"/>
+              </a:spcAft>
+            </a:pPr>
+            <a:r>
+              <a:rPr sz="10500" b="1">
+                <a:solidFill>
+                  <a:srgbClr val="FFFFFF"/>
+                </a:solidFill>
+                <a:latin typeface="Inter Black"/>
+              </a:rPr>
+              <a:t>GET AZURE.</a:t>
+            </a:r>
+          </a:p>
+        </p:txBody>
+      </p:sp>
+      <p:sp>
+        <p:nvSpPr>
+          <p:cNvPr id="10" name="TextBox 9"/>
+          <p:cNvSpPr txBox="1"/>
+          <p:nvPr/>
+        </p:nvSpPr>
+        <p:spPr>
+          <a:xfrm>
+            <a:off x="1051560" y="5983605"/>
+            <a:ext cx="16002000" cy="476249"/>
+          </a:xfrm>
+          <a:prstGeom prst="rect">
+            <a:avLst/>
+          </a:prstGeom>
+          <a:noFill/>
+        </p:spPr>
+        <p:txBody>
+          <a:bodyPr wrap="none"/>
+          <a:lstStyle/>
+          <a:p>
+            <a:pPr algn="l">
+              <a:spcBef>
+                <a:spcPts val="0"/>
+              </a:spcBef>
+              <a:spcAft>
+                <a:spcPts val="0"/>
+              </a:spcAft>
+            </a:pPr>
+            <a:r>
+              <a:rPr sz="2700" b="1">
+                <a:solidFill>
+                  <a:srgbClr val="444444"/>
+                </a:solidFill>
+                <a:latin typeface="Inter Black"/>
+              </a:rPr>
+              <a:t>NO TERRAFORM. NO BICEP. NO ARM.</a:t>
+            </a:r>
+          </a:p>
+        </p:txBody>
+      </p:sp>
+      <p:sp>
+        <p:nvSpPr>
+          <p:cNvPr id="11" name="Rectangle 10"/>
+          <p:cNvSpPr/>
+          <p:nvPr/>
+        </p:nvSpPr>
+        <p:spPr>
+          <a:xfrm>
+            <a:off x="1143000" y="8801100"/>
+            <a:ext cx="2124075" cy="533400"/>
+          </a:xfrm>
+          <a:prstGeom prst="rect">
+            <a:avLst/>
+          </a:prstGeom>
+          <a:solidFill>
+            <a:srgbClr val="111111"/>
+          </a:solidFill>
+          <a:ln>
+            <a:noFill/>
+          </a:ln>
+        </p:spPr>
+        <p:style>
+          <a:lnRef idx="1">
+            <a:schemeClr val="accent1"/>
+          </a:lnRef>
+          <a:fillRef idx="3">
+            <a:schemeClr val="accent1"/>
+          </a:fillRef>
+          <a:effectRef idx="2">
+            <a:schemeClr val="accent1"/>
+          </a:effectRef>
+          <a:fontRef idx="minor">
+            <a:schemeClr val="lt1"/>
+          </a:fontRef>
+        </p:style>
+        <p:txBody>
+          <a:bodyPr rtlCol="0" anchor="ctr"/>
+          <a:lstStyle/>
+          <a:p>
+            <a:pPr algn="ctr"/>
+          </a:p>
+        </p:txBody>
+      </p:sp>
+      <p:sp>
+        <p:nvSpPr>
+          <p:cNvPr id="12" name="Oval 11"/>
+          <p:cNvSpPr/>
+          <p:nvPr/>
+        </p:nvSpPr>
+        <p:spPr>
+          <a:xfrm>
+            <a:off x="1333500" y="8934449"/>
+            <a:ext cx="266700" cy="266700"/>
+          </a:xfrm>
+          <a:prstGeom prst="ellipse">
+            <a:avLst/>
+          </a:prstGeom>
+          <a:solidFill>
+            <a:srgbClr val="0078D4"/>
+          </a:solidFill>
+          <a:ln>
+            <a:noFill/>
+          </a:ln>
+        </p:spPr>
+        <p:style>
+          <a:lnRef idx="1">
+            <a:schemeClr val="accent1"/>
+          </a:lnRef>
+          <a:fillRef idx="3">
+            <a:schemeClr val="accent1"/>
+          </a:fillRef>
+          <a:effectRef idx="2">
+            <a:schemeClr val="accent1"/>
+          </a:effectRef>
+          <a:fontRef idx="minor">
+            <a:schemeClr val="lt1"/>
+          </a:fontRef>
+        </p:style>
+        <p:txBody>
+          <a:bodyPr rtlCol="0" anchor="ctr"/>
+          <a:lstStyle/>
+          <a:p>
+            <a:pPr algn="ctr"/>
+          </a:p>
+        </p:txBody>
+      </p:sp>
+      <p:sp>
+        <p:nvSpPr>
+          <p:cNvPr id="13" name="TextBox 12"/>
+          <p:cNvSpPr txBox="1"/>
+          <p:nvPr/>
+        </p:nvSpPr>
+        <p:spPr>
+          <a:xfrm>
+            <a:off x="1327785" y="8917305"/>
+            <a:ext cx="114300" cy="152400"/>
+          </a:xfrm>
+          <a:prstGeom prst="rect">
+            <a:avLst/>
+          </a:prstGeom>
+          <a:noFill/>
+        </p:spPr>
+        <p:txBody>
+          <a:bodyPr wrap="none"/>
+          <a:lstStyle/>
+          <a:p>
+            <a:pPr algn="l">
+              <a:spcBef>
+                <a:spcPts val="0"/>
+              </a:spcBef>
+              <a:spcAft>
+                <a:spcPts val="0"/>
+              </a:spcAft>
+            </a:pPr>
+            <a:r>
+              <a:rPr sz="900" b="1">
+                <a:solidFill>
+                  <a:srgbClr val="FFFFFF"/>
+                </a:solidFill>
+                <a:latin typeface="Inter Bold"/>
+              </a:rPr>
+              <a:t>1</a:t>
+            </a:r>
+          </a:p>
+        </p:txBody>
+      </p:sp>
+      <p:sp>
+        <p:nvSpPr>
+          <p:cNvPr id="14" name="TextBox 13"/>
+          <p:cNvSpPr txBox="1"/>
+          <p:nvPr/>
+        </p:nvSpPr>
+        <p:spPr>
+          <a:xfrm>
+            <a:off x="1604010" y="8793480"/>
+            <a:ext cx="1457325" cy="180975"/>
+          </a:xfrm>
+          <a:prstGeom prst="rect">
+            <a:avLst/>
+          </a:prstGeom>
+          <a:noFill/>
+        </p:spPr>
+        <p:txBody>
+          <a:bodyPr wrap="none"/>
+          <a:lstStyle/>
+          <a:p>
+            <a:pPr algn="l">
+              <a:spcBef>
+                <a:spcPts val="0"/>
+              </a:spcBef>
+              <a:spcAft>
+                <a:spcPts val="0"/>
+              </a:spcAft>
+            </a:pPr>
+            <a:r>
+              <a:rPr sz="1200" b="1">
+                <a:solidFill>
+                  <a:srgbClr val="FFFFFF"/>
+                </a:solidFill>
+                <a:latin typeface="Inter ExtraBold"/>
+              </a:rPr>
+              <a:t>KUBECTL APPLY</a:t>
+            </a:r>
+          </a:p>
+        </p:txBody>
+      </p:sp>
+      <p:sp>
+        <p:nvSpPr>
+          <p:cNvPr id="15" name="Rectangle 14"/>
+          <p:cNvSpPr/>
+          <p:nvPr/>
+        </p:nvSpPr>
+        <p:spPr>
+          <a:xfrm>
+            <a:off x="3714750" y="8801100"/>
+            <a:ext cx="2162174" cy="533400"/>
+          </a:xfrm>
+          <a:prstGeom prst="rect">
+            <a:avLst/>
+          </a:prstGeom>
+          <a:solidFill>
+            <a:srgbClr val="111111"/>
+          </a:solidFill>
+          <a:ln>
+            <a:noFill/>
+          </a:ln>
+        </p:spPr>
+        <p:style>
+          <a:lnRef idx="1">
+            <a:schemeClr val="accent1"/>
+          </a:lnRef>
+          <a:fillRef idx="3">
+            <a:schemeClr val="accent1"/>
+          </a:fillRef>
+          <a:effectRef idx="2">
+            <a:schemeClr val="accent1"/>
+          </a:effectRef>
+          <a:fontRef idx="minor">
+            <a:schemeClr val="lt1"/>
+          </a:fontRef>
+        </p:style>
+        <p:txBody>
+          <a:bodyPr rtlCol="0" anchor="ctr"/>
+          <a:lstStyle/>
+          <a:p>
+            <a:pPr algn="ctr"/>
+          </a:p>
+        </p:txBody>
+      </p:sp>
+      <p:sp>
+        <p:nvSpPr>
+          <p:cNvPr id="16" name="Oval 15"/>
+          <p:cNvSpPr/>
+          <p:nvPr/>
+        </p:nvSpPr>
+        <p:spPr>
+          <a:xfrm>
+            <a:off x="3905249" y="8934449"/>
+            <a:ext cx="266700" cy="266700"/>
+          </a:xfrm>
+          <a:prstGeom prst="ellipse">
+            <a:avLst/>
+          </a:prstGeom>
+          <a:solidFill>
+            <a:srgbClr val="EF7B4D"/>
+          </a:solidFill>
+          <a:ln>
+            <a:noFill/>
+          </a:ln>
+        </p:spPr>
+        <p:style>
+          <a:lnRef idx="1">
+            <a:schemeClr val="accent1"/>
+          </a:lnRef>
+          <a:fillRef idx="3">
+            <a:schemeClr val="accent1"/>
+          </a:fillRef>
+          <a:effectRef idx="2">
+            <a:schemeClr val="accent1"/>
+          </a:effectRef>
+          <a:fontRef idx="minor">
+            <a:schemeClr val="lt1"/>
+          </a:fontRef>
+        </p:style>
+        <p:txBody>
+          <a:bodyPr rtlCol="0" anchor="ctr"/>
+          <a:lstStyle/>
+          <a:p>
+            <a:pPr algn="ctr"/>
+          </a:p>
+        </p:txBody>
+      </p:sp>
+      <p:sp>
+        <p:nvSpPr>
+          <p:cNvPr id="17" name="TextBox 16"/>
+          <p:cNvSpPr txBox="1"/>
+          <p:nvPr/>
+        </p:nvSpPr>
+        <p:spPr>
+          <a:xfrm>
+            <a:off x="3899535" y="8917305"/>
+            <a:ext cx="114300" cy="152400"/>
+          </a:xfrm>
+          <a:prstGeom prst="rect">
+            <a:avLst/>
+          </a:prstGeom>
+          <a:noFill/>
+        </p:spPr>
+        <p:txBody>
+          <a:bodyPr wrap="none"/>
+          <a:lstStyle/>
+          <a:p>
+            <a:pPr algn="l">
+              <a:spcBef>
+                <a:spcPts val="0"/>
+              </a:spcBef>
+              <a:spcAft>
+                <a:spcPts val="0"/>
+              </a:spcAft>
+            </a:pPr>
+            <a:r>
+              <a:rPr sz="900" b="1">
+                <a:solidFill>
+                  <a:srgbClr val="FFFFFF"/>
+                </a:solidFill>
+                <a:latin typeface="Inter Bold"/>
+              </a:rPr>
+              <a:t>2</a:t>
+            </a:r>
+          </a:p>
+        </p:txBody>
+      </p:sp>
+      <p:sp>
+        <p:nvSpPr>
+          <p:cNvPr id="18" name="TextBox 17"/>
+          <p:cNvSpPr txBox="1"/>
+          <p:nvPr/>
+        </p:nvSpPr>
+        <p:spPr>
+          <a:xfrm>
+            <a:off x="4175760" y="8793480"/>
+            <a:ext cx="1495425" cy="180975"/>
+          </a:xfrm>
+          <a:prstGeom prst="rect">
+            <a:avLst/>
+          </a:prstGeom>
+          <a:noFill/>
+        </p:spPr>
+        <p:txBody>
+          <a:bodyPr wrap="none"/>
+          <a:lstStyle/>
+          <a:p>
+            <a:pPr algn="l">
+              <a:spcBef>
+                <a:spcPts val="0"/>
+              </a:spcBef>
+              <a:spcAft>
+                <a:spcPts val="0"/>
+              </a:spcAft>
+            </a:pPr>
+            <a:r>
+              <a:rPr sz="1200" b="1">
+                <a:solidFill>
+                  <a:srgbClr val="FFFFFF"/>
+                </a:solidFill>
+                <a:latin typeface="Inter ExtraBold"/>
+              </a:rPr>
+              <a:t>ARGO CD SYNCS</a:t>
+            </a:r>
+          </a:p>
+        </p:txBody>
+      </p:sp>
+      <p:sp>
+        <p:nvSpPr>
+          <p:cNvPr id="19" name="Rectangle 18"/>
+          <p:cNvSpPr/>
+          <p:nvPr/>
+        </p:nvSpPr>
+        <p:spPr>
+          <a:xfrm>
+            <a:off x="6324599" y="8801100"/>
+            <a:ext cx="2886075" cy="533400"/>
+          </a:xfrm>
+          <a:prstGeom prst="rect">
+            <a:avLst/>
+          </a:prstGeom>
+          <a:solidFill>
+            <a:srgbClr val="111111"/>
+          </a:solidFill>
+          <a:ln>
+            <a:noFill/>
+          </a:ln>
+        </p:spPr>
+        <p:style>
+          <a:lnRef idx="1">
+            <a:schemeClr val="accent1"/>
+          </a:lnRef>
+          <a:fillRef idx="3">
+            <a:schemeClr val="accent1"/>
+          </a:fillRef>
+          <a:effectRef idx="2">
+            <a:schemeClr val="accent1"/>
+          </a:effectRef>
+          <a:fontRef idx="minor">
+            <a:schemeClr val="lt1"/>
+          </a:fontRef>
+        </p:style>
+        <p:txBody>
+          <a:bodyPr rtlCol="0" anchor="ctr"/>
+          <a:lstStyle/>
+          <a:p>
+            <a:pPr algn="ctr"/>
+          </a:p>
+        </p:txBody>
+      </p:sp>
+      <p:sp>
+        <p:nvSpPr>
+          <p:cNvPr id="20" name="Oval 19"/>
+          <p:cNvSpPr/>
+          <p:nvPr/>
+        </p:nvSpPr>
+        <p:spPr>
+          <a:xfrm>
+            <a:off x="6515100" y="8934449"/>
+            <a:ext cx="266700" cy="266700"/>
+          </a:xfrm>
+          <a:prstGeom prst="ellipse">
+            <a:avLst/>
+          </a:prstGeom>
+          <a:solidFill>
+            <a:srgbClr val="10B981"/>
+          </a:solidFill>
+          <a:ln>
+            <a:noFill/>
+          </a:ln>
+        </p:spPr>
+        <p:style>
+          <a:lnRef idx="1">
+            <a:schemeClr val="accent1"/>
+          </a:lnRef>
+          <a:fillRef idx="3">
+            <a:schemeClr val="accent1"/>
+          </a:fillRef>
+          <a:effectRef idx="2">
+            <a:schemeClr val="accent1"/>
+          </a:effectRef>
+          <a:fontRef idx="minor">
+            <a:schemeClr val="lt1"/>
+          </a:fontRef>
+        </p:style>
+        <p:txBody>
+          <a:bodyPr rtlCol="0" anchor="ctr"/>
+          <a:lstStyle/>
+          <a:p>
+            <a:pPr algn="ctr"/>
+          </a:p>
+        </p:txBody>
+      </p:sp>
+      <p:sp>
+        <p:nvSpPr>
+          <p:cNvPr id="21" name="TextBox 20"/>
+          <p:cNvSpPr txBox="1"/>
+          <p:nvPr/>
+        </p:nvSpPr>
+        <p:spPr>
+          <a:xfrm>
+            <a:off x="6509384" y="8917305"/>
+            <a:ext cx="114300" cy="152400"/>
+          </a:xfrm>
+          <a:prstGeom prst="rect">
+            <a:avLst/>
+          </a:prstGeom>
+          <a:noFill/>
+        </p:spPr>
+        <p:txBody>
+          <a:bodyPr wrap="none"/>
+          <a:lstStyle/>
+          <a:p>
+            <a:pPr algn="l">
+              <a:spcBef>
+                <a:spcPts val="0"/>
+              </a:spcBef>
+              <a:spcAft>
+                <a:spcPts val="0"/>
+              </a:spcAft>
+            </a:pPr>
+            <a:r>
+              <a:rPr sz="900" b="1">
+                <a:solidFill>
+                  <a:srgbClr val="FFFFFF"/>
+                </a:solidFill>
+                <a:latin typeface="Inter Bold"/>
+              </a:rPr>
+              <a:t>3</a:t>
+            </a:r>
+          </a:p>
+        </p:txBody>
+      </p:sp>
+      <p:sp>
+        <p:nvSpPr>
+          <p:cNvPr id="22" name="TextBox 21"/>
+          <p:cNvSpPr txBox="1"/>
+          <p:nvPr/>
+        </p:nvSpPr>
+        <p:spPr>
+          <a:xfrm>
+            <a:off x="6785610" y="8793480"/>
+            <a:ext cx="2219325" cy="180975"/>
+          </a:xfrm>
+          <a:prstGeom prst="rect">
+            <a:avLst/>
+          </a:prstGeom>
+          <a:noFill/>
+        </p:spPr>
+        <p:txBody>
+          <a:bodyPr wrap="none"/>
+          <a:lstStyle/>
+          <a:p>
+            <a:pPr algn="l">
+              <a:spcBef>
+                <a:spcPts val="0"/>
+              </a:spcBef>
+              <a:spcAft>
+                <a:spcPts val="0"/>
+              </a:spcAft>
+            </a:pPr>
+            <a:r>
+              <a:rPr sz="1200" b="1">
+                <a:solidFill>
+                  <a:srgbClr val="FFFFFF"/>
+                </a:solidFill>
+                <a:latin typeface="Inter ExtraBold"/>
+              </a:rPr>
+              <a:t>AZURE RESOURCE READY</a:t>
+            </a:r>
+          </a:p>
+        </p:txBody>
+      </p:sp>
+      <p:sp>
+        <p:nvSpPr>
+          <p:cNvPr id="23" name="TextBox 22"/>
+          <p:cNvSpPr txBox="1"/>
+          <p:nvPr/>
+        </p:nvSpPr>
+        <p:spPr>
+          <a:xfrm>
+            <a:off x="3289935" y="8888730"/>
+            <a:ext cx="219075" cy="276225"/>
+          </a:xfrm>
+          <a:prstGeom prst="rect">
+            <a:avLst/>
+          </a:prstGeom>
+          <a:noFill/>
+        </p:spPr>
+        <p:txBody>
+          <a:bodyPr wrap="none"/>
+          <a:lstStyle/>
+          <a:p>
+            <a:pPr algn="l">
+              <a:spcBef>
+                <a:spcPts val="0"/>
+              </a:spcBef>
+              <a:spcAft>
+                <a:spcPts val="0"/>
+              </a:spcAft>
+            </a:pPr>
+            <a:r>
+              <a:rPr sz="1800" b="1">
+                <a:solidFill>
+                  <a:srgbClr val="444444"/>
+                </a:solidFill>
+                <a:latin typeface="Inter Bold"/>
+              </a:rPr>
+              <a:t>→</a:t>
+            </a:r>
+          </a:p>
+        </p:txBody>
+      </p:sp>
+      <p:sp>
+        <p:nvSpPr>
+          <p:cNvPr id="24" name="TextBox 23"/>
+          <p:cNvSpPr txBox="1"/>
+          <p:nvPr/>
+        </p:nvSpPr>
+        <p:spPr>
+          <a:xfrm>
+            <a:off x="5899784" y="8888730"/>
+            <a:ext cx="219075" cy="276225"/>
+          </a:xfrm>
+          <a:prstGeom prst="rect">
+            <a:avLst/>
+          </a:prstGeom>
+          <a:noFill/>
+        </p:spPr>
+        <p:txBody>
+          <a:bodyPr wrap="none"/>
+          <a:lstStyle/>
+          <a:p>
+            <a:pPr algn="l">
+              <a:spcBef>
+                <a:spcPts val="0"/>
+              </a:spcBef>
+              <a:spcAft>
+                <a:spcPts val="0"/>
+              </a:spcAft>
+            </a:pPr>
+            <a:r>
+              <a:rPr sz="1800" b="1">
+                <a:solidFill>
+                  <a:srgbClr val="444444"/>
+                </a:solidFill>
+                <a:latin typeface="Inter Bold"/>
+              </a:rPr>
+              <a:t>→</a:t>
+            </a:r>
+          </a:p>
+        </p:txBody>
+      </p:sp>
+    </p:spTree>
+  </p:cSld>
+  <p:clrMapOvr>
+    <a:masterClrMapping/>
+  </p:clrMapOvr>
+</p:sld>
+</file>
+
+<file path=ppt/slides/slide32.xml><?xml version="1.0" encoding="utf-8"?>
+<p:sld xmlns:a="http://schemas.openxmlformats.org/drawingml/2006/main" xmlns:p="http://schemas.openxmlformats.org/presentationml/2006/main" xmlns:r="http://schemas.openxmlformats.org/officeDocument/2006/relationships">
+  <p:cSld>
+    <p:spTree>
+      <p:nvGrpSpPr>
+        <p:cNvPr id="1" name=""/>
+        <p:cNvGrpSpPr/>
+        <p:nvPr/>
+      </p:nvGrpSpPr>
+      <p:grpSpPr/>
+      <p:sp>
+        <p:nvSpPr>
+          <p:cNvPr id="2" name="Rectangle 1"/>
+          <p:cNvSpPr/>
+          <p:nvPr/>
+        </p:nvSpPr>
+        <p:spPr>
+          <a:xfrm>
+            <a:off x="0" y="0"/>
+            <a:ext cx="18288000" cy="10287000"/>
+          </a:xfrm>
+          <a:prstGeom prst="rect">
+            <a:avLst/>
+          </a:prstGeom>
+          <a:solidFill>
+            <a:srgbClr val="FFFFFF"/>
+          </a:solidFill>
+          <a:ln>
+            <a:noFill/>
+          </a:ln>
+        </p:spPr>
+        <p:style>
+          <a:lnRef idx="1">
+            <a:schemeClr val="accent1"/>
+          </a:lnRef>
+          <a:fillRef idx="3">
+            <a:schemeClr val="accent1"/>
+          </a:fillRef>
+          <a:effectRef idx="2">
+            <a:schemeClr val="accent1"/>
+          </a:effectRef>
+          <a:fontRef idx="minor">
+            <a:schemeClr val="lt1"/>
+          </a:fontRef>
+        </p:style>
+        <p:txBody>
+          <a:bodyPr rtlCol="0" anchor="ctr"/>
+          <a:lstStyle/>
+          <a:p>
+            <a:pPr algn="ctr"/>
+          </a:p>
+        </p:txBody>
+      </p:sp>
+      <p:sp>
+        <p:nvSpPr>
+          <p:cNvPr id="3" name="TextBox 2"/>
+          <p:cNvSpPr txBox="1"/>
+          <p:nvPr/>
+        </p:nvSpPr>
+        <p:spPr>
+          <a:xfrm>
+            <a:off x="5433060" y="1859280"/>
+            <a:ext cx="9163050" cy="5305425"/>
+          </a:xfrm>
+          <a:prstGeom prst="rect">
+            <a:avLst/>
+          </a:prstGeom>
+          <a:noFill/>
+        </p:spPr>
+        <p:txBody>
+          <a:bodyPr wrap="none"/>
+          <a:lstStyle/>
+          <a:p>
+            <a:pPr algn="l">
+              <a:spcBef>
+                <a:spcPts val="0"/>
+              </a:spcBef>
+              <a:spcAft>
+                <a:spcPts val="0"/>
+              </a:spcAft>
+            </a:pPr>
+            <a:r>
+              <a:rPr sz="34500" b="1">
+                <a:solidFill>
+                  <a:srgbClr val="000000">
+                    <a:alpha val="3000"/>
+                  </a:srgbClr>
+                </a:solidFill>
+                <a:latin typeface="Inter Black"/>
+              </a:rPr>
+              <a:t>ASO</a:t>
+            </a:r>
+          </a:p>
+        </p:txBody>
+      </p:sp>
+      <p:sp>
+        <p:nvSpPr>
+          <p:cNvPr id="4" name="Rectangle 3"/>
+          <p:cNvSpPr/>
+          <p:nvPr/>
+        </p:nvSpPr>
+        <p:spPr>
+          <a:xfrm>
+            <a:off x="0" y="0"/>
+            <a:ext cx="76200" cy="10287000"/>
+          </a:xfrm>
+          <a:prstGeom prst="rect">
+            <a:avLst/>
+          </a:prstGeom>
+          <a:solidFill>
+            <a:srgbClr val="000000"/>
+          </a:solidFill>
+          <a:ln>
+            <a:noFill/>
+          </a:ln>
+        </p:spPr>
+        <p:style>
+          <a:lnRef idx="1">
+            <a:schemeClr val="accent1"/>
+          </a:lnRef>
+          <a:fillRef idx="3">
+            <a:schemeClr val="accent1"/>
+          </a:fillRef>
+          <a:effectRef idx="2">
+            <a:schemeClr val="accent1"/>
+          </a:effectRef>
+          <a:fontRef idx="minor">
+            <a:schemeClr val="lt1"/>
+          </a:fontRef>
+        </p:style>
+        <p:txBody>
+          <a:bodyPr rtlCol="0" anchor="ctr"/>
+          <a:lstStyle/>
+          <a:p>
+            <a:pPr algn="ctr"/>
+          </a:p>
+        </p:txBody>
+      </p:sp>
+      <p:sp>
+        <p:nvSpPr>
+          <p:cNvPr id="5" name="Rectangle 4"/>
+          <p:cNvSpPr/>
+          <p:nvPr/>
+        </p:nvSpPr>
+        <p:spPr>
+          <a:xfrm>
+            <a:off x="16383000" y="10210800"/>
+            <a:ext cx="1905000" cy="76200"/>
+          </a:xfrm>
+          <a:prstGeom prst="rect">
+            <a:avLst/>
+          </a:prstGeom>
+          <a:solidFill>
+            <a:srgbClr val="000000"/>
+          </a:solidFill>
+          <a:ln>
+            <a:noFill/>
+          </a:ln>
+        </p:spPr>
+        <p:style>
+          <a:lnRef idx="1">
+            <a:schemeClr val="accent1"/>
+          </a:lnRef>
+          <a:fillRef idx="3">
+            <a:schemeClr val="accent1"/>
+          </a:fillRef>
+          <a:effectRef idx="2">
+            <a:schemeClr val="accent1"/>
+          </a:effectRef>
+          <a:fontRef idx="minor">
+            <a:schemeClr val="lt1"/>
+          </a:fontRef>
+        </p:style>
+        <p:txBody>
+          <a:bodyPr rtlCol="0" anchor="ctr"/>
+          <a:lstStyle/>
+          <a:p>
+            <a:pPr algn="ctr"/>
+          </a:p>
+        </p:txBody>
+      </p:sp>
+      <p:sp>
+        <p:nvSpPr>
+          <p:cNvPr id="6" name="Rectangle 5"/>
+          <p:cNvSpPr/>
+          <p:nvPr/>
+        </p:nvSpPr>
+        <p:spPr>
+          <a:xfrm>
+            <a:off x="1143000" y="1143000"/>
+            <a:ext cx="133350" cy="133350"/>
+          </a:xfrm>
+          <a:prstGeom prst="rect">
+            <a:avLst/>
+          </a:prstGeom>
+          <a:solidFill>
+            <a:srgbClr val="888888"/>
+          </a:solidFill>
+          <a:ln>
+            <a:noFill/>
+          </a:ln>
+        </p:spPr>
+        <p:style>
+          <a:lnRef idx="1">
+            <a:schemeClr val="accent1"/>
+          </a:lnRef>
+          <a:fillRef idx="3">
+            <a:schemeClr val="accent1"/>
+          </a:fillRef>
+          <a:effectRef idx="2">
+            <a:schemeClr val="accent1"/>
+          </a:effectRef>
+          <a:fontRef idx="minor">
+            <a:schemeClr val="lt1"/>
+          </a:fontRef>
+        </p:style>
+        <p:txBody>
+          <a:bodyPr rtlCol="0" anchor="ctr"/>
+          <a:lstStyle/>
+          <a:p>
+            <a:pPr algn="ctr"/>
+          </a:p>
+        </p:txBody>
+      </p:sp>
+      <p:sp>
+        <p:nvSpPr>
+          <p:cNvPr id="7" name="TextBox 6"/>
+          <p:cNvSpPr txBox="1"/>
+          <p:nvPr/>
+        </p:nvSpPr>
+        <p:spPr>
+          <a:xfrm>
+            <a:off x="1337310" y="1049655"/>
+            <a:ext cx="3810000" cy="228600"/>
+          </a:xfrm>
+          <a:prstGeom prst="rect">
+            <a:avLst/>
+          </a:prstGeom>
+          <a:noFill/>
+        </p:spPr>
+        <p:txBody>
+          <a:bodyPr wrap="none"/>
+          <a:lstStyle/>
+          <a:p>
+            <a:pPr algn="l">
+              <a:spcBef>
+                <a:spcPts val="0"/>
+              </a:spcBef>
+              <a:spcAft>
+                <a:spcPts val="0"/>
+              </a:spcAft>
+            </a:pPr>
+            <a:r>
+              <a:rPr sz="1500" b="0" spc="300">
+                <a:solidFill>
+                  <a:srgbClr val="888888"/>
+                </a:solidFill>
+                <a:latin typeface="Inter SemiBold"/>
+              </a:rPr>
+              <a:t>06 / ASO</a:t>
+            </a:r>
+          </a:p>
+        </p:txBody>
+      </p:sp>
+      <p:sp>
+        <p:nvSpPr>
+          <p:cNvPr id="8" name="TextBox 7"/>
+          <p:cNvSpPr txBox="1"/>
+          <p:nvPr/>
+        </p:nvSpPr>
+        <p:spPr>
+          <a:xfrm>
+            <a:off x="1051560" y="2592704"/>
+            <a:ext cx="16002000" cy="552450"/>
+          </a:xfrm>
+          <a:prstGeom prst="rect">
+            <a:avLst/>
+          </a:prstGeom>
+          <a:noFill/>
+        </p:spPr>
+        <p:txBody>
+          <a:bodyPr wrap="none"/>
+          <a:lstStyle/>
+          <a:p>
+            <a:pPr algn="l">
+              <a:spcBef>
+                <a:spcPts val="0"/>
+              </a:spcBef>
+              <a:spcAft>
+                <a:spcPts val="0"/>
+              </a:spcAft>
+            </a:pPr>
+            <a:r>
+              <a:rPr sz="4800" b="1">
+                <a:solidFill>
+                  <a:srgbClr val="000000"/>
+                </a:solidFill>
+                <a:latin typeface="Inter Black"/>
+              </a:rPr>
+              <a:t>FAST. TRANSPARENT. COMPOSABLE.</a:t>
+            </a:r>
+          </a:p>
+        </p:txBody>
+      </p:sp>
+      <p:sp>
+        <p:nvSpPr>
+          <p:cNvPr id="9" name="TextBox 8"/>
+          <p:cNvSpPr txBox="1"/>
+          <p:nvPr/>
+        </p:nvSpPr>
+        <p:spPr>
+          <a:xfrm>
+            <a:off x="1051560" y="3154679"/>
+            <a:ext cx="16002000" cy="228600"/>
+          </a:xfrm>
+          <a:prstGeom prst="rect">
+            <a:avLst/>
+          </a:prstGeom>
+          <a:noFill/>
+        </p:spPr>
+        <p:txBody>
+          <a:bodyPr wrap="none"/>
+          <a:lstStyle/>
+          <a:p>
+            <a:pPr algn="l">
+              <a:spcBef>
+                <a:spcPts val="0"/>
+              </a:spcBef>
+              <a:spcAft>
+                <a:spcPts val="0"/>
+              </a:spcAft>
+            </a:pPr>
+            <a:r>
+              <a:rPr sz="1500" b="0" spc="75">
+                <a:solidFill>
+                  <a:srgbClr val="AAAAAA"/>
+                </a:solidFill>
+                <a:latin typeface="Inter SemiBold"/>
+              </a:rPr>
+              <a:t>THREE THINGS TO KNOW BEFORE YOU CHOOSE ASO.</a:t>
+            </a:r>
+          </a:p>
+        </p:txBody>
+      </p:sp>
+      <p:sp>
+        <p:nvSpPr>
+          <p:cNvPr id="10" name="Rectangle 9"/>
+          <p:cNvSpPr/>
+          <p:nvPr/>
+        </p:nvSpPr>
+        <p:spPr>
+          <a:xfrm>
+            <a:off x="1143000" y="4933950"/>
+            <a:ext cx="16002000" cy="800100"/>
+          </a:xfrm>
+          <a:prstGeom prst="rect">
+            <a:avLst/>
+          </a:prstGeom>
+          <a:solidFill>
+            <a:srgbClr val="F8F8F8"/>
+          </a:solidFill>
+          <a:ln>
+            <a:noFill/>
+          </a:ln>
+        </p:spPr>
+        <p:style>
+          <a:lnRef idx="1">
+            <a:schemeClr val="accent1"/>
+          </a:lnRef>
+          <a:fillRef idx="3">
+            <a:schemeClr val="accent1"/>
+          </a:fillRef>
+          <a:effectRef idx="2">
+            <a:schemeClr val="accent1"/>
+          </a:effectRef>
+          <a:fontRef idx="minor">
+            <a:schemeClr val="lt1"/>
+          </a:fontRef>
+        </p:style>
+        <p:txBody>
+          <a:bodyPr rtlCol="0" anchor="ctr"/>
+          <a:lstStyle/>
+          <a:p>
+            <a:pPr algn="ctr"/>
+          </a:p>
+        </p:txBody>
+      </p:sp>
+      <p:sp>
+        <p:nvSpPr>
+          <p:cNvPr id="11" name="Rectangle 10"/>
+          <p:cNvSpPr/>
+          <p:nvPr/>
+        </p:nvSpPr>
+        <p:spPr>
+          <a:xfrm>
+            <a:off x="1371600" y="5162550"/>
+            <a:ext cx="342900" cy="342900"/>
+          </a:xfrm>
+          <a:prstGeom prst="rect">
+            <a:avLst/>
+          </a:prstGeom>
+          <a:solidFill>
+            <a:srgbClr val="0078D4"/>
+          </a:solidFill>
+          <a:ln>
+            <a:noFill/>
+          </a:ln>
+        </p:spPr>
+        <p:style>
+          <a:lnRef idx="1">
+            <a:schemeClr val="accent1"/>
+          </a:lnRef>
+          <a:fillRef idx="3">
+            <a:schemeClr val="accent1"/>
+          </a:fillRef>
+          <a:effectRef idx="2">
+            <a:schemeClr val="accent1"/>
+          </a:effectRef>
+          <a:fontRef idx="minor">
+            <a:schemeClr val="lt1"/>
+          </a:fontRef>
+        </p:style>
+        <p:txBody>
+          <a:bodyPr rtlCol="0" anchor="ctr"/>
+          <a:lstStyle/>
+          <a:p>
+            <a:pPr algn="ctr"/>
+          </a:p>
+        </p:txBody>
+      </p:sp>
+      <p:sp>
+        <p:nvSpPr>
+          <p:cNvPr id="12" name="TextBox 11"/>
+          <p:cNvSpPr txBox="1"/>
+          <p:nvPr/>
+        </p:nvSpPr>
+        <p:spPr>
+          <a:xfrm>
+            <a:off x="1384935" y="5164455"/>
+            <a:ext cx="152400" cy="190499"/>
+          </a:xfrm>
+          <a:prstGeom prst="rect">
+            <a:avLst/>
+          </a:prstGeom>
+          <a:noFill/>
+        </p:spPr>
+        <p:txBody>
+          <a:bodyPr wrap="none"/>
+          <a:lstStyle/>
+          <a:p>
+            <a:pPr algn="l">
+              <a:spcBef>
+                <a:spcPts val="0"/>
+              </a:spcBef>
+              <a:spcAft>
+                <a:spcPts val="0"/>
+              </a:spcAft>
+            </a:pPr>
+            <a:r>
+              <a:rPr sz="1200" b="1">
+                <a:solidFill>
+                  <a:srgbClr val="FFFFFF"/>
+                </a:solidFill>
+                <a:latin typeface="Inter Bold"/>
+              </a:rPr>
+              <a:t>1</a:t>
+            </a:r>
+          </a:p>
+        </p:txBody>
+      </p:sp>
+      <p:sp>
+        <p:nvSpPr>
+          <p:cNvPr id="13" name="TextBox 12"/>
+          <p:cNvSpPr txBox="1"/>
+          <p:nvPr/>
+        </p:nvSpPr>
+        <p:spPr>
+          <a:xfrm>
+            <a:off x="1813560" y="5031105"/>
+            <a:ext cx="13906499" cy="209550"/>
+          </a:xfrm>
+          <a:prstGeom prst="rect">
+            <a:avLst/>
+          </a:prstGeom>
+          <a:noFill/>
+        </p:spPr>
+        <p:txBody>
+          <a:bodyPr wrap="none"/>
+          <a:lstStyle/>
+          <a:p>
+            <a:pPr algn="l">
+              <a:spcBef>
+                <a:spcPts val="0"/>
+              </a:spcBef>
+              <a:spcAft>
+                <a:spcPts val="0"/>
+              </a:spcAft>
+            </a:pPr>
+            <a:r>
+              <a:rPr sz="1350" b="1">
+                <a:solidFill>
+                  <a:srgbClr val="000000"/>
+                </a:solidFill>
+                <a:latin typeface="Inter ExtraBold"/>
+              </a:rPr>
+              <a:t>FAST TO START</a:t>
+            </a:r>
+          </a:p>
+        </p:txBody>
+      </p:sp>
+      <p:sp>
+        <p:nvSpPr>
+          <p:cNvPr id="14" name="TextBox 13"/>
+          <p:cNvSpPr txBox="1"/>
+          <p:nvPr/>
+        </p:nvSpPr>
+        <p:spPr>
+          <a:xfrm>
+            <a:off x="1813560" y="5326380"/>
+            <a:ext cx="13906499" cy="304800"/>
+          </a:xfrm>
+          <a:prstGeom prst="rect">
+            <a:avLst/>
+          </a:prstGeom>
+          <a:noFill/>
+        </p:spPr>
+        <p:txBody>
+          <a:bodyPr wrap="square"/>
+          <a:lstStyle/>
+          <a:p>
+            <a:pPr algn="l">
+              <a:spcBef>
+                <a:spcPts val="0"/>
+              </a:spcBef>
+              <a:spcAft>
+                <a:spcPts val="0"/>
+              </a:spcAft>
+            </a:pPr>
+            <a:r>
+              <a:rPr sz="1125" b="0">
+                <a:solidFill>
+                  <a:srgbClr val="666666"/>
+                </a:solidFill>
+                <a:latin typeface="Inter"/>
+              </a:rPr>
+              <a:t>Zero abstractions to design. Install ASO, configure workload identity, start provisioning.</a:t>
+            </a:r>
+          </a:p>
+        </p:txBody>
+      </p:sp>
+      <p:sp>
+        <p:nvSpPr>
+          <p:cNvPr id="15" name="Rectangle 14"/>
+          <p:cNvSpPr/>
+          <p:nvPr/>
+        </p:nvSpPr>
+        <p:spPr>
+          <a:xfrm>
+            <a:off x="1143000" y="5810249"/>
+            <a:ext cx="16002000" cy="800100"/>
+          </a:xfrm>
+          <a:prstGeom prst="rect">
+            <a:avLst/>
+          </a:prstGeom>
+          <a:solidFill>
+            <a:srgbClr val="FFFFFF"/>
+          </a:solidFill>
+          <a:ln w="9525">
+            <a:solidFill>
+              <a:srgbClr val="F0F0F0"/>
+            </a:solidFill>
+          </a:ln>
+        </p:spPr>
+        <p:style>
+          <a:lnRef idx="1">
+            <a:schemeClr val="accent1"/>
+          </a:lnRef>
+          <a:fillRef idx="3">
+            <a:schemeClr val="accent1"/>
+          </a:fillRef>
+          <a:effectRef idx="2">
+            <a:schemeClr val="accent1"/>
+          </a:effectRef>
+          <a:fontRef idx="minor">
+            <a:schemeClr val="lt1"/>
+          </a:fontRef>
+        </p:style>
+        <p:txBody>
+          <a:bodyPr rtlCol="0" anchor="ctr"/>
+          <a:lstStyle/>
+          <a:p>
+            <a:pPr algn="ctr"/>
+          </a:p>
+        </p:txBody>
+      </p:sp>
+      <p:sp>
+        <p:nvSpPr>
+          <p:cNvPr id="16" name="Rectangle 15"/>
+          <p:cNvSpPr/>
+          <p:nvPr/>
+        </p:nvSpPr>
+        <p:spPr>
+          <a:xfrm>
+            <a:off x="1371600" y="6038849"/>
+            <a:ext cx="342900" cy="342900"/>
+          </a:xfrm>
+          <a:prstGeom prst="rect">
+            <a:avLst/>
+          </a:prstGeom>
+          <a:solidFill>
+            <a:srgbClr val="0078D4"/>
+          </a:solidFill>
+          <a:ln>
+            <a:noFill/>
+          </a:ln>
+        </p:spPr>
+        <p:style>
+          <a:lnRef idx="1">
+            <a:schemeClr val="accent1"/>
+          </a:lnRef>
+          <a:fillRef idx="3">
+            <a:schemeClr val="accent1"/>
+          </a:fillRef>
+          <a:effectRef idx="2">
+            <a:schemeClr val="accent1"/>
+          </a:effectRef>
+          <a:fontRef idx="minor">
+            <a:schemeClr val="lt1"/>
+          </a:fontRef>
+        </p:style>
+        <p:txBody>
+          <a:bodyPr rtlCol="0" anchor="ctr"/>
+          <a:lstStyle/>
+          <a:p>
+            <a:pPr algn="ctr"/>
+          </a:p>
+        </p:txBody>
+      </p:sp>
+      <p:sp>
+        <p:nvSpPr>
+          <p:cNvPr id="17" name="TextBox 16"/>
+          <p:cNvSpPr txBox="1"/>
+          <p:nvPr/>
+        </p:nvSpPr>
+        <p:spPr>
+          <a:xfrm>
+            <a:off x="1384935" y="6040755"/>
+            <a:ext cx="152400" cy="190499"/>
+          </a:xfrm>
+          <a:prstGeom prst="rect">
+            <a:avLst/>
+          </a:prstGeom>
+          <a:noFill/>
+        </p:spPr>
+        <p:txBody>
+          <a:bodyPr wrap="none"/>
+          <a:lstStyle/>
+          <a:p>
+            <a:pPr algn="l">
+              <a:spcBef>
+                <a:spcPts val="0"/>
+              </a:spcBef>
+              <a:spcAft>
+                <a:spcPts val="0"/>
+              </a:spcAft>
+            </a:pPr>
+            <a:r>
+              <a:rPr sz="1200" b="1">
+                <a:solidFill>
+                  <a:srgbClr val="FFFFFF"/>
+                </a:solidFill>
+                <a:latin typeface="Inter Bold"/>
+              </a:rPr>
+              <a:t>2</a:t>
+            </a:r>
+          </a:p>
+        </p:txBody>
+      </p:sp>
+      <p:sp>
+        <p:nvSpPr>
+          <p:cNvPr id="18" name="TextBox 17"/>
+          <p:cNvSpPr txBox="1"/>
+          <p:nvPr/>
+        </p:nvSpPr>
+        <p:spPr>
+          <a:xfrm>
+            <a:off x="1813560" y="5907405"/>
+            <a:ext cx="13906499" cy="209550"/>
+          </a:xfrm>
+          <a:prstGeom prst="rect">
+            <a:avLst/>
+          </a:prstGeom>
+          <a:noFill/>
+        </p:spPr>
+        <p:txBody>
+          <a:bodyPr wrap="none"/>
+          <a:lstStyle/>
+          <a:p>
+            <a:pPr algn="l">
+              <a:spcBef>
+                <a:spcPts val="0"/>
+              </a:spcBef>
+              <a:spcAft>
+                <a:spcPts val="0"/>
+              </a:spcAft>
+            </a:pPr>
+            <a:r>
+              <a:rPr sz="1350" b="1">
+                <a:solidFill>
+                  <a:srgbClr val="000000"/>
+                </a:solidFill>
+                <a:latin typeface="Inter ExtraBold"/>
+              </a:rPr>
+              <a:t>TRANSPARENT</a:t>
+            </a:r>
+          </a:p>
+        </p:txBody>
+      </p:sp>
+      <p:sp>
+        <p:nvSpPr>
+          <p:cNvPr id="19" name="TextBox 18"/>
+          <p:cNvSpPr txBox="1"/>
+          <p:nvPr/>
+        </p:nvSpPr>
+        <p:spPr>
+          <a:xfrm>
+            <a:off x="1813560" y="6202680"/>
+            <a:ext cx="13906499" cy="304800"/>
+          </a:xfrm>
+          <a:prstGeom prst="rect">
+            <a:avLst/>
+          </a:prstGeom>
+          <a:noFill/>
+        </p:spPr>
+        <p:txBody>
+          <a:bodyPr wrap="square"/>
+          <a:lstStyle/>
+          <a:p>
+            <a:pPr algn="l">
+              <a:spcBef>
+                <a:spcPts val="0"/>
+              </a:spcBef>
+              <a:spcAft>
+                <a:spcPts val="0"/>
+              </a:spcAft>
+            </a:pPr>
+            <a:r>
+              <a:rPr sz="1125" b="0">
+                <a:solidFill>
+                  <a:srgbClr val="666666"/>
+                </a:solidFill>
+                <a:latin typeface="Inter"/>
+              </a:rPr>
+              <a:t>Developers see Azure resource types directly. A feature for Azure-native teams; a limitation when you want to hide the cloud layer.</a:t>
+            </a:r>
+          </a:p>
+        </p:txBody>
+      </p:sp>
+      <p:sp>
+        <p:nvSpPr>
+          <p:cNvPr id="20" name="Rectangle 19"/>
+          <p:cNvSpPr/>
+          <p:nvPr/>
+        </p:nvSpPr>
+        <p:spPr>
+          <a:xfrm>
+            <a:off x="1143000" y="6686550"/>
+            <a:ext cx="16002000" cy="800100"/>
+          </a:xfrm>
+          <a:prstGeom prst="rect">
+            <a:avLst/>
+          </a:prstGeom>
+          <a:solidFill>
+            <a:srgbClr val="F8F8F8"/>
+          </a:solidFill>
+          <a:ln>
+            <a:noFill/>
+          </a:ln>
+        </p:spPr>
+        <p:style>
+          <a:lnRef idx="1">
+            <a:schemeClr val="accent1"/>
+          </a:lnRef>
+          <a:fillRef idx="3">
+            <a:schemeClr val="accent1"/>
+          </a:fillRef>
+          <a:effectRef idx="2">
+            <a:schemeClr val="accent1"/>
+          </a:effectRef>
+          <a:fontRef idx="minor">
+            <a:schemeClr val="lt1"/>
+          </a:fontRef>
+        </p:style>
+        <p:txBody>
+          <a:bodyPr rtlCol="0" anchor="ctr"/>
+          <a:lstStyle/>
+          <a:p>
+            <a:pPr algn="ctr"/>
+          </a:p>
+        </p:txBody>
+      </p:sp>
+      <p:sp>
+        <p:nvSpPr>
+          <p:cNvPr id="21" name="Rectangle 20"/>
+          <p:cNvSpPr/>
+          <p:nvPr/>
+        </p:nvSpPr>
+        <p:spPr>
+          <a:xfrm>
+            <a:off x="1371600" y="6915150"/>
+            <a:ext cx="342900" cy="342900"/>
+          </a:xfrm>
+          <a:prstGeom prst="rect">
+            <a:avLst/>
+          </a:prstGeom>
+          <a:solidFill>
+            <a:srgbClr val="0078D4"/>
+          </a:solidFill>
+          <a:ln>
+            <a:noFill/>
+          </a:ln>
+        </p:spPr>
+        <p:style>
+          <a:lnRef idx="1">
+            <a:schemeClr val="accent1"/>
+          </a:lnRef>
+          <a:fillRef idx="3">
+            <a:schemeClr val="accent1"/>
+          </a:fillRef>
+          <a:effectRef idx="2">
+            <a:schemeClr val="accent1"/>
+          </a:effectRef>
+          <a:fontRef idx="minor">
+            <a:schemeClr val="lt1"/>
+          </a:fontRef>
+        </p:style>
+        <p:txBody>
+          <a:bodyPr rtlCol="0" anchor="ctr"/>
+          <a:lstStyle/>
+          <a:p>
+            <a:pPr algn="ctr"/>
+          </a:p>
+        </p:txBody>
+      </p:sp>
+      <p:sp>
+        <p:nvSpPr>
+          <p:cNvPr id="22" name="TextBox 21"/>
+          <p:cNvSpPr txBox="1"/>
+          <p:nvPr/>
+        </p:nvSpPr>
+        <p:spPr>
+          <a:xfrm>
+            <a:off x="1384935" y="6917055"/>
+            <a:ext cx="152400" cy="190499"/>
+          </a:xfrm>
+          <a:prstGeom prst="rect">
+            <a:avLst/>
+          </a:prstGeom>
+          <a:noFill/>
+        </p:spPr>
+        <p:txBody>
+          <a:bodyPr wrap="none"/>
+          <a:lstStyle/>
+          <a:p>
+            <a:pPr algn="l">
+              <a:spcBef>
+                <a:spcPts val="0"/>
+              </a:spcBef>
+              <a:spcAft>
+                <a:spcPts val="0"/>
+              </a:spcAft>
+            </a:pPr>
+            <a:r>
+              <a:rPr sz="1200" b="1">
+                <a:solidFill>
+                  <a:srgbClr val="FFFFFF"/>
+                </a:solidFill>
+                <a:latin typeface="Inter Bold"/>
+              </a:rPr>
+              <a:t>3</a:t>
+            </a:r>
+          </a:p>
+        </p:txBody>
+      </p:sp>
+      <p:sp>
+        <p:nvSpPr>
+          <p:cNvPr id="23" name="TextBox 22"/>
+          <p:cNvSpPr txBox="1"/>
+          <p:nvPr/>
+        </p:nvSpPr>
+        <p:spPr>
+          <a:xfrm>
+            <a:off x="1813560" y="6783705"/>
+            <a:ext cx="13906499" cy="209550"/>
+          </a:xfrm>
+          <a:prstGeom prst="rect">
+            <a:avLst/>
+          </a:prstGeom>
+          <a:noFill/>
+        </p:spPr>
+        <p:txBody>
+          <a:bodyPr wrap="none"/>
+          <a:lstStyle/>
+          <a:p>
+            <a:pPr algn="l">
+              <a:spcBef>
+                <a:spcPts val="0"/>
+              </a:spcBef>
+              <a:spcAft>
+                <a:spcPts val="0"/>
+              </a:spcAft>
+            </a:pPr>
+            <a:r>
+              <a:rPr sz="1350" b="1">
+                <a:solidFill>
+                  <a:srgbClr val="000000"/>
+                </a:solidFill>
+                <a:latin typeface="Inter ExtraBold"/>
+              </a:rPr>
+              <a:t>COMPOSABLE</a:t>
+            </a:r>
+          </a:p>
+        </p:txBody>
+      </p:sp>
+      <p:sp>
+        <p:nvSpPr>
+          <p:cNvPr id="24" name="TextBox 23"/>
+          <p:cNvSpPr txBox="1"/>
+          <p:nvPr/>
+        </p:nvSpPr>
+        <p:spPr>
+          <a:xfrm>
+            <a:off x="1813560" y="7078980"/>
+            <a:ext cx="13906499" cy="304800"/>
+          </a:xfrm>
+          <a:prstGeom prst="rect">
+            <a:avLst/>
+          </a:prstGeom>
+          <a:noFill/>
+        </p:spPr>
+        <p:txBody>
+          <a:bodyPr wrap="square"/>
+          <a:lstStyle/>
+          <a:p>
+            <a:pPr algn="l">
+              <a:spcBef>
+                <a:spcPts val="0"/>
+              </a:spcBef>
+              <a:spcAft>
+                <a:spcPts val="0"/>
+              </a:spcAft>
+            </a:pPr>
+            <a:r>
+              <a:rPr sz="1125" b="0">
+                <a:solidFill>
+                  <a:srgbClr val="666666"/>
+                </a:solidFill>
+                <a:latin typeface="Inter"/>
+              </a:rPr>
+              <a:t>Pairs naturally with KRO for higher-level developer APIs. ASO handles the Azure layer; KRO composes the experience.</a:t>
+            </a:r>
+          </a:p>
+        </p:txBody>
+      </p:sp>
+      <p:sp>
+        <p:nvSpPr>
+          <p:cNvPr id="25" name="Rectangle 24"/>
+          <p:cNvSpPr/>
+          <p:nvPr/>
+        </p:nvSpPr>
+        <p:spPr>
+          <a:xfrm>
+            <a:off x="1143000" y="8943975"/>
+            <a:ext cx="16002000" cy="390525"/>
+          </a:xfrm>
+          <a:prstGeom prst="rect">
+            <a:avLst/>
+          </a:prstGeom>
+          <a:solidFill>
+            <a:srgbClr val="0D0D0D"/>
+          </a:solidFill>
+          <a:ln>
+            <a:noFill/>
+          </a:ln>
+        </p:spPr>
+        <p:style>
+          <a:lnRef idx="1">
+            <a:schemeClr val="accent1"/>
+          </a:lnRef>
+          <a:fillRef idx="3">
+            <a:schemeClr val="accent1"/>
+          </a:fillRef>
+          <a:effectRef idx="2">
+            <a:schemeClr val="accent1"/>
+          </a:effectRef>
+          <a:fontRef idx="minor">
+            <a:schemeClr val="lt1"/>
+          </a:fontRef>
+        </p:style>
+        <p:txBody>
+          <a:bodyPr rtlCol="0" anchor="ctr"/>
+          <a:lstStyle/>
+          <a:p>
+            <a:pPr algn="ctr"/>
+          </a:p>
+        </p:txBody>
+      </p:sp>
+      <p:sp>
+        <p:nvSpPr>
+          <p:cNvPr id="26" name="TextBox 25"/>
+          <p:cNvSpPr txBox="1"/>
+          <p:nvPr/>
+        </p:nvSpPr>
+        <p:spPr>
+          <a:xfrm>
+            <a:off x="1280160" y="8964930"/>
+            <a:ext cx="3486150" cy="161924"/>
+          </a:xfrm>
+          <a:prstGeom prst="rect">
+            <a:avLst/>
+          </a:prstGeom>
+          <a:noFill/>
+        </p:spPr>
+        <p:txBody>
+          <a:bodyPr wrap="none"/>
+          <a:lstStyle/>
+          <a:p>
+            <a:pPr algn="l">
+              <a:spcBef>
+                <a:spcPts val="0"/>
+              </a:spcBef>
+              <a:spcAft>
+                <a:spcPts val="0"/>
+              </a:spcAft>
+            </a:pPr>
+            <a:r>
+              <a:rPr sz="1050" b="1" spc="150">
+                <a:solidFill>
+                  <a:srgbClr val="FFFFFF"/>
+                </a:solidFill>
+                <a:latin typeface="Inter Bold"/>
+              </a:rPr>
+              <a:t>WANT CLOUD-AGNOSTIC ABSTRACTIONS?</a:t>
+            </a:r>
+          </a:p>
+        </p:txBody>
+      </p:sp>
+      <p:sp>
+        <p:nvSpPr>
+          <p:cNvPr id="27" name="TextBox 26"/>
+          <p:cNvSpPr txBox="1"/>
+          <p:nvPr/>
+        </p:nvSpPr>
+        <p:spPr>
+          <a:xfrm>
+            <a:off x="4918710" y="8964930"/>
+            <a:ext cx="2857500" cy="161924"/>
+          </a:xfrm>
+          <a:prstGeom prst="rect">
+            <a:avLst/>
+          </a:prstGeom>
+          <a:noFill/>
+        </p:spPr>
+        <p:txBody>
+          <a:bodyPr wrap="none"/>
+          <a:lstStyle/>
+          <a:p>
+            <a:pPr algn="l">
+              <a:spcBef>
+                <a:spcPts val="0"/>
+              </a:spcBef>
+              <a:spcAft>
+                <a:spcPts val="0"/>
+              </a:spcAft>
+            </a:pPr>
+            <a:r>
+              <a:rPr sz="1050" b="0" spc="75">
+                <a:solidFill>
+                  <a:srgbClr val="666666"/>
+                </a:solidFill>
+                <a:latin typeface="Inter SemiBold"/>
+              </a:rPr>
+              <a:t>→  CROSSPLANE IS NEXT</a:t>
+            </a:r>
+          </a:p>
+        </p:txBody>
+      </p:sp>
+    </p:spTree>
+  </p:cSld>
+  <p:clrMapOvr>
+    <a:masterClrMapping/>
+  </p:clrMapOvr>
+</p:sld>
+</file>
+
+<file path=ppt/slides/slide33.xml><?xml version="1.0" encoding="utf-8"?>
+<p:sld xmlns:a="http://schemas.openxmlformats.org/drawingml/2006/main" xmlns:p="http://schemas.openxmlformats.org/presentationml/2006/main" xmlns:r="http://schemas.openxmlformats.org/officeDocument/2006/relationships">
+  <p:cSld>
+    <p:spTree>
+      <p:nvGrpSpPr>
+        <p:cNvPr id="1" name=""/>
+        <p:cNvGrpSpPr/>
+        <p:nvPr/>
+      </p:nvGrpSpPr>
+      <p:grpSpPr/>
+      <p:sp>
+        <p:nvSpPr>
+          <p:cNvPr id="2" name="Rectangle 1"/>
+          <p:cNvSpPr/>
+          <p:nvPr/>
+        </p:nvSpPr>
+        <p:spPr>
+          <a:xfrm>
+            <a:off x="0" y="0"/>
+            <a:ext cx="18288000" cy="10287000"/>
+          </a:xfrm>
+          <a:prstGeom prst="rect">
+            <a:avLst/>
+          </a:prstGeom>
+          <a:solidFill>
+            <a:srgbClr val="000000"/>
+          </a:solidFill>
+          <a:ln>
+            <a:noFill/>
+          </a:ln>
+        </p:spPr>
+        <p:style>
+          <a:lnRef idx="1">
+            <a:schemeClr val="accent1"/>
+          </a:lnRef>
+          <a:fillRef idx="3">
+            <a:schemeClr val="accent1"/>
+          </a:fillRef>
+          <a:effectRef idx="2">
+            <a:schemeClr val="accent1"/>
+          </a:effectRef>
+          <a:fontRef idx="minor">
+            <a:schemeClr val="lt1"/>
+          </a:fontRef>
+        </p:style>
+        <p:txBody>
+          <a:bodyPr rtlCol="0" anchor="ctr"/>
+          <a:lstStyle/>
+          <a:p>
+            <a:pPr algn="ctr"/>
+          </a:p>
+        </p:txBody>
+      </p:sp>
+      <p:sp>
+        <p:nvSpPr>
+          <p:cNvPr id="3" name="Rectangle 2"/>
+          <p:cNvSpPr/>
+          <p:nvPr/>
+        </p:nvSpPr>
+        <p:spPr>
+          <a:xfrm>
+            <a:off x="0" y="0"/>
+            <a:ext cx="76200" cy="10287000"/>
+          </a:xfrm>
+          <a:prstGeom prst="rect">
+            <a:avLst/>
+          </a:prstGeom>
+          <a:solidFill>
+            <a:srgbClr val="FFFFFF"/>
+          </a:solidFill>
+          <a:ln>
+            <a:noFill/>
+          </a:ln>
+        </p:spPr>
+        <p:style>
+          <a:lnRef idx="1">
+            <a:schemeClr val="accent1"/>
+          </a:lnRef>
+          <a:fillRef idx="3">
+            <a:schemeClr val="accent1"/>
+          </a:fillRef>
+          <a:effectRef idx="2">
+            <a:schemeClr val="accent1"/>
+          </a:effectRef>
+          <a:fontRef idx="minor">
+            <a:schemeClr val="lt1"/>
+          </a:fontRef>
+        </p:style>
+        <p:txBody>
+          <a:bodyPr rtlCol="0" anchor="ctr"/>
+          <a:lstStyle/>
+          <a:p>
+            <a:pPr algn="ctr"/>
+          </a:p>
+        </p:txBody>
+      </p:sp>
+      <p:sp>
+        <p:nvSpPr>
+          <p:cNvPr id="4" name="Rectangle 3"/>
+          <p:cNvSpPr/>
+          <p:nvPr/>
+        </p:nvSpPr>
+        <p:spPr>
+          <a:xfrm>
+            <a:off x="16383000" y="10096500"/>
+            <a:ext cx="1905000" cy="76200"/>
+          </a:xfrm>
+          <a:prstGeom prst="rect">
+            <a:avLst/>
+          </a:prstGeom>
+          <a:solidFill>
+            <a:srgbClr val="FFFFFF"/>
+          </a:solidFill>
+          <a:ln>
+            <a:noFill/>
+          </a:ln>
+        </p:spPr>
+        <p:style>
+          <a:lnRef idx="1">
+            <a:schemeClr val="accent1"/>
+          </a:lnRef>
+          <a:fillRef idx="3">
+            <a:schemeClr val="accent1"/>
+          </a:fillRef>
+          <a:effectRef idx="2">
+            <a:schemeClr val="accent1"/>
+          </a:effectRef>
+          <a:fontRef idx="minor">
+            <a:schemeClr val="lt1"/>
+          </a:fontRef>
+        </p:style>
+        <p:txBody>
+          <a:bodyPr rtlCol="0" anchor="ctr"/>
+          <a:lstStyle/>
+          <a:p>
+            <a:pPr algn="ctr"/>
+          </a:p>
+        </p:txBody>
+      </p:sp>
+      <p:sp>
+        <p:nvSpPr>
+          <p:cNvPr id="5" name="Oval 4"/>
+          <p:cNvSpPr/>
+          <p:nvPr/>
+        </p:nvSpPr>
+        <p:spPr>
+          <a:xfrm>
+            <a:off x="16954500" y="1523999"/>
+            <a:ext cx="133350" cy="133350"/>
+          </a:xfrm>
+          <a:prstGeom prst="ellipse">
+            <a:avLst/>
+          </a:prstGeom>
+          <a:solidFill>
+            <a:srgbClr val="FFFFFF"/>
+          </a:solidFill>
+          <a:ln>
+            <a:noFill/>
+          </a:ln>
+        </p:spPr>
+        <p:style>
+          <a:lnRef idx="1">
+            <a:schemeClr val="accent1"/>
+          </a:lnRef>
+          <a:fillRef idx="3">
+            <a:schemeClr val="accent1"/>
+          </a:fillRef>
+          <a:effectRef idx="2">
+            <a:schemeClr val="accent1"/>
+          </a:effectRef>
+          <a:fontRef idx="minor">
+            <a:schemeClr val="lt1"/>
+          </a:fontRef>
+        </p:style>
+        <p:txBody>
+          <a:bodyPr rtlCol="0" anchor="ctr"/>
+          <a:lstStyle/>
+          <a:p>
+            <a:pPr algn="ctr"/>
+          </a:p>
+        </p:txBody>
+      </p:sp>
+      <p:sp>
+        <p:nvSpPr>
+          <p:cNvPr id="6" name="Oval 5"/>
+          <p:cNvSpPr/>
+          <p:nvPr/>
+        </p:nvSpPr>
+        <p:spPr>
+          <a:xfrm>
+            <a:off x="17335500" y="1523999"/>
+            <a:ext cx="133350" cy="133350"/>
+          </a:xfrm>
+          <a:prstGeom prst="ellipse">
+            <a:avLst/>
+          </a:prstGeom>
+          <a:solidFill>
+            <a:srgbClr val="FFFFFF">
+              <a:alpha val="40000"/>
+            </a:srgbClr>
+          </a:solidFill>
+          <a:ln>
+            <a:noFill/>
+          </a:ln>
+        </p:spPr>
+        <p:style>
+          <a:lnRef idx="1">
+            <a:schemeClr val="accent1"/>
+          </a:lnRef>
+          <a:fillRef idx="3">
+            <a:schemeClr val="accent1"/>
+          </a:fillRef>
+          <a:effectRef idx="2">
+            <a:schemeClr val="accent1"/>
+          </a:effectRef>
+          <a:fontRef idx="minor">
+            <a:schemeClr val="lt1"/>
+          </a:fontRef>
+        </p:style>
+        <p:txBody>
+          <a:bodyPr rtlCol="0" anchor="ctr"/>
+          <a:lstStyle/>
+          <a:p>
+            <a:pPr algn="ctr"/>
+          </a:p>
+        </p:txBody>
+      </p:sp>
+      <p:sp>
+        <p:nvSpPr>
+          <p:cNvPr id="7" name="Oval 6"/>
+          <p:cNvSpPr/>
+          <p:nvPr/>
+        </p:nvSpPr>
+        <p:spPr>
+          <a:xfrm>
+            <a:off x="17716500" y="1523999"/>
+            <a:ext cx="133350" cy="133350"/>
+          </a:xfrm>
+          <a:prstGeom prst="ellipse">
+            <a:avLst/>
+          </a:prstGeom>
+          <a:solidFill>
+            <a:srgbClr val="FFFFFF">
+              <a:alpha val="20000"/>
+            </a:srgbClr>
+          </a:solidFill>
+          <a:ln>
+            <a:noFill/>
+          </a:ln>
+        </p:spPr>
+        <p:style>
+          <a:lnRef idx="1">
+            <a:schemeClr val="accent1"/>
+          </a:lnRef>
+          <a:fillRef idx="3">
+            <a:schemeClr val="accent1"/>
+          </a:fillRef>
+          <a:effectRef idx="2">
+            <a:schemeClr val="accent1"/>
+          </a:effectRef>
+          <a:fontRef idx="minor">
+            <a:schemeClr val="lt1"/>
+          </a:fontRef>
+        </p:style>
+        <p:txBody>
+          <a:bodyPr rtlCol="0" anchor="ctr"/>
+          <a:lstStyle/>
+          <a:p>
+            <a:pPr algn="ctr"/>
+          </a:p>
+        </p:txBody>
+      </p:sp>
+      <p:sp>
+        <p:nvSpPr>
+          <p:cNvPr id="8" name="TextBox 7"/>
+          <p:cNvSpPr txBox="1"/>
+          <p:nvPr/>
+        </p:nvSpPr>
+        <p:spPr>
+          <a:xfrm>
+            <a:off x="3147060" y="2049780"/>
+            <a:ext cx="15830550" cy="5762625"/>
+          </a:xfrm>
+          <a:prstGeom prst="rect">
+            <a:avLst/>
+          </a:prstGeom>
+          <a:noFill/>
+        </p:spPr>
+        <p:txBody>
+          <a:bodyPr wrap="none"/>
+          <a:lstStyle/>
+          <a:p>
+            <a:pPr algn="l">
+              <a:spcBef>
+                <a:spcPts val="0"/>
+              </a:spcBef>
+              <a:spcAft>
+                <a:spcPts val="0"/>
+              </a:spcAft>
+            </a:pPr>
+            <a:r>
+              <a:rPr sz="37500" b="1">
+                <a:solidFill>
+                  <a:srgbClr val="FFFFFF">
+                    <a:alpha val="5000"/>
+                  </a:srgbClr>
+                </a:solidFill>
+                <a:latin typeface="Inter Black"/>
+              </a:rPr>
+              <a:t>CROSS</a:t>
+            </a:r>
+          </a:p>
+        </p:txBody>
+      </p:sp>
+      <p:sp>
+        <p:nvSpPr>
+          <p:cNvPr id="9" name="Rectangle 8"/>
+          <p:cNvSpPr/>
+          <p:nvPr/>
+        </p:nvSpPr>
+        <p:spPr>
+          <a:xfrm>
+            <a:off x="1143000" y="1143000"/>
+            <a:ext cx="133350" cy="133350"/>
+          </a:xfrm>
+          <a:prstGeom prst="rect">
+            <a:avLst/>
+          </a:prstGeom>
+          <a:solidFill>
+            <a:srgbClr val="FFFFFF"/>
+          </a:solidFill>
+          <a:ln>
+            <a:noFill/>
+          </a:ln>
+        </p:spPr>
+        <p:style>
+          <a:lnRef idx="1">
+            <a:schemeClr val="accent1"/>
+          </a:lnRef>
+          <a:fillRef idx="3">
+            <a:schemeClr val="accent1"/>
+          </a:fillRef>
+          <a:effectRef idx="2">
+            <a:schemeClr val="accent1"/>
+          </a:effectRef>
+          <a:fontRef idx="minor">
+            <a:schemeClr val="lt1"/>
+          </a:fontRef>
+        </p:style>
+        <p:txBody>
+          <a:bodyPr rtlCol="0" anchor="ctr"/>
+          <a:lstStyle/>
+          <a:p>
+            <a:pPr algn="ctr"/>
+          </a:p>
+        </p:txBody>
+      </p:sp>
+      <p:sp>
+        <p:nvSpPr>
+          <p:cNvPr id="10" name="TextBox 9"/>
+          <p:cNvSpPr txBox="1"/>
+          <p:nvPr/>
+        </p:nvSpPr>
+        <p:spPr>
+          <a:xfrm>
+            <a:off x="1337310" y="1049655"/>
+            <a:ext cx="5715000" cy="228600"/>
+          </a:xfrm>
+          <a:prstGeom prst="rect">
+            <a:avLst/>
+          </a:prstGeom>
+          <a:noFill/>
+        </p:spPr>
+        <p:txBody>
+          <a:bodyPr wrap="none"/>
+          <a:lstStyle/>
+          <a:p>
+            <a:pPr algn="l">
+              <a:spcBef>
+                <a:spcPts val="0"/>
+              </a:spcBef>
+              <a:spcAft>
+                <a:spcPts val="0"/>
+              </a:spcAft>
+            </a:pPr>
+            <a:r>
+              <a:rPr sz="1500" b="0" spc="300">
+                <a:solidFill>
+                  <a:srgbClr val="FFFFFF"/>
+                </a:solidFill>
+                <a:latin typeface="Inter SemiBold"/>
+              </a:rPr>
+              <a:t>07 / CROSSPLANE</a:t>
+            </a:r>
+          </a:p>
+        </p:txBody>
+      </p:sp>
+      <p:sp>
+        <p:nvSpPr>
+          <p:cNvPr id="11" name="TextBox 10"/>
+          <p:cNvSpPr txBox="1"/>
+          <p:nvPr/>
+        </p:nvSpPr>
+        <p:spPr>
+          <a:xfrm>
+            <a:off x="1051560" y="6812280"/>
+            <a:ext cx="16002000" cy="1676400"/>
+          </a:xfrm>
+          <a:prstGeom prst="rect">
+            <a:avLst/>
+          </a:prstGeom>
+          <a:noFill/>
+        </p:spPr>
+        <p:txBody>
+          <a:bodyPr wrap="none"/>
+          <a:lstStyle/>
+          <a:p>
+            <a:pPr algn="l">
+              <a:spcBef>
+                <a:spcPts val="0"/>
+              </a:spcBef>
+              <a:spcAft>
+                <a:spcPts val="0"/>
+              </a:spcAft>
+            </a:pPr>
+            <a:r>
+              <a:rPr sz="15000" b="1">
+                <a:solidFill>
+                  <a:srgbClr val="FFFFFF"/>
+                </a:solidFill>
+                <a:latin typeface="Inter Black"/>
+              </a:rPr>
+              <a:t>CROSSPLANE.</a:t>
+            </a:r>
+          </a:p>
+        </p:txBody>
+      </p:sp>
+      <p:sp>
+        <p:nvSpPr>
+          <p:cNvPr id="12" name="TextBox 11"/>
+          <p:cNvSpPr txBox="1"/>
+          <p:nvPr/>
+        </p:nvSpPr>
+        <p:spPr>
+          <a:xfrm>
+            <a:off x="1051560" y="8564880"/>
+            <a:ext cx="16002000" cy="723900"/>
+          </a:xfrm>
+          <a:prstGeom prst="rect">
+            <a:avLst/>
+          </a:prstGeom>
+          <a:noFill/>
+        </p:spPr>
+        <p:txBody>
+          <a:bodyPr wrap="none"/>
+          <a:lstStyle/>
+          <a:p>
+            <a:pPr algn="l">
+              <a:spcBef>
+                <a:spcPts val="0"/>
+              </a:spcBef>
+              <a:spcAft>
+                <a:spcPts val="0"/>
+              </a:spcAft>
+            </a:pPr>
+            <a:r>
+              <a:rPr sz="6300" b="1">
+                <a:solidFill>
+                  <a:srgbClr val="666666"/>
+                </a:solidFill>
+                <a:latin typeface="Inter Black"/>
+              </a:rPr>
+              <a:t>YOU DESIGN THE API.</a:t>
             </a:r>
           </a:p>
         </p:txBody>

</xml_diff>

<commit_message>
Add S10-01, S10-02, S11-01, S11-02 slides (48 total)
- S10-01: Sovereignty Payoff intro (YOUR API. / YOURS watermark)
- S10-02: AI and the Platform (numbered cards, AI watermark)
- S11-01: The Whole Picture arch slide (3-card stack: Git+Argo → K8s API → Tools)
- S11-02: Closing outro (MAKE YES SAFE. / SAFE watermark)
- Add corner_radius support to add_rect_outlined helper

Co-authored-by: Copilot <223556219+Copilot@users.noreply.github.com>
</commit_message>
<xml_diff>
--- a/presentation.pptx
+++ b/presentation.pptx
@@ -49,6 +49,10 @@
     <p:sldId id="297" r:id="rId48"/>
     <p:sldId id="298" r:id="rId49"/>
     <p:sldId id="299" r:id="rId50"/>
+    <p:sldId id="300" r:id="rId51"/>
+    <p:sldId id="301" r:id="rId52"/>
+    <p:sldId id="302" r:id="rId53"/>
+    <p:sldId id="303" r:id="rId54"/>
   </p:sldIdLst>
   <p:sldSz cx="18288000" cy="10287000" type="screen4x3"/>
   <p:notesSz cx="6858000" cy="9144000"/>
@@ -37749,6 +37753,3175 @@
                 <a:latin typeface="Inter SemiBold"/>
               </a:rPr>
               <a:t>→  START DIRECTLY WITH ASO OR CROSSPLANE</a:t>
+            </a:r>
+          </a:p>
+        </p:txBody>
+      </p:sp>
+    </p:spTree>
+  </p:cSld>
+  <p:clrMapOvr>
+    <a:masterClrMapping/>
+  </p:clrMapOvr>
+</p:sld>
+</file>
+
+<file path=ppt/slides/slide45.xml><?xml version="1.0" encoding="utf-8"?>
+<p:sld xmlns:a="http://schemas.openxmlformats.org/drawingml/2006/main" xmlns:p="http://schemas.openxmlformats.org/presentationml/2006/main" xmlns:r="http://schemas.openxmlformats.org/officeDocument/2006/relationships">
+  <p:cSld>
+    <p:spTree>
+      <p:nvGrpSpPr>
+        <p:cNvPr id="1" name=""/>
+        <p:cNvGrpSpPr/>
+        <p:nvPr/>
+      </p:nvGrpSpPr>
+      <p:grpSpPr/>
+      <p:sp>
+        <p:nvSpPr>
+          <p:cNvPr id="2" name="Rectangle 1"/>
+          <p:cNvSpPr/>
+          <p:nvPr/>
+        </p:nvSpPr>
+        <p:spPr>
+          <a:xfrm>
+            <a:off x="0" y="0"/>
+            <a:ext cx="18288000" cy="10287000"/>
+          </a:xfrm>
+          <a:prstGeom prst="rect">
+            <a:avLst/>
+          </a:prstGeom>
+          <a:solidFill>
+            <a:srgbClr val="000000"/>
+          </a:solidFill>
+          <a:ln>
+            <a:noFill/>
+          </a:ln>
+        </p:spPr>
+        <p:style>
+          <a:lnRef idx="1">
+            <a:schemeClr val="accent1"/>
+          </a:lnRef>
+          <a:fillRef idx="3">
+            <a:schemeClr val="accent1"/>
+          </a:fillRef>
+          <a:effectRef idx="2">
+            <a:schemeClr val="accent1"/>
+          </a:effectRef>
+          <a:fontRef idx="minor">
+            <a:schemeClr val="lt1"/>
+          </a:fontRef>
+        </p:style>
+        <p:txBody>
+          <a:bodyPr rtlCol="0" anchor="ctr"/>
+          <a:lstStyle/>
+          <a:p>
+            <a:pPr algn="ctr"/>
+          </a:p>
+        </p:txBody>
+      </p:sp>
+      <p:sp>
+        <p:nvSpPr>
+          <p:cNvPr id="3" name="Rectangle 2"/>
+          <p:cNvSpPr/>
+          <p:nvPr/>
+        </p:nvSpPr>
+        <p:spPr>
+          <a:xfrm>
+            <a:off x="0" y="0"/>
+            <a:ext cx="76200" cy="10287000"/>
+          </a:xfrm>
+          <a:prstGeom prst="rect">
+            <a:avLst/>
+          </a:prstGeom>
+          <a:solidFill>
+            <a:srgbClr val="FFFFFF"/>
+          </a:solidFill>
+          <a:ln>
+            <a:noFill/>
+          </a:ln>
+        </p:spPr>
+        <p:style>
+          <a:lnRef idx="1">
+            <a:schemeClr val="accent1"/>
+          </a:lnRef>
+          <a:fillRef idx="3">
+            <a:schemeClr val="accent1"/>
+          </a:fillRef>
+          <a:effectRef idx="2">
+            <a:schemeClr val="accent1"/>
+          </a:effectRef>
+          <a:fontRef idx="minor">
+            <a:schemeClr val="lt1"/>
+          </a:fontRef>
+        </p:style>
+        <p:txBody>
+          <a:bodyPr rtlCol="0" anchor="ctr"/>
+          <a:lstStyle/>
+          <a:p>
+            <a:pPr algn="ctr"/>
+          </a:p>
+        </p:txBody>
+      </p:sp>
+      <p:sp>
+        <p:nvSpPr>
+          <p:cNvPr id="4" name="Rectangle 3"/>
+          <p:cNvSpPr/>
+          <p:nvPr/>
+        </p:nvSpPr>
+        <p:spPr>
+          <a:xfrm>
+            <a:off x="16383000" y="10096500"/>
+            <a:ext cx="1905000" cy="76200"/>
+          </a:xfrm>
+          <a:prstGeom prst="rect">
+            <a:avLst/>
+          </a:prstGeom>
+          <a:solidFill>
+            <a:srgbClr val="FFFFFF"/>
+          </a:solidFill>
+          <a:ln>
+            <a:noFill/>
+          </a:ln>
+        </p:spPr>
+        <p:style>
+          <a:lnRef idx="1">
+            <a:schemeClr val="accent1"/>
+          </a:lnRef>
+          <a:fillRef idx="3">
+            <a:schemeClr val="accent1"/>
+          </a:fillRef>
+          <a:effectRef idx="2">
+            <a:schemeClr val="accent1"/>
+          </a:effectRef>
+          <a:fontRef idx="minor">
+            <a:schemeClr val="lt1"/>
+          </a:fontRef>
+        </p:style>
+        <p:txBody>
+          <a:bodyPr rtlCol="0" anchor="ctr"/>
+          <a:lstStyle/>
+          <a:p>
+            <a:pPr algn="ctr"/>
+          </a:p>
+        </p:txBody>
+      </p:sp>
+      <p:sp>
+        <p:nvSpPr>
+          <p:cNvPr id="5" name="Oval 4"/>
+          <p:cNvSpPr/>
+          <p:nvPr/>
+        </p:nvSpPr>
+        <p:spPr>
+          <a:xfrm>
+            <a:off x="16954500" y="1523999"/>
+            <a:ext cx="133350" cy="133350"/>
+          </a:xfrm>
+          <a:prstGeom prst="ellipse">
+            <a:avLst/>
+          </a:prstGeom>
+          <a:solidFill>
+            <a:srgbClr val="FFFFFF"/>
+          </a:solidFill>
+          <a:ln>
+            <a:noFill/>
+          </a:ln>
+        </p:spPr>
+        <p:style>
+          <a:lnRef idx="1">
+            <a:schemeClr val="accent1"/>
+          </a:lnRef>
+          <a:fillRef idx="3">
+            <a:schemeClr val="accent1"/>
+          </a:fillRef>
+          <a:effectRef idx="2">
+            <a:schemeClr val="accent1"/>
+          </a:effectRef>
+          <a:fontRef idx="minor">
+            <a:schemeClr val="lt1"/>
+          </a:fontRef>
+        </p:style>
+        <p:txBody>
+          <a:bodyPr rtlCol="0" anchor="ctr"/>
+          <a:lstStyle/>
+          <a:p>
+            <a:pPr algn="ctr"/>
+          </a:p>
+        </p:txBody>
+      </p:sp>
+      <p:sp>
+        <p:nvSpPr>
+          <p:cNvPr id="6" name="Oval 5"/>
+          <p:cNvSpPr/>
+          <p:nvPr/>
+        </p:nvSpPr>
+        <p:spPr>
+          <a:xfrm>
+            <a:off x="17335500" y="1523999"/>
+            <a:ext cx="133350" cy="133350"/>
+          </a:xfrm>
+          <a:prstGeom prst="ellipse">
+            <a:avLst/>
+          </a:prstGeom>
+          <a:solidFill>
+            <a:srgbClr val="FFFFFF">
+              <a:alpha val="40000"/>
+            </a:srgbClr>
+          </a:solidFill>
+          <a:ln>
+            <a:noFill/>
+          </a:ln>
+        </p:spPr>
+        <p:style>
+          <a:lnRef idx="1">
+            <a:schemeClr val="accent1"/>
+          </a:lnRef>
+          <a:fillRef idx="3">
+            <a:schemeClr val="accent1"/>
+          </a:fillRef>
+          <a:effectRef idx="2">
+            <a:schemeClr val="accent1"/>
+          </a:effectRef>
+          <a:fontRef idx="minor">
+            <a:schemeClr val="lt1"/>
+          </a:fontRef>
+        </p:style>
+        <p:txBody>
+          <a:bodyPr rtlCol="0" anchor="ctr"/>
+          <a:lstStyle/>
+          <a:p>
+            <a:pPr algn="ctr"/>
+          </a:p>
+        </p:txBody>
+      </p:sp>
+      <p:sp>
+        <p:nvSpPr>
+          <p:cNvPr id="7" name="Oval 6"/>
+          <p:cNvSpPr/>
+          <p:nvPr/>
+        </p:nvSpPr>
+        <p:spPr>
+          <a:xfrm>
+            <a:off x="17716500" y="1523999"/>
+            <a:ext cx="133350" cy="133350"/>
+          </a:xfrm>
+          <a:prstGeom prst="ellipse">
+            <a:avLst/>
+          </a:prstGeom>
+          <a:solidFill>
+            <a:srgbClr val="FFFFFF">
+              <a:alpha val="20000"/>
+            </a:srgbClr>
+          </a:solidFill>
+          <a:ln>
+            <a:noFill/>
+          </a:ln>
+        </p:spPr>
+        <p:style>
+          <a:lnRef idx="1">
+            <a:schemeClr val="accent1"/>
+          </a:lnRef>
+          <a:fillRef idx="3">
+            <a:schemeClr val="accent1"/>
+          </a:fillRef>
+          <a:effectRef idx="2">
+            <a:schemeClr val="accent1"/>
+          </a:effectRef>
+          <a:fontRef idx="minor">
+            <a:schemeClr val="lt1"/>
+          </a:fontRef>
+        </p:style>
+        <p:txBody>
+          <a:bodyPr rtlCol="0" anchor="ctr"/>
+          <a:lstStyle/>
+          <a:p>
+            <a:pPr algn="ctr"/>
+          </a:p>
+        </p:txBody>
+      </p:sp>
+      <p:sp>
+        <p:nvSpPr>
+          <p:cNvPr id="8" name="TextBox 7"/>
+          <p:cNvSpPr txBox="1"/>
+          <p:nvPr/>
+        </p:nvSpPr>
+        <p:spPr>
+          <a:xfrm>
+            <a:off x="2575560" y="2049780"/>
+            <a:ext cx="13334999" cy="6095999"/>
+          </a:xfrm>
+          <a:prstGeom prst="rect">
+            <a:avLst/>
+          </a:prstGeom>
+          <a:noFill/>
+        </p:spPr>
+        <p:txBody>
+          <a:bodyPr wrap="none"/>
+          <a:lstStyle/>
+          <a:p>
+            <a:pPr algn="l">
+              <a:spcBef>
+                <a:spcPts val="0"/>
+              </a:spcBef>
+              <a:spcAft>
+                <a:spcPts val="0"/>
+              </a:spcAft>
+            </a:pPr>
+            <a:r>
+              <a:rPr sz="37500" b="1">
+                <a:solidFill>
+                  <a:srgbClr val="FFFFFF">
+                    <a:alpha val="5000"/>
+                  </a:srgbClr>
+                </a:solidFill>
+                <a:latin typeface="Inter Black"/>
+              </a:rPr>
+              <a:t>YOURS</a:t>
+            </a:r>
+          </a:p>
+        </p:txBody>
+      </p:sp>
+      <p:sp>
+        <p:nvSpPr>
+          <p:cNvPr id="9" name="Rectangle 8"/>
+          <p:cNvSpPr/>
+          <p:nvPr/>
+        </p:nvSpPr>
+        <p:spPr>
+          <a:xfrm>
+            <a:off x="1143000" y="1143000"/>
+            <a:ext cx="133350" cy="133350"/>
+          </a:xfrm>
+          <a:prstGeom prst="rect">
+            <a:avLst/>
+          </a:prstGeom>
+          <a:solidFill>
+            <a:srgbClr val="FFFFFF"/>
+          </a:solidFill>
+          <a:ln>
+            <a:noFill/>
+          </a:ln>
+        </p:spPr>
+        <p:style>
+          <a:lnRef idx="1">
+            <a:schemeClr val="accent1"/>
+          </a:lnRef>
+          <a:fillRef idx="3">
+            <a:schemeClr val="accent1"/>
+          </a:fillRef>
+          <a:effectRef idx="2">
+            <a:schemeClr val="accent1"/>
+          </a:effectRef>
+          <a:fontRef idx="minor">
+            <a:schemeClr val="lt1"/>
+          </a:fontRef>
+        </p:style>
+        <p:txBody>
+          <a:bodyPr rtlCol="0" anchor="ctr"/>
+          <a:lstStyle/>
+          <a:p>
+            <a:pPr algn="ctr"/>
+          </a:p>
+        </p:txBody>
+      </p:sp>
+      <p:sp>
+        <p:nvSpPr>
+          <p:cNvPr id="10" name="TextBox 9"/>
+          <p:cNvSpPr txBox="1"/>
+          <p:nvPr/>
+        </p:nvSpPr>
+        <p:spPr>
+          <a:xfrm>
+            <a:off x="1337310" y="1049655"/>
+            <a:ext cx="6667499" cy="228600"/>
+          </a:xfrm>
+          <a:prstGeom prst="rect">
+            <a:avLst/>
+          </a:prstGeom>
+          <a:noFill/>
+        </p:spPr>
+        <p:txBody>
+          <a:bodyPr wrap="none"/>
+          <a:lstStyle/>
+          <a:p>
+            <a:pPr algn="l">
+              <a:spcBef>
+                <a:spcPts val="0"/>
+              </a:spcBef>
+              <a:spcAft>
+                <a:spcPts val="0"/>
+              </a:spcAft>
+            </a:pPr>
+            <a:r>
+              <a:rPr sz="1500" b="0" spc="300">
+                <a:solidFill>
+                  <a:srgbClr val="FFFFFF"/>
+                </a:solidFill>
+                <a:latin typeface="Inter SemiBold"/>
+              </a:rPr>
+              <a:t>10 / SOVEREIGNTY</a:t>
+            </a:r>
+          </a:p>
+        </p:txBody>
+      </p:sp>
+      <p:sp>
+        <p:nvSpPr>
+          <p:cNvPr id="11" name="TextBox 10"/>
+          <p:cNvSpPr txBox="1"/>
+          <p:nvPr/>
+        </p:nvSpPr>
+        <p:spPr>
+          <a:xfrm>
+            <a:off x="1051560" y="7155180"/>
+            <a:ext cx="16002000" cy="1504950"/>
+          </a:xfrm>
+          <a:prstGeom prst="rect">
+            <a:avLst/>
+          </a:prstGeom>
+          <a:noFill/>
+        </p:spPr>
+        <p:txBody>
+          <a:bodyPr wrap="none"/>
+          <a:lstStyle/>
+          <a:p>
+            <a:pPr algn="l">
+              <a:spcBef>
+                <a:spcPts val="0"/>
+              </a:spcBef>
+              <a:spcAft>
+                <a:spcPts val="0"/>
+              </a:spcAft>
+            </a:pPr>
+            <a:r>
+              <a:rPr sz="13500" b="1">
+                <a:solidFill>
+                  <a:srgbClr val="FFFFFF"/>
+                </a:solidFill>
+                <a:latin typeface="Inter Black"/>
+              </a:rPr>
+              <a:t>YOUR API.</a:t>
+            </a:r>
+          </a:p>
+        </p:txBody>
+      </p:sp>
+      <p:sp>
+        <p:nvSpPr>
+          <p:cNvPr id="12" name="TextBox 11"/>
+          <p:cNvSpPr txBox="1"/>
+          <p:nvPr/>
+        </p:nvSpPr>
+        <p:spPr>
+          <a:xfrm>
+            <a:off x="1051560" y="8736330"/>
+            <a:ext cx="16002000" cy="552450"/>
+          </a:xfrm>
+          <a:prstGeom prst="rect">
+            <a:avLst/>
+          </a:prstGeom>
+          <a:noFill/>
+        </p:spPr>
+        <p:txBody>
+          <a:bodyPr wrap="none"/>
+          <a:lstStyle/>
+          <a:p>
+            <a:pPr algn="l">
+              <a:spcBef>
+                <a:spcPts val="0"/>
+              </a:spcBef>
+              <a:spcAft>
+                <a:spcPts val="0"/>
+              </a:spcAft>
+            </a:pPr>
+            <a:r>
+              <a:rPr sz="4800" b="1">
+                <a:solidFill>
+                  <a:srgbClr val="666666"/>
+                </a:solidFill>
+                <a:latin typeface="Inter Black"/>
+              </a:rPr>
+              <a:t>YOUR STATE. YOUR AUDIT TRAIL.</a:t>
+            </a:r>
+          </a:p>
+        </p:txBody>
+      </p:sp>
+    </p:spTree>
+  </p:cSld>
+  <p:clrMapOvr>
+    <a:masterClrMapping/>
+  </p:clrMapOvr>
+</p:sld>
+</file>
+
+<file path=ppt/slides/slide46.xml><?xml version="1.0" encoding="utf-8"?>
+<p:sld xmlns:a="http://schemas.openxmlformats.org/drawingml/2006/main" xmlns:p="http://schemas.openxmlformats.org/presentationml/2006/main" xmlns:r="http://schemas.openxmlformats.org/officeDocument/2006/relationships">
+  <p:cSld>
+    <p:spTree>
+      <p:nvGrpSpPr>
+        <p:cNvPr id="1" name=""/>
+        <p:cNvGrpSpPr/>
+        <p:nvPr/>
+      </p:nvGrpSpPr>
+      <p:grpSpPr/>
+      <p:sp>
+        <p:nvSpPr>
+          <p:cNvPr id="2" name="Rectangle 1"/>
+          <p:cNvSpPr/>
+          <p:nvPr/>
+        </p:nvSpPr>
+        <p:spPr>
+          <a:xfrm>
+            <a:off x="0" y="0"/>
+            <a:ext cx="18288000" cy="10287000"/>
+          </a:xfrm>
+          <a:prstGeom prst="rect">
+            <a:avLst/>
+          </a:prstGeom>
+          <a:solidFill>
+            <a:srgbClr val="FFFFFF"/>
+          </a:solidFill>
+          <a:ln>
+            <a:noFill/>
+          </a:ln>
+        </p:spPr>
+        <p:style>
+          <a:lnRef idx="1">
+            <a:schemeClr val="accent1"/>
+          </a:lnRef>
+          <a:fillRef idx="3">
+            <a:schemeClr val="accent1"/>
+          </a:fillRef>
+          <a:effectRef idx="2">
+            <a:schemeClr val="accent1"/>
+          </a:effectRef>
+          <a:fontRef idx="minor">
+            <a:schemeClr val="lt1"/>
+          </a:fontRef>
+        </p:style>
+        <p:txBody>
+          <a:bodyPr rtlCol="0" anchor="ctr"/>
+          <a:lstStyle/>
+          <a:p>
+            <a:pPr algn="ctr"/>
+          </a:p>
+        </p:txBody>
+      </p:sp>
+      <p:sp>
+        <p:nvSpPr>
+          <p:cNvPr id="3" name="Rectangle 2"/>
+          <p:cNvSpPr/>
+          <p:nvPr/>
+        </p:nvSpPr>
+        <p:spPr>
+          <a:xfrm>
+            <a:off x="0" y="0"/>
+            <a:ext cx="76200" cy="10287000"/>
+          </a:xfrm>
+          <a:prstGeom prst="rect">
+            <a:avLst/>
+          </a:prstGeom>
+          <a:solidFill>
+            <a:srgbClr val="000000"/>
+          </a:solidFill>
+          <a:ln>
+            <a:noFill/>
+          </a:ln>
+        </p:spPr>
+        <p:style>
+          <a:lnRef idx="1">
+            <a:schemeClr val="accent1"/>
+          </a:lnRef>
+          <a:fillRef idx="3">
+            <a:schemeClr val="accent1"/>
+          </a:fillRef>
+          <a:effectRef idx="2">
+            <a:schemeClr val="accent1"/>
+          </a:effectRef>
+          <a:fontRef idx="minor">
+            <a:schemeClr val="lt1"/>
+          </a:fontRef>
+        </p:style>
+        <p:txBody>
+          <a:bodyPr rtlCol="0" anchor="ctr"/>
+          <a:lstStyle/>
+          <a:p>
+            <a:pPr algn="ctr"/>
+          </a:p>
+        </p:txBody>
+      </p:sp>
+      <p:sp>
+        <p:nvSpPr>
+          <p:cNvPr id="4" name="Rectangle 3"/>
+          <p:cNvSpPr/>
+          <p:nvPr/>
+        </p:nvSpPr>
+        <p:spPr>
+          <a:xfrm>
+            <a:off x="16383000" y="10210800"/>
+            <a:ext cx="1905000" cy="76200"/>
+          </a:xfrm>
+          <a:prstGeom prst="rect">
+            <a:avLst/>
+          </a:prstGeom>
+          <a:solidFill>
+            <a:srgbClr val="000000"/>
+          </a:solidFill>
+          <a:ln>
+            <a:noFill/>
+          </a:ln>
+        </p:spPr>
+        <p:style>
+          <a:lnRef idx="1">
+            <a:schemeClr val="accent1"/>
+          </a:lnRef>
+          <a:fillRef idx="3">
+            <a:schemeClr val="accent1"/>
+          </a:fillRef>
+          <a:effectRef idx="2">
+            <a:schemeClr val="accent1"/>
+          </a:effectRef>
+          <a:fontRef idx="minor">
+            <a:schemeClr val="lt1"/>
+          </a:fontRef>
+        </p:style>
+        <p:txBody>
+          <a:bodyPr rtlCol="0" anchor="ctr"/>
+          <a:lstStyle/>
+          <a:p>
+            <a:pPr algn="ctr"/>
+          </a:p>
+        </p:txBody>
+      </p:sp>
+      <p:sp>
+        <p:nvSpPr>
+          <p:cNvPr id="5" name="TextBox 4"/>
+          <p:cNvSpPr txBox="1"/>
+          <p:nvPr/>
+        </p:nvSpPr>
+        <p:spPr>
+          <a:xfrm>
+            <a:off x="11338560" y="1859280"/>
+            <a:ext cx="6858000" cy="6095999"/>
+          </a:xfrm>
+          <a:prstGeom prst="rect">
+            <a:avLst/>
+          </a:prstGeom>
+          <a:noFill/>
+        </p:spPr>
+        <p:txBody>
+          <a:bodyPr wrap="none"/>
+          <a:lstStyle/>
+          <a:p>
+            <a:pPr algn="l">
+              <a:spcBef>
+                <a:spcPts val="0"/>
+              </a:spcBef>
+              <a:spcAft>
+                <a:spcPts val="0"/>
+              </a:spcAft>
+            </a:pPr>
+            <a:r>
+              <a:rPr sz="34500" b="1">
+                <a:solidFill>
+                  <a:srgbClr val="000000">
+                    <a:alpha val="3000"/>
+                  </a:srgbClr>
+                </a:solidFill>
+                <a:latin typeface="Inter Black"/>
+              </a:rPr>
+              <a:t>AI</a:t>
+            </a:r>
+          </a:p>
+        </p:txBody>
+      </p:sp>
+      <p:sp>
+        <p:nvSpPr>
+          <p:cNvPr id="6" name="Rectangle 5"/>
+          <p:cNvSpPr/>
+          <p:nvPr/>
+        </p:nvSpPr>
+        <p:spPr>
+          <a:xfrm>
+            <a:off x="1143000" y="1143000"/>
+            <a:ext cx="133350" cy="133350"/>
+          </a:xfrm>
+          <a:prstGeom prst="rect">
+            <a:avLst/>
+          </a:prstGeom>
+          <a:solidFill>
+            <a:srgbClr val="888888"/>
+          </a:solidFill>
+          <a:ln>
+            <a:noFill/>
+          </a:ln>
+        </p:spPr>
+        <p:style>
+          <a:lnRef idx="1">
+            <a:schemeClr val="accent1"/>
+          </a:lnRef>
+          <a:fillRef idx="3">
+            <a:schemeClr val="accent1"/>
+          </a:fillRef>
+          <a:effectRef idx="2">
+            <a:schemeClr val="accent1"/>
+          </a:effectRef>
+          <a:fontRef idx="minor">
+            <a:schemeClr val="lt1"/>
+          </a:fontRef>
+        </p:style>
+        <p:txBody>
+          <a:bodyPr rtlCol="0" anchor="ctr"/>
+          <a:lstStyle/>
+          <a:p>
+            <a:pPr algn="ctr"/>
+          </a:p>
+        </p:txBody>
+      </p:sp>
+      <p:sp>
+        <p:nvSpPr>
+          <p:cNvPr id="7" name="TextBox 6"/>
+          <p:cNvSpPr txBox="1"/>
+          <p:nvPr/>
+        </p:nvSpPr>
+        <p:spPr>
+          <a:xfrm>
+            <a:off x="1337310" y="1049655"/>
+            <a:ext cx="6667499" cy="228600"/>
+          </a:xfrm>
+          <a:prstGeom prst="rect">
+            <a:avLst/>
+          </a:prstGeom>
+          <a:noFill/>
+        </p:spPr>
+        <p:txBody>
+          <a:bodyPr wrap="none"/>
+          <a:lstStyle/>
+          <a:p>
+            <a:pPr algn="l">
+              <a:spcBef>
+                <a:spcPts val="0"/>
+              </a:spcBef>
+              <a:spcAft>
+                <a:spcPts val="0"/>
+              </a:spcAft>
+            </a:pPr>
+            <a:r>
+              <a:rPr sz="1500" b="0" spc="300">
+                <a:solidFill>
+                  <a:srgbClr val="888888"/>
+                </a:solidFill>
+                <a:latin typeface="Inter SemiBold"/>
+              </a:rPr>
+              <a:t>10 / AI + PLATFORM</a:t>
+            </a:r>
+          </a:p>
+        </p:txBody>
+      </p:sp>
+      <p:sp>
+        <p:nvSpPr>
+          <p:cNvPr id="8" name="TextBox 7"/>
+          <p:cNvSpPr txBox="1"/>
+          <p:nvPr/>
+        </p:nvSpPr>
+        <p:spPr>
+          <a:xfrm>
+            <a:off x="1051560" y="2592704"/>
+            <a:ext cx="16002000" cy="552450"/>
+          </a:xfrm>
+          <a:prstGeom prst="rect">
+            <a:avLst/>
+          </a:prstGeom>
+          <a:noFill/>
+        </p:spPr>
+        <p:txBody>
+          <a:bodyPr wrap="none"/>
+          <a:lstStyle/>
+          <a:p>
+            <a:pPr algn="l">
+              <a:spcBef>
+                <a:spcPts val="0"/>
+              </a:spcBef>
+              <a:spcAft>
+                <a:spcPts val="0"/>
+              </a:spcAft>
+            </a:pPr>
+            <a:r>
+              <a:rPr sz="4800" b="1">
+                <a:solidFill>
+                  <a:srgbClr val="000000"/>
+                </a:solidFill>
+                <a:latin typeface="Inter Black"/>
+              </a:rPr>
+              <a:t>AI WRITES THE YAML.</a:t>
+            </a:r>
+          </a:p>
+        </p:txBody>
+      </p:sp>
+      <p:sp>
+        <p:nvSpPr>
+          <p:cNvPr id="9" name="TextBox 8"/>
+          <p:cNvSpPr txBox="1"/>
+          <p:nvPr/>
+        </p:nvSpPr>
+        <p:spPr>
+          <a:xfrm>
+            <a:off x="1051560" y="3154679"/>
+            <a:ext cx="16002000" cy="228600"/>
+          </a:xfrm>
+          <a:prstGeom prst="rect">
+            <a:avLst/>
+          </a:prstGeom>
+          <a:noFill/>
+        </p:spPr>
+        <p:txBody>
+          <a:bodyPr wrap="none"/>
+          <a:lstStyle/>
+          <a:p>
+            <a:pPr algn="l">
+              <a:spcBef>
+                <a:spcPts val="0"/>
+              </a:spcBef>
+              <a:spcAft>
+                <a:spcPts val="0"/>
+              </a:spcAft>
+            </a:pPr>
+            <a:r>
+              <a:rPr sz="1500" b="0" spc="75">
+                <a:solidFill>
+                  <a:srgbClr val="AAAAAA"/>
+                </a:solidFill>
+                <a:latin typeface="Inter SemiBold"/>
+              </a:rPr>
+              <a:t>THE PLATFORM DECIDES WHAT RUNS.</a:t>
+            </a:r>
+          </a:p>
+        </p:txBody>
+      </p:sp>
+      <p:sp>
+        <p:nvSpPr>
+          <p:cNvPr id="10" name="Rectangle 9"/>
+          <p:cNvSpPr/>
+          <p:nvPr/>
+        </p:nvSpPr>
+        <p:spPr>
+          <a:xfrm>
+            <a:off x="1143000" y="4933950"/>
+            <a:ext cx="16002000" cy="800100"/>
+          </a:xfrm>
+          <a:prstGeom prst="roundRect">
+            <a:avLst>
+              <a:gd name="adj" fmla="val 14285"/>
+            </a:avLst>
+          </a:prstGeom>
+          <a:solidFill>
+            <a:srgbClr val="F8F8F8"/>
+          </a:solidFill>
+          <a:ln>
+            <a:noFill/>
+          </a:ln>
+        </p:spPr>
+        <p:style>
+          <a:lnRef idx="1">
+            <a:schemeClr val="accent1"/>
+          </a:lnRef>
+          <a:fillRef idx="3">
+            <a:schemeClr val="accent1"/>
+          </a:fillRef>
+          <a:effectRef idx="2">
+            <a:schemeClr val="accent1"/>
+          </a:effectRef>
+          <a:fontRef idx="minor">
+            <a:schemeClr val="lt1"/>
+          </a:fontRef>
+        </p:style>
+        <p:txBody>
+          <a:bodyPr rtlCol="0" anchor="ctr"/>
+          <a:lstStyle/>
+          <a:p>
+            <a:pPr algn="ctr"/>
+          </a:p>
+        </p:txBody>
+      </p:sp>
+      <p:sp>
+        <p:nvSpPr>
+          <p:cNvPr id="11" name="Rectangle 10"/>
+          <p:cNvSpPr/>
+          <p:nvPr/>
+        </p:nvSpPr>
+        <p:spPr>
+          <a:xfrm>
+            <a:off x="1371600" y="5162550"/>
+            <a:ext cx="342900" cy="342900"/>
+          </a:xfrm>
+          <a:prstGeom prst="roundRect">
+            <a:avLst>
+              <a:gd name="adj" fmla="val 33333"/>
+            </a:avLst>
+          </a:prstGeom>
+          <a:solidFill>
+            <a:srgbClr val="2563EB"/>
+          </a:solidFill>
+          <a:ln>
+            <a:noFill/>
+          </a:ln>
+        </p:spPr>
+        <p:style>
+          <a:lnRef idx="1">
+            <a:schemeClr val="accent1"/>
+          </a:lnRef>
+          <a:fillRef idx="3">
+            <a:schemeClr val="accent1"/>
+          </a:fillRef>
+          <a:effectRef idx="2">
+            <a:schemeClr val="accent1"/>
+          </a:effectRef>
+          <a:fontRef idx="minor">
+            <a:schemeClr val="lt1"/>
+          </a:fontRef>
+        </p:style>
+        <p:txBody>
+          <a:bodyPr rtlCol="0" anchor="ctr"/>
+          <a:lstStyle/>
+          <a:p>
+            <a:pPr algn="ctr"/>
+          </a:p>
+        </p:txBody>
+      </p:sp>
+      <p:sp>
+        <p:nvSpPr>
+          <p:cNvPr id="12" name="TextBox 11"/>
+          <p:cNvSpPr txBox="1"/>
+          <p:nvPr/>
+        </p:nvSpPr>
+        <p:spPr>
+          <a:xfrm>
+            <a:off x="1384935" y="5164455"/>
+            <a:ext cx="152400" cy="190499"/>
+          </a:xfrm>
+          <a:prstGeom prst="rect">
+            <a:avLst/>
+          </a:prstGeom>
+          <a:noFill/>
+        </p:spPr>
+        <p:txBody>
+          <a:bodyPr wrap="none"/>
+          <a:lstStyle/>
+          <a:p>
+            <a:pPr algn="l">
+              <a:spcBef>
+                <a:spcPts val="0"/>
+              </a:spcBef>
+              <a:spcAft>
+                <a:spcPts val="0"/>
+              </a:spcAft>
+            </a:pPr>
+            <a:r>
+              <a:rPr sz="1200" b="1">
+                <a:solidFill>
+                  <a:srgbClr val="FFFFFF"/>
+                </a:solidFill>
+                <a:latin typeface="Inter Bold"/>
+              </a:rPr>
+              <a:t>1</a:t>
+            </a:r>
+          </a:p>
+        </p:txBody>
+      </p:sp>
+      <p:sp>
+        <p:nvSpPr>
+          <p:cNvPr id="13" name="TextBox 12"/>
+          <p:cNvSpPr txBox="1"/>
+          <p:nvPr/>
+        </p:nvSpPr>
+        <p:spPr>
+          <a:xfrm>
+            <a:off x="1813560" y="5031105"/>
+            <a:ext cx="13906499" cy="209550"/>
+          </a:xfrm>
+          <a:prstGeom prst="rect">
+            <a:avLst/>
+          </a:prstGeom>
+          <a:noFill/>
+        </p:spPr>
+        <p:txBody>
+          <a:bodyPr wrap="none"/>
+          <a:lstStyle/>
+          <a:p>
+            <a:pPr algn="l">
+              <a:spcBef>
+                <a:spcPts val="0"/>
+              </a:spcBef>
+              <a:spcAft>
+                <a:spcPts val="0"/>
+              </a:spcAft>
+            </a:pPr>
+            <a:r>
+              <a:rPr sz="1350" b="1">
+                <a:solidFill>
+                  <a:srgbClr val="000000"/>
+                </a:solidFill>
+                <a:latin typeface="Inter ExtraBold"/>
+              </a:rPr>
+              <a:t>AI ACCELERATES VELOCITY</a:t>
+            </a:r>
+          </a:p>
+        </p:txBody>
+      </p:sp>
+      <p:sp>
+        <p:nvSpPr>
+          <p:cNvPr id="14" name="TextBox 13"/>
+          <p:cNvSpPr txBox="1"/>
+          <p:nvPr/>
+        </p:nvSpPr>
+        <p:spPr>
+          <a:xfrm>
+            <a:off x="1813560" y="5326380"/>
+            <a:ext cx="13906499" cy="304800"/>
+          </a:xfrm>
+          <a:prstGeom prst="rect">
+            <a:avLst/>
+          </a:prstGeom>
+          <a:noFill/>
+        </p:spPr>
+        <p:txBody>
+          <a:bodyPr wrap="square"/>
+          <a:lstStyle/>
+          <a:p>
+            <a:pPr algn="l">
+              <a:spcBef>
+                <a:spcPts val="0"/>
+              </a:spcBef>
+              <a:spcAft>
+                <a:spcPts val="0"/>
+              </a:spcAft>
+            </a:pPr>
+            <a:r>
+              <a:rPr sz="1125" b="0">
+                <a:solidFill>
+                  <a:srgbClr val="666666"/>
+                </a:solidFill>
+                <a:latin typeface="Inter"/>
+              </a:rPr>
+              <a:t>Developers generate more infrastructure requests, faster. Platforms built for ticket queues will break under that load.</a:t>
+            </a:r>
+          </a:p>
+        </p:txBody>
+      </p:sp>
+      <p:sp>
+        <p:nvSpPr>
+          <p:cNvPr id="15" name="Rectangle 14"/>
+          <p:cNvSpPr/>
+          <p:nvPr/>
+        </p:nvSpPr>
+        <p:spPr>
+          <a:xfrm>
+            <a:off x="1143000" y="5810249"/>
+            <a:ext cx="16002000" cy="800100"/>
+          </a:xfrm>
+          <a:prstGeom prst="roundRect">
+            <a:avLst>
+              <a:gd name="adj" fmla="val 14285"/>
+            </a:avLst>
+          </a:prstGeom>
+          <a:solidFill>
+            <a:srgbClr val="FFFFFF"/>
+          </a:solidFill>
+          <a:ln w="9525">
+            <a:solidFill>
+              <a:srgbClr val="F0F0F0"/>
+            </a:solidFill>
+          </a:ln>
+        </p:spPr>
+        <p:style>
+          <a:lnRef idx="1">
+            <a:schemeClr val="accent1"/>
+          </a:lnRef>
+          <a:fillRef idx="3">
+            <a:schemeClr val="accent1"/>
+          </a:fillRef>
+          <a:effectRef idx="2">
+            <a:schemeClr val="accent1"/>
+          </a:effectRef>
+          <a:fontRef idx="minor">
+            <a:schemeClr val="lt1"/>
+          </a:fontRef>
+        </p:style>
+        <p:txBody>
+          <a:bodyPr rtlCol="0" anchor="ctr"/>
+          <a:lstStyle/>
+          <a:p>
+            <a:pPr algn="ctr"/>
+          </a:p>
+        </p:txBody>
+      </p:sp>
+      <p:sp>
+        <p:nvSpPr>
+          <p:cNvPr id="16" name="Rectangle 15"/>
+          <p:cNvSpPr/>
+          <p:nvPr/>
+        </p:nvSpPr>
+        <p:spPr>
+          <a:xfrm>
+            <a:off x="1371600" y="6038849"/>
+            <a:ext cx="342900" cy="342900"/>
+          </a:xfrm>
+          <a:prstGeom prst="roundRect">
+            <a:avLst>
+              <a:gd name="adj" fmla="val 33333"/>
+            </a:avLst>
+          </a:prstGeom>
+          <a:solidFill>
+            <a:srgbClr val="2563EB"/>
+          </a:solidFill>
+          <a:ln>
+            <a:noFill/>
+          </a:ln>
+        </p:spPr>
+        <p:style>
+          <a:lnRef idx="1">
+            <a:schemeClr val="accent1"/>
+          </a:lnRef>
+          <a:fillRef idx="3">
+            <a:schemeClr val="accent1"/>
+          </a:fillRef>
+          <a:effectRef idx="2">
+            <a:schemeClr val="accent1"/>
+          </a:effectRef>
+          <a:fontRef idx="minor">
+            <a:schemeClr val="lt1"/>
+          </a:fontRef>
+        </p:style>
+        <p:txBody>
+          <a:bodyPr rtlCol="0" anchor="ctr"/>
+          <a:lstStyle/>
+          <a:p>
+            <a:pPr algn="ctr"/>
+          </a:p>
+        </p:txBody>
+      </p:sp>
+      <p:sp>
+        <p:nvSpPr>
+          <p:cNvPr id="17" name="TextBox 16"/>
+          <p:cNvSpPr txBox="1"/>
+          <p:nvPr/>
+        </p:nvSpPr>
+        <p:spPr>
+          <a:xfrm>
+            <a:off x="1384935" y="6040755"/>
+            <a:ext cx="152400" cy="190499"/>
+          </a:xfrm>
+          <a:prstGeom prst="rect">
+            <a:avLst/>
+          </a:prstGeom>
+          <a:noFill/>
+        </p:spPr>
+        <p:txBody>
+          <a:bodyPr wrap="none"/>
+          <a:lstStyle/>
+          <a:p>
+            <a:pPr algn="l">
+              <a:spcBef>
+                <a:spcPts val="0"/>
+              </a:spcBef>
+              <a:spcAft>
+                <a:spcPts val="0"/>
+              </a:spcAft>
+            </a:pPr>
+            <a:r>
+              <a:rPr sz="1200" b="1">
+                <a:solidFill>
+                  <a:srgbClr val="FFFFFF"/>
+                </a:solidFill>
+                <a:latin typeface="Inter Bold"/>
+              </a:rPr>
+              <a:t>2</a:t>
+            </a:r>
+          </a:p>
+        </p:txBody>
+      </p:sp>
+      <p:sp>
+        <p:nvSpPr>
+          <p:cNvPr id="18" name="TextBox 17"/>
+          <p:cNvSpPr txBox="1"/>
+          <p:nvPr/>
+        </p:nvSpPr>
+        <p:spPr>
+          <a:xfrm>
+            <a:off x="1813560" y="5907405"/>
+            <a:ext cx="13906499" cy="209550"/>
+          </a:xfrm>
+          <a:prstGeom prst="rect">
+            <a:avLst/>
+          </a:prstGeom>
+          <a:noFill/>
+        </p:spPr>
+        <p:txBody>
+          <a:bodyPr wrap="none"/>
+          <a:lstStyle/>
+          <a:p>
+            <a:pPr algn="l">
+              <a:spcBef>
+                <a:spcPts val="0"/>
+              </a:spcBef>
+              <a:spcAft>
+                <a:spcPts val="0"/>
+              </a:spcAft>
+            </a:pPr>
+            <a:r>
+              <a:rPr sz="1350" b="1">
+                <a:solidFill>
+                  <a:srgbClr val="000000"/>
+                </a:solidFill>
+                <a:latin typeface="Inter ExtraBold"/>
+              </a:rPr>
+              <a:t>PLATFORMS NEED GUARDRAILS</a:t>
+            </a:r>
+          </a:p>
+        </p:txBody>
+      </p:sp>
+      <p:sp>
+        <p:nvSpPr>
+          <p:cNvPr id="19" name="TextBox 18"/>
+          <p:cNvSpPr txBox="1"/>
+          <p:nvPr/>
+        </p:nvSpPr>
+        <p:spPr>
+          <a:xfrm>
+            <a:off x="1813560" y="6202680"/>
+            <a:ext cx="13906499" cy="304800"/>
+          </a:xfrm>
+          <a:prstGeom prst="rect">
+            <a:avLst/>
+          </a:prstGeom>
+          <a:noFill/>
+        </p:spPr>
+        <p:txBody>
+          <a:bodyPr wrap="square"/>
+          <a:lstStyle/>
+          <a:p>
+            <a:pPr algn="l">
+              <a:spcBef>
+                <a:spcPts val="0"/>
+              </a:spcBef>
+              <a:spcAft>
+                <a:spcPts val="0"/>
+              </a:spcAft>
+            </a:pPr>
+            <a:r>
+              <a:rPr sz="1125" b="0">
+                <a:solidFill>
+                  <a:srgbClr val="666666"/>
+                </a:solidFill>
+                <a:latin typeface="Inter"/>
+              </a:rPr>
+              <a:t>Self-service CRs. Automatic policy gates. GitOps audit trails. Scales linearly with developer velocity.</a:t>
+            </a:r>
+          </a:p>
+        </p:txBody>
+      </p:sp>
+      <p:sp>
+        <p:nvSpPr>
+          <p:cNvPr id="20" name="Rectangle 19"/>
+          <p:cNvSpPr/>
+          <p:nvPr/>
+        </p:nvSpPr>
+        <p:spPr>
+          <a:xfrm>
+            <a:off x="1143000" y="6686550"/>
+            <a:ext cx="16002000" cy="800100"/>
+          </a:xfrm>
+          <a:prstGeom prst="roundRect">
+            <a:avLst>
+              <a:gd name="adj" fmla="val 14285"/>
+            </a:avLst>
+          </a:prstGeom>
+          <a:solidFill>
+            <a:srgbClr val="F8F8F8"/>
+          </a:solidFill>
+          <a:ln>
+            <a:noFill/>
+          </a:ln>
+        </p:spPr>
+        <p:style>
+          <a:lnRef idx="1">
+            <a:schemeClr val="accent1"/>
+          </a:lnRef>
+          <a:fillRef idx="3">
+            <a:schemeClr val="accent1"/>
+          </a:fillRef>
+          <a:effectRef idx="2">
+            <a:schemeClr val="accent1"/>
+          </a:effectRef>
+          <a:fontRef idx="minor">
+            <a:schemeClr val="lt1"/>
+          </a:fontRef>
+        </p:style>
+        <p:txBody>
+          <a:bodyPr rtlCol="0" anchor="ctr"/>
+          <a:lstStyle/>
+          <a:p>
+            <a:pPr algn="ctr"/>
+          </a:p>
+        </p:txBody>
+      </p:sp>
+      <p:sp>
+        <p:nvSpPr>
+          <p:cNvPr id="21" name="Rectangle 20"/>
+          <p:cNvSpPr/>
+          <p:nvPr/>
+        </p:nvSpPr>
+        <p:spPr>
+          <a:xfrm>
+            <a:off x="1371600" y="6915150"/>
+            <a:ext cx="342900" cy="342900"/>
+          </a:xfrm>
+          <a:prstGeom prst="roundRect">
+            <a:avLst>
+              <a:gd name="adj" fmla="val 33333"/>
+            </a:avLst>
+          </a:prstGeom>
+          <a:solidFill>
+            <a:srgbClr val="2563EB"/>
+          </a:solidFill>
+          <a:ln>
+            <a:noFill/>
+          </a:ln>
+        </p:spPr>
+        <p:style>
+          <a:lnRef idx="1">
+            <a:schemeClr val="accent1"/>
+          </a:lnRef>
+          <a:fillRef idx="3">
+            <a:schemeClr val="accent1"/>
+          </a:fillRef>
+          <a:effectRef idx="2">
+            <a:schemeClr val="accent1"/>
+          </a:effectRef>
+          <a:fontRef idx="minor">
+            <a:schemeClr val="lt1"/>
+          </a:fontRef>
+        </p:style>
+        <p:txBody>
+          <a:bodyPr rtlCol="0" anchor="ctr"/>
+          <a:lstStyle/>
+          <a:p>
+            <a:pPr algn="ctr"/>
+          </a:p>
+        </p:txBody>
+      </p:sp>
+      <p:sp>
+        <p:nvSpPr>
+          <p:cNvPr id="22" name="TextBox 21"/>
+          <p:cNvSpPr txBox="1"/>
+          <p:nvPr/>
+        </p:nvSpPr>
+        <p:spPr>
+          <a:xfrm>
+            <a:off x="1384935" y="6917055"/>
+            <a:ext cx="152400" cy="190499"/>
+          </a:xfrm>
+          <a:prstGeom prst="rect">
+            <a:avLst/>
+          </a:prstGeom>
+          <a:noFill/>
+        </p:spPr>
+        <p:txBody>
+          <a:bodyPr wrap="none"/>
+          <a:lstStyle/>
+          <a:p>
+            <a:pPr algn="l">
+              <a:spcBef>
+                <a:spcPts val="0"/>
+              </a:spcBef>
+              <a:spcAft>
+                <a:spcPts val="0"/>
+              </a:spcAft>
+            </a:pPr>
+            <a:r>
+              <a:rPr sz="1200" b="1">
+                <a:solidFill>
+                  <a:srgbClr val="FFFFFF"/>
+                </a:solidFill>
+                <a:latin typeface="Inter Bold"/>
+              </a:rPr>
+              <a:t>3</a:t>
+            </a:r>
+          </a:p>
+        </p:txBody>
+      </p:sp>
+      <p:sp>
+        <p:nvSpPr>
+          <p:cNvPr id="23" name="TextBox 22"/>
+          <p:cNvSpPr txBox="1"/>
+          <p:nvPr/>
+        </p:nvSpPr>
+        <p:spPr>
+          <a:xfrm>
+            <a:off x="1813560" y="6783705"/>
+            <a:ext cx="13906499" cy="209550"/>
+          </a:xfrm>
+          <a:prstGeom prst="rect">
+            <a:avLst/>
+          </a:prstGeom>
+          <a:noFill/>
+        </p:spPr>
+        <p:txBody>
+          <a:bodyPr wrap="none"/>
+          <a:lstStyle/>
+          <a:p>
+            <a:pPr algn="l">
+              <a:spcBef>
+                <a:spcPts val="0"/>
+              </a:spcBef>
+              <a:spcAft>
+                <a:spcPts val="0"/>
+              </a:spcAft>
+            </a:pPr>
+            <a:r>
+              <a:rPr sz="1350" b="1">
+                <a:solidFill>
+                  <a:srgbClr val="000000"/>
+                </a:solidFill>
+                <a:latin typeface="Inter ExtraBold"/>
+              </a:rPr>
+              <a:t>AI BUILDS THE PLATFORM TOO</a:t>
+            </a:r>
+          </a:p>
+        </p:txBody>
+      </p:sp>
+      <p:sp>
+        <p:nvSpPr>
+          <p:cNvPr id="24" name="TextBox 23"/>
+          <p:cNvSpPr txBox="1"/>
+          <p:nvPr/>
+        </p:nvSpPr>
+        <p:spPr>
+          <a:xfrm>
+            <a:off x="1813560" y="7078980"/>
+            <a:ext cx="13906499" cy="304800"/>
+          </a:xfrm>
+          <a:prstGeom prst="rect">
+            <a:avLst/>
+          </a:prstGeom>
+          <a:noFill/>
+        </p:spPr>
+        <p:txBody>
+          <a:bodyPr wrap="square"/>
+          <a:lstStyle/>
+          <a:p>
+            <a:pPr algn="l">
+              <a:spcBef>
+                <a:spcPts val="0"/>
+              </a:spcBef>
+              <a:spcAft>
+                <a:spcPts val="0"/>
+              </a:spcAft>
+            </a:pPr>
+            <a:r>
+              <a:rPr sz="1125" b="0">
+                <a:solidFill>
+                  <a:srgbClr val="666666"/>
+                </a:solidFill>
+                <a:latin typeface="Inter"/>
+              </a:rPr>
+              <a:t>Crossplane Compositions, KRO ResourceGroups, Terranetes policies — well-structured schemas AI is very good at generating.</a:t>
+            </a:r>
+          </a:p>
+        </p:txBody>
+      </p:sp>
+      <p:sp>
+        <p:nvSpPr>
+          <p:cNvPr id="25" name="Rectangle 24"/>
+          <p:cNvSpPr/>
+          <p:nvPr/>
+        </p:nvSpPr>
+        <p:spPr>
+          <a:xfrm>
+            <a:off x="1143000" y="8943975"/>
+            <a:ext cx="16002000" cy="390525"/>
+          </a:xfrm>
+          <a:prstGeom prst="roundRect">
+            <a:avLst>
+              <a:gd name="adj" fmla="val 29268"/>
+            </a:avLst>
+          </a:prstGeom>
+          <a:solidFill>
+            <a:srgbClr val="0D0D0D"/>
+          </a:solidFill>
+          <a:ln>
+            <a:noFill/>
+          </a:ln>
+        </p:spPr>
+        <p:style>
+          <a:lnRef idx="1">
+            <a:schemeClr val="accent1"/>
+          </a:lnRef>
+          <a:fillRef idx="3">
+            <a:schemeClr val="accent1"/>
+          </a:fillRef>
+          <a:effectRef idx="2">
+            <a:schemeClr val="accent1"/>
+          </a:effectRef>
+          <a:fontRef idx="minor">
+            <a:schemeClr val="lt1"/>
+          </a:fontRef>
+        </p:style>
+        <p:txBody>
+          <a:bodyPr rtlCol="0" anchor="ctr"/>
+          <a:lstStyle/>
+          <a:p>
+            <a:pPr algn="ctr"/>
+          </a:p>
+        </p:txBody>
+      </p:sp>
+      <p:sp>
+        <p:nvSpPr>
+          <p:cNvPr id="26" name="TextBox 25"/>
+          <p:cNvSpPr txBox="1"/>
+          <p:nvPr/>
+        </p:nvSpPr>
+        <p:spPr>
+          <a:xfrm>
+            <a:off x="1280160" y="8964930"/>
+            <a:ext cx="3238500" cy="161924"/>
+          </a:xfrm>
+          <a:prstGeom prst="rect">
+            <a:avLst/>
+          </a:prstGeom>
+          <a:noFill/>
+        </p:spPr>
+        <p:txBody>
+          <a:bodyPr wrap="none"/>
+          <a:lstStyle/>
+          <a:p>
+            <a:pPr algn="l">
+              <a:spcBef>
+                <a:spcPts val="0"/>
+              </a:spcBef>
+              <a:spcAft>
+                <a:spcPts val="0"/>
+              </a:spcAft>
+            </a:pPr>
+            <a:r>
+              <a:rPr sz="1050" b="1" spc="150">
+                <a:solidFill>
+                  <a:srgbClr val="FFFFFF"/>
+                </a:solidFill>
+                <a:latin typeface="Inter Bold"/>
+              </a:rPr>
+              <a:t>THE BOTTLENECK ISN'T THE DEVELOPER.</a:t>
+            </a:r>
+          </a:p>
+        </p:txBody>
+      </p:sp>
+      <p:sp>
+        <p:nvSpPr>
+          <p:cNvPr id="27" name="TextBox 26"/>
+          <p:cNvSpPr txBox="1"/>
+          <p:nvPr/>
+        </p:nvSpPr>
+        <p:spPr>
+          <a:xfrm>
+            <a:off x="4671060" y="8964930"/>
+            <a:ext cx="4762500" cy="161924"/>
+          </a:xfrm>
+          <a:prstGeom prst="rect">
+            <a:avLst/>
+          </a:prstGeom>
+          <a:noFill/>
+        </p:spPr>
+        <p:txBody>
+          <a:bodyPr wrap="none"/>
+          <a:lstStyle/>
+          <a:p>
+            <a:pPr algn="l">
+              <a:spcBef>
+                <a:spcPts val="0"/>
+              </a:spcBef>
+              <a:spcAft>
+                <a:spcPts val="0"/>
+              </a:spcAft>
+            </a:pPr>
+            <a:r>
+              <a:rPr sz="1050" b="0" spc="75">
+                <a:solidFill>
+                  <a:srgbClr val="666666"/>
+                </a:solidFill>
+                <a:latin typeface="Inter SemiBold"/>
+              </a:rPr>
+              <a:t>→  IT'S A PLATFORM THAT DOESN'T SCALE</a:t>
+            </a:r>
+          </a:p>
+        </p:txBody>
+      </p:sp>
+    </p:spTree>
+  </p:cSld>
+  <p:clrMapOvr>
+    <a:masterClrMapping/>
+  </p:clrMapOvr>
+</p:sld>
+</file>
+
+<file path=ppt/slides/slide47.xml><?xml version="1.0" encoding="utf-8"?>
+<p:sld xmlns:a="http://schemas.openxmlformats.org/drawingml/2006/main" xmlns:p="http://schemas.openxmlformats.org/presentationml/2006/main" xmlns:r="http://schemas.openxmlformats.org/officeDocument/2006/relationships">
+  <p:cSld>
+    <p:spTree>
+      <p:nvGrpSpPr>
+        <p:cNvPr id="1" name=""/>
+        <p:cNvGrpSpPr/>
+        <p:nvPr/>
+      </p:nvGrpSpPr>
+      <p:grpSpPr/>
+      <p:sp>
+        <p:nvSpPr>
+          <p:cNvPr id="2" name="Rectangle 1"/>
+          <p:cNvSpPr/>
+          <p:nvPr/>
+        </p:nvSpPr>
+        <p:spPr>
+          <a:xfrm>
+            <a:off x="0" y="0"/>
+            <a:ext cx="18288000" cy="10287000"/>
+          </a:xfrm>
+          <a:prstGeom prst="rect">
+            <a:avLst/>
+          </a:prstGeom>
+          <a:solidFill>
+            <a:srgbClr val="000000"/>
+          </a:solidFill>
+          <a:ln>
+            <a:noFill/>
+          </a:ln>
+        </p:spPr>
+        <p:style>
+          <a:lnRef idx="1">
+            <a:schemeClr val="accent1"/>
+          </a:lnRef>
+          <a:fillRef idx="3">
+            <a:schemeClr val="accent1"/>
+          </a:fillRef>
+          <a:effectRef idx="2">
+            <a:schemeClr val="accent1"/>
+          </a:effectRef>
+          <a:fontRef idx="minor">
+            <a:schemeClr val="lt1"/>
+          </a:fontRef>
+        </p:style>
+        <p:txBody>
+          <a:bodyPr rtlCol="0" anchor="ctr"/>
+          <a:lstStyle/>
+          <a:p>
+            <a:pPr algn="ctr"/>
+          </a:p>
+        </p:txBody>
+      </p:sp>
+      <p:sp>
+        <p:nvSpPr>
+          <p:cNvPr id="3" name="Rectangle 2"/>
+          <p:cNvSpPr/>
+          <p:nvPr/>
+        </p:nvSpPr>
+        <p:spPr>
+          <a:xfrm>
+            <a:off x="0" y="0"/>
+            <a:ext cx="76200" cy="10287000"/>
+          </a:xfrm>
+          <a:prstGeom prst="rect">
+            <a:avLst/>
+          </a:prstGeom>
+          <a:solidFill>
+            <a:srgbClr val="FFFFFF"/>
+          </a:solidFill>
+          <a:ln>
+            <a:noFill/>
+          </a:ln>
+        </p:spPr>
+        <p:style>
+          <a:lnRef idx="1">
+            <a:schemeClr val="accent1"/>
+          </a:lnRef>
+          <a:fillRef idx="3">
+            <a:schemeClr val="accent1"/>
+          </a:fillRef>
+          <a:effectRef idx="2">
+            <a:schemeClr val="accent1"/>
+          </a:effectRef>
+          <a:fontRef idx="minor">
+            <a:schemeClr val="lt1"/>
+          </a:fontRef>
+        </p:style>
+        <p:txBody>
+          <a:bodyPr rtlCol="0" anchor="ctr"/>
+          <a:lstStyle/>
+          <a:p>
+            <a:pPr algn="ctr"/>
+          </a:p>
+        </p:txBody>
+      </p:sp>
+      <p:sp>
+        <p:nvSpPr>
+          <p:cNvPr id="4" name="Rectangle 3"/>
+          <p:cNvSpPr/>
+          <p:nvPr/>
+        </p:nvSpPr>
+        <p:spPr>
+          <a:xfrm>
+            <a:off x="16383000" y="10096500"/>
+            <a:ext cx="1905000" cy="76200"/>
+          </a:xfrm>
+          <a:prstGeom prst="rect">
+            <a:avLst/>
+          </a:prstGeom>
+          <a:solidFill>
+            <a:srgbClr val="FFFFFF"/>
+          </a:solidFill>
+          <a:ln>
+            <a:noFill/>
+          </a:ln>
+        </p:spPr>
+        <p:style>
+          <a:lnRef idx="1">
+            <a:schemeClr val="accent1"/>
+          </a:lnRef>
+          <a:fillRef idx="3">
+            <a:schemeClr val="accent1"/>
+          </a:fillRef>
+          <a:effectRef idx="2">
+            <a:schemeClr val="accent1"/>
+          </a:effectRef>
+          <a:fontRef idx="minor">
+            <a:schemeClr val="lt1"/>
+          </a:fontRef>
+        </p:style>
+        <p:txBody>
+          <a:bodyPr rtlCol="0" anchor="ctr"/>
+          <a:lstStyle/>
+          <a:p>
+            <a:pPr algn="ctr"/>
+          </a:p>
+        </p:txBody>
+      </p:sp>
+      <p:sp>
+        <p:nvSpPr>
+          <p:cNvPr id="5" name="Rectangle 4"/>
+          <p:cNvSpPr/>
+          <p:nvPr/>
+        </p:nvSpPr>
+        <p:spPr>
+          <a:xfrm>
+            <a:off x="1143000" y="1143000"/>
+            <a:ext cx="133350" cy="133350"/>
+          </a:xfrm>
+          <a:prstGeom prst="rect">
+            <a:avLst/>
+          </a:prstGeom>
+          <a:solidFill>
+            <a:srgbClr val="FFFFFF"/>
+          </a:solidFill>
+          <a:ln>
+            <a:noFill/>
+          </a:ln>
+        </p:spPr>
+        <p:style>
+          <a:lnRef idx="1">
+            <a:schemeClr val="accent1"/>
+          </a:lnRef>
+          <a:fillRef idx="3">
+            <a:schemeClr val="accent1"/>
+          </a:fillRef>
+          <a:effectRef idx="2">
+            <a:schemeClr val="accent1"/>
+          </a:effectRef>
+          <a:fontRef idx="minor">
+            <a:schemeClr val="lt1"/>
+          </a:fontRef>
+        </p:style>
+        <p:txBody>
+          <a:bodyPr rtlCol="0" anchor="ctr"/>
+          <a:lstStyle/>
+          <a:p>
+            <a:pPr algn="ctr"/>
+          </a:p>
+        </p:txBody>
+      </p:sp>
+      <p:sp>
+        <p:nvSpPr>
+          <p:cNvPr id="6" name="TextBox 5"/>
+          <p:cNvSpPr txBox="1"/>
+          <p:nvPr/>
+        </p:nvSpPr>
+        <p:spPr>
+          <a:xfrm>
+            <a:off x="1337310" y="1049655"/>
+            <a:ext cx="6667499" cy="228600"/>
+          </a:xfrm>
+          <a:prstGeom prst="rect">
+            <a:avLst/>
+          </a:prstGeom>
+          <a:noFill/>
+        </p:spPr>
+        <p:txBody>
+          <a:bodyPr wrap="none"/>
+          <a:lstStyle/>
+          <a:p>
+            <a:pPr algn="l">
+              <a:spcBef>
+                <a:spcPts val="0"/>
+              </a:spcBef>
+              <a:spcAft>
+                <a:spcPts val="0"/>
+              </a:spcAft>
+            </a:pPr>
+            <a:r>
+              <a:rPr sz="1500" b="0" spc="300">
+                <a:solidFill>
+                  <a:srgbClr val="FFFFFF"/>
+                </a:solidFill>
+                <a:latin typeface="Inter SemiBold"/>
+              </a:rPr>
+              <a:t>11 / THE WHOLE PICTURE</a:t>
+            </a:r>
+          </a:p>
+        </p:txBody>
+      </p:sp>
+      <p:sp>
+        <p:nvSpPr>
+          <p:cNvPr id="7" name="TextBox 6"/>
+          <p:cNvSpPr txBox="1"/>
+          <p:nvPr/>
+        </p:nvSpPr>
+        <p:spPr>
+          <a:xfrm>
+            <a:off x="1051560" y="3354704"/>
+            <a:ext cx="16002000" cy="619124"/>
+          </a:xfrm>
+          <a:prstGeom prst="rect">
+            <a:avLst/>
+          </a:prstGeom>
+          <a:noFill/>
+        </p:spPr>
+        <p:txBody>
+          <a:bodyPr wrap="none"/>
+          <a:lstStyle/>
+          <a:p>
+            <a:pPr algn="l">
+              <a:spcBef>
+                <a:spcPts val="0"/>
+              </a:spcBef>
+              <a:spcAft>
+                <a:spcPts val="0"/>
+              </a:spcAft>
+            </a:pPr>
+            <a:r>
+              <a:rPr sz="5400" b="1">
+                <a:solidFill>
+                  <a:srgbClr val="FFFFFF"/>
+                </a:solidFill>
+                <a:latin typeface="Inter Black"/>
+              </a:rPr>
+              <a:t>THE COMPLETE STACK.</a:t>
+            </a:r>
+          </a:p>
+        </p:txBody>
+      </p:sp>
+      <p:sp>
+        <p:nvSpPr>
+          <p:cNvPr id="8" name="TextBox 7"/>
+          <p:cNvSpPr txBox="1"/>
+          <p:nvPr/>
+        </p:nvSpPr>
+        <p:spPr>
+          <a:xfrm>
+            <a:off x="1051560" y="3983354"/>
+            <a:ext cx="16002000" cy="228600"/>
+          </a:xfrm>
+          <a:prstGeom prst="rect">
+            <a:avLst/>
+          </a:prstGeom>
+          <a:noFill/>
+        </p:spPr>
+        <p:txBody>
+          <a:bodyPr wrap="none"/>
+          <a:lstStyle/>
+          <a:p>
+            <a:pPr algn="l">
+              <a:spcBef>
+                <a:spcPts val="0"/>
+              </a:spcBef>
+              <a:spcAft>
+                <a:spcPts val="0"/>
+              </a:spcAft>
+            </a:pPr>
+            <a:r>
+              <a:rPr sz="1200" b="0" spc="150">
+                <a:solidFill>
+                  <a:srgbClr val="555555"/>
+                </a:solidFill>
+                <a:latin typeface="Inter SemiBold"/>
+              </a:rPr>
+              <a:t>GIT  →  ARGO CD  →  KUBERNETES API  →  FOUR TOOLS  →  AZURE</a:t>
+            </a:r>
+          </a:p>
+        </p:txBody>
+      </p:sp>
+      <p:sp>
+        <p:nvSpPr>
+          <p:cNvPr id="9" name="Rectangle 8"/>
+          <p:cNvSpPr/>
+          <p:nvPr/>
+        </p:nvSpPr>
+        <p:spPr>
+          <a:xfrm>
+            <a:off x="1143000" y="6477000"/>
+            <a:ext cx="4857750" cy="2857500"/>
+          </a:xfrm>
+          <a:prstGeom prst="rect">
+            <a:avLst/>
+          </a:prstGeom>
+          <a:solidFill>
+            <a:srgbClr val="111111"/>
+          </a:solidFill>
+          <a:ln>
+            <a:noFill/>
+          </a:ln>
+        </p:spPr>
+        <p:style>
+          <a:lnRef idx="1">
+            <a:schemeClr val="accent1"/>
+          </a:lnRef>
+          <a:fillRef idx="3">
+            <a:schemeClr val="accent1"/>
+          </a:fillRef>
+          <a:effectRef idx="2">
+            <a:schemeClr val="accent1"/>
+          </a:effectRef>
+          <a:fontRef idx="minor">
+            <a:schemeClr val="lt1"/>
+          </a:fontRef>
+        </p:style>
+        <p:txBody>
+          <a:bodyPr rtlCol="0" anchor="ctr"/>
+          <a:lstStyle/>
+          <a:p>
+            <a:pPr algn="ctr"/>
+          </a:p>
+        </p:txBody>
+      </p:sp>
+      <p:sp>
+        <p:nvSpPr>
+          <p:cNvPr id="10" name="Rectangle 9"/>
+          <p:cNvSpPr/>
+          <p:nvPr/>
+        </p:nvSpPr>
+        <p:spPr>
+          <a:xfrm>
+            <a:off x="1143000" y="6477000"/>
+            <a:ext cx="4857750" cy="47624"/>
+          </a:xfrm>
+          <a:prstGeom prst="rect">
+            <a:avLst/>
+          </a:prstGeom>
+          <a:solidFill>
+            <a:srgbClr val="555555"/>
+          </a:solidFill>
+          <a:ln>
+            <a:noFill/>
+          </a:ln>
+        </p:spPr>
+        <p:style>
+          <a:lnRef idx="1">
+            <a:schemeClr val="accent1"/>
+          </a:lnRef>
+          <a:fillRef idx="3">
+            <a:schemeClr val="accent1"/>
+          </a:fillRef>
+          <a:effectRef idx="2">
+            <a:schemeClr val="accent1"/>
+          </a:effectRef>
+          <a:fontRef idx="minor">
+            <a:schemeClr val="lt1"/>
+          </a:fontRef>
+        </p:style>
+        <p:txBody>
+          <a:bodyPr rtlCol="0" anchor="ctr"/>
+          <a:lstStyle/>
+          <a:p>
+            <a:pPr algn="ctr"/>
+          </a:p>
+        </p:txBody>
+      </p:sp>
+      <p:sp>
+        <p:nvSpPr>
+          <p:cNvPr id="11" name="TextBox 10"/>
+          <p:cNvSpPr txBox="1"/>
+          <p:nvPr/>
+        </p:nvSpPr>
+        <p:spPr>
+          <a:xfrm>
+            <a:off x="1242060" y="6621780"/>
+            <a:ext cx="4476750" cy="152400"/>
+          </a:xfrm>
+          <a:prstGeom prst="rect">
+            <a:avLst/>
+          </a:prstGeom>
+          <a:noFill/>
+        </p:spPr>
+        <p:txBody>
+          <a:bodyPr wrap="none"/>
+          <a:lstStyle/>
+          <a:p>
+            <a:pPr algn="l">
+              <a:spcBef>
+                <a:spcPts val="0"/>
+              </a:spcBef>
+              <a:spcAft>
+                <a:spcPts val="0"/>
+              </a:spcAft>
+            </a:pPr>
+            <a:r>
+              <a:rPr sz="825" b="1" spc="225">
+                <a:solidFill>
+                  <a:srgbClr val="888888"/>
+                </a:solidFill>
+                <a:latin typeface="Inter Bold"/>
+              </a:rPr>
+              <a:t>SOURCE OF TRUTH</a:t>
+            </a:r>
+          </a:p>
+        </p:txBody>
+      </p:sp>
+      <p:sp>
+        <p:nvSpPr>
+          <p:cNvPr id="12" name="TextBox 11"/>
+          <p:cNvSpPr txBox="1"/>
+          <p:nvPr/>
+        </p:nvSpPr>
+        <p:spPr>
+          <a:xfrm>
+            <a:off x="1242060" y="6850380"/>
+            <a:ext cx="4476750" cy="266700"/>
+          </a:xfrm>
+          <a:prstGeom prst="rect">
+            <a:avLst/>
+          </a:prstGeom>
+          <a:noFill/>
+        </p:spPr>
+        <p:txBody>
+          <a:bodyPr wrap="none"/>
+          <a:lstStyle/>
+          <a:p>
+            <a:pPr algn="l">
+              <a:spcBef>
+                <a:spcPts val="0"/>
+              </a:spcBef>
+              <a:spcAft>
+                <a:spcPts val="0"/>
+              </a:spcAft>
+            </a:pPr>
+            <a:r>
+              <a:rPr sz="1500" b="1">
+                <a:solidFill>
+                  <a:srgbClr val="FFFFFF"/>
+                </a:solidFill>
+                <a:latin typeface="Inter ExtraBold"/>
+              </a:rPr>
+              <a:t>Git + Argo CD</a:t>
+            </a:r>
+          </a:p>
+        </p:txBody>
+      </p:sp>
+      <p:sp>
+        <p:nvSpPr>
+          <p:cNvPr id="13" name="TextBox 12"/>
+          <p:cNvSpPr txBox="1"/>
+          <p:nvPr/>
+        </p:nvSpPr>
+        <p:spPr>
+          <a:xfrm>
+            <a:off x="1242060" y="7212330"/>
+            <a:ext cx="4476750" cy="1904999"/>
+          </a:xfrm>
+          <a:prstGeom prst="rect">
+            <a:avLst/>
+          </a:prstGeom>
+          <a:noFill/>
+        </p:spPr>
+        <p:txBody>
+          <a:bodyPr wrap="square"/>
+          <a:lstStyle/>
+          <a:p>
+            <a:pPr algn="l">
+              <a:spcBef>
+                <a:spcPts val="0"/>
+              </a:spcBef>
+              <a:spcAft>
+                <a:spcPts val="0"/>
+              </a:spcAft>
+            </a:pPr>
+            <a:r>
+              <a:rPr sz="975" b="0">
+                <a:solidFill>
+                  <a:srgbClr val="555555"/>
+                </a:solidFill>
+                <a:latin typeface="Inter"/>
+              </a:rPr>
+              <a:t>Every intent starts as a commit. Argo CD continuously reconciles the cluster to match the Git state.</a:t>
+            </a:r>
+          </a:p>
+        </p:txBody>
+      </p:sp>
+      <p:sp>
+        <p:nvSpPr>
+          <p:cNvPr id="14" name="Rectangle 13"/>
+          <p:cNvSpPr/>
+          <p:nvPr/>
+        </p:nvSpPr>
+        <p:spPr>
+          <a:xfrm>
+            <a:off x="6638925" y="6477000"/>
+            <a:ext cx="4857750" cy="2857500"/>
+          </a:xfrm>
+          <a:prstGeom prst="rect">
+            <a:avLst/>
+          </a:prstGeom>
+          <a:solidFill>
+            <a:srgbClr val="111111"/>
+          </a:solidFill>
+          <a:ln w="9525">
+            <a:solidFill>
+              <a:srgbClr val="6366F1"/>
+            </a:solidFill>
+          </a:ln>
+        </p:spPr>
+        <p:style>
+          <a:lnRef idx="1">
+            <a:schemeClr val="accent1"/>
+          </a:lnRef>
+          <a:fillRef idx="3">
+            <a:schemeClr val="accent1"/>
+          </a:fillRef>
+          <a:effectRef idx="2">
+            <a:schemeClr val="accent1"/>
+          </a:effectRef>
+          <a:fontRef idx="minor">
+            <a:schemeClr val="lt1"/>
+          </a:fontRef>
+        </p:style>
+        <p:txBody>
+          <a:bodyPr rtlCol="0" anchor="ctr"/>
+          <a:lstStyle/>
+          <a:p>
+            <a:pPr algn="ctr"/>
+          </a:p>
+        </p:txBody>
+      </p:sp>
+      <p:sp>
+        <p:nvSpPr>
+          <p:cNvPr id="15" name="Rectangle 14"/>
+          <p:cNvSpPr/>
+          <p:nvPr/>
+        </p:nvSpPr>
+        <p:spPr>
+          <a:xfrm>
+            <a:off x="6638925" y="6477000"/>
+            <a:ext cx="4857750" cy="47624"/>
+          </a:xfrm>
+          <a:prstGeom prst="rect">
+            <a:avLst/>
+          </a:prstGeom>
+          <a:solidFill>
+            <a:srgbClr val="6366F1"/>
+          </a:solidFill>
+          <a:ln>
+            <a:noFill/>
+          </a:ln>
+        </p:spPr>
+        <p:style>
+          <a:lnRef idx="1">
+            <a:schemeClr val="accent1"/>
+          </a:lnRef>
+          <a:fillRef idx="3">
+            <a:schemeClr val="accent1"/>
+          </a:fillRef>
+          <a:effectRef idx="2">
+            <a:schemeClr val="accent1"/>
+          </a:effectRef>
+          <a:fontRef idx="minor">
+            <a:schemeClr val="lt1"/>
+          </a:fontRef>
+        </p:style>
+        <p:txBody>
+          <a:bodyPr rtlCol="0" anchor="ctr"/>
+          <a:lstStyle/>
+          <a:p>
+            <a:pPr algn="ctr"/>
+          </a:p>
+        </p:txBody>
+      </p:sp>
+      <p:sp>
+        <p:nvSpPr>
+          <p:cNvPr id="16" name="TextBox 15"/>
+          <p:cNvSpPr txBox="1"/>
+          <p:nvPr/>
+        </p:nvSpPr>
+        <p:spPr>
+          <a:xfrm>
+            <a:off x="6737984" y="6621780"/>
+            <a:ext cx="4476750" cy="152400"/>
+          </a:xfrm>
+          <a:prstGeom prst="rect">
+            <a:avLst/>
+          </a:prstGeom>
+          <a:noFill/>
+        </p:spPr>
+        <p:txBody>
+          <a:bodyPr wrap="none"/>
+          <a:lstStyle/>
+          <a:p>
+            <a:pPr algn="l">
+              <a:spcBef>
+                <a:spcPts val="0"/>
+              </a:spcBef>
+              <a:spcAft>
+                <a:spcPts val="0"/>
+              </a:spcAft>
+            </a:pPr>
+            <a:r>
+              <a:rPr sz="825" b="1" spc="225">
+                <a:solidFill>
+                  <a:srgbClr val="6366F1"/>
+                </a:solidFill>
+                <a:latin typeface="Inter Bold"/>
+              </a:rPr>
+              <a:t>THE CONTROL PLANE</a:t>
+            </a:r>
+          </a:p>
+        </p:txBody>
+      </p:sp>
+      <p:sp>
+        <p:nvSpPr>
+          <p:cNvPr id="17" name="TextBox 16"/>
+          <p:cNvSpPr txBox="1"/>
+          <p:nvPr/>
+        </p:nvSpPr>
+        <p:spPr>
+          <a:xfrm>
+            <a:off x="6737984" y="6850380"/>
+            <a:ext cx="4476750" cy="266700"/>
+          </a:xfrm>
+          <a:prstGeom prst="rect">
+            <a:avLst/>
+          </a:prstGeom>
+          <a:noFill/>
+        </p:spPr>
+        <p:txBody>
+          <a:bodyPr wrap="none"/>
+          <a:lstStyle/>
+          <a:p>
+            <a:pPr algn="l">
+              <a:spcBef>
+                <a:spcPts val="0"/>
+              </a:spcBef>
+              <a:spcAft>
+                <a:spcPts val="0"/>
+              </a:spcAft>
+            </a:pPr>
+            <a:r>
+              <a:rPr sz="1500" b="1">
+                <a:solidFill>
+                  <a:srgbClr val="FFFFFF"/>
+                </a:solidFill>
+                <a:latin typeface="Inter ExtraBold"/>
+              </a:rPr>
+              <a:t>Kubernetes API</a:t>
+            </a:r>
+          </a:p>
+        </p:txBody>
+      </p:sp>
+      <p:sp>
+        <p:nvSpPr>
+          <p:cNvPr id="18" name="TextBox 17"/>
+          <p:cNvSpPr txBox="1"/>
+          <p:nvPr/>
+        </p:nvSpPr>
+        <p:spPr>
+          <a:xfrm>
+            <a:off x="6737984" y="7212330"/>
+            <a:ext cx="4476750" cy="1904999"/>
+          </a:xfrm>
+          <a:prstGeom prst="rect">
+            <a:avLst/>
+          </a:prstGeom>
+          <a:noFill/>
+        </p:spPr>
+        <p:txBody>
+          <a:bodyPr wrap="square"/>
+          <a:lstStyle/>
+          <a:p>
+            <a:pPr algn="l">
+              <a:spcBef>
+                <a:spcPts val="0"/>
+              </a:spcBef>
+              <a:spcAft>
+                <a:spcPts val="0"/>
+              </a:spcAft>
+            </a:pPr>
+            <a:r>
+              <a:rPr sz="975" b="0">
+                <a:solidFill>
+                  <a:srgbClr val="555555"/>
+                </a:solidFill>
+                <a:latin typeface="Inter"/>
+              </a:rPr>
+              <a:t>The unified entry point for every team, tool, and automation. One API. One audit trail. Yours.</a:t>
+            </a:r>
+          </a:p>
+        </p:txBody>
+      </p:sp>
+      <p:sp>
+        <p:nvSpPr>
+          <p:cNvPr id="19" name="Rectangle 18"/>
+          <p:cNvSpPr/>
+          <p:nvPr/>
+        </p:nvSpPr>
+        <p:spPr>
+          <a:xfrm>
+            <a:off x="12134850" y="6477000"/>
+            <a:ext cx="4857750" cy="2857500"/>
+          </a:xfrm>
+          <a:prstGeom prst="rect">
+            <a:avLst/>
+          </a:prstGeom>
+          <a:solidFill>
+            <a:srgbClr val="111111"/>
+          </a:solidFill>
+          <a:ln>
+            <a:noFill/>
+          </a:ln>
+        </p:spPr>
+        <p:style>
+          <a:lnRef idx="1">
+            <a:schemeClr val="accent1"/>
+          </a:lnRef>
+          <a:fillRef idx="3">
+            <a:schemeClr val="accent1"/>
+          </a:fillRef>
+          <a:effectRef idx="2">
+            <a:schemeClr val="accent1"/>
+          </a:effectRef>
+          <a:fontRef idx="minor">
+            <a:schemeClr val="lt1"/>
+          </a:fontRef>
+        </p:style>
+        <p:txBody>
+          <a:bodyPr rtlCol="0" anchor="ctr"/>
+          <a:lstStyle/>
+          <a:p>
+            <a:pPr algn="ctr"/>
+          </a:p>
+        </p:txBody>
+      </p:sp>
+      <p:sp>
+        <p:nvSpPr>
+          <p:cNvPr id="20" name="Rectangle 19"/>
+          <p:cNvSpPr/>
+          <p:nvPr/>
+        </p:nvSpPr>
+        <p:spPr>
+          <a:xfrm>
+            <a:off x="12134850" y="6477000"/>
+            <a:ext cx="4857750" cy="47624"/>
+          </a:xfrm>
+          <a:prstGeom prst="rect">
+            <a:avLst/>
+          </a:prstGeom>
+          <a:solidFill>
+            <a:srgbClr val="10B981"/>
+          </a:solidFill>
+          <a:ln>
+            <a:noFill/>
+          </a:ln>
+        </p:spPr>
+        <p:style>
+          <a:lnRef idx="1">
+            <a:schemeClr val="accent1"/>
+          </a:lnRef>
+          <a:fillRef idx="3">
+            <a:schemeClr val="accent1"/>
+          </a:fillRef>
+          <a:effectRef idx="2">
+            <a:schemeClr val="accent1"/>
+          </a:effectRef>
+          <a:fontRef idx="minor">
+            <a:schemeClr val="lt1"/>
+          </a:fontRef>
+        </p:style>
+        <p:txBody>
+          <a:bodyPr rtlCol="0" anchor="ctr"/>
+          <a:lstStyle/>
+          <a:p>
+            <a:pPr algn="ctr"/>
+          </a:p>
+        </p:txBody>
+      </p:sp>
+      <p:sp>
+        <p:nvSpPr>
+          <p:cNvPr id="21" name="TextBox 20"/>
+          <p:cNvSpPr txBox="1"/>
+          <p:nvPr/>
+        </p:nvSpPr>
+        <p:spPr>
+          <a:xfrm>
+            <a:off x="12233910" y="6621780"/>
+            <a:ext cx="4476750" cy="152400"/>
+          </a:xfrm>
+          <a:prstGeom prst="rect">
+            <a:avLst/>
+          </a:prstGeom>
+          <a:noFill/>
+        </p:spPr>
+        <p:txBody>
+          <a:bodyPr wrap="none"/>
+          <a:lstStyle/>
+          <a:p>
+            <a:pPr algn="l">
+              <a:spcBef>
+                <a:spcPts val="0"/>
+              </a:spcBef>
+              <a:spcAft>
+                <a:spcPts val="0"/>
+              </a:spcAft>
+            </a:pPr>
+            <a:r>
+              <a:rPr sz="825" b="1" spc="225">
+                <a:solidFill>
+                  <a:srgbClr val="10B981"/>
+                </a:solidFill>
+                <a:latin typeface="Inter Bold"/>
+              </a:rPr>
+              <a:t>THE PROVISIONERS</a:t>
+            </a:r>
+          </a:p>
+        </p:txBody>
+      </p:sp>
+      <p:sp>
+        <p:nvSpPr>
+          <p:cNvPr id="22" name="TextBox 21"/>
+          <p:cNvSpPr txBox="1"/>
+          <p:nvPr/>
+        </p:nvSpPr>
+        <p:spPr>
+          <a:xfrm>
+            <a:off x="12233910" y="6850380"/>
+            <a:ext cx="4476750" cy="266700"/>
+          </a:xfrm>
+          <a:prstGeom prst="rect">
+            <a:avLst/>
+          </a:prstGeom>
+          <a:noFill/>
+        </p:spPr>
+        <p:txBody>
+          <a:bodyPr wrap="none"/>
+          <a:lstStyle/>
+          <a:p>
+            <a:pPr algn="l">
+              <a:spcBef>
+                <a:spcPts val="0"/>
+              </a:spcBef>
+              <a:spcAft>
+                <a:spcPts val="0"/>
+              </a:spcAft>
+            </a:pPr>
+            <a:r>
+              <a:rPr sz="1500" b="1">
+                <a:solidFill>
+                  <a:srgbClr val="FFFFFF"/>
+                </a:solidFill>
+                <a:latin typeface="Inter ExtraBold"/>
+              </a:rPr>
+              <a:t>Four tools. One Azure.</a:t>
+            </a:r>
+          </a:p>
+        </p:txBody>
+      </p:sp>
+      <p:sp>
+        <p:nvSpPr>
+          <p:cNvPr id="23" name="TextBox 22"/>
+          <p:cNvSpPr txBox="1"/>
+          <p:nvPr/>
+        </p:nvSpPr>
+        <p:spPr>
+          <a:xfrm>
+            <a:off x="12233910" y="7212330"/>
+            <a:ext cx="4476750" cy="190499"/>
+          </a:xfrm>
+          <a:prstGeom prst="rect">
+            <a:avLst/>
+          </a:prstGeom>
+          <a:noFill/>
+        </p:spPr>
+        <p:txBody>
+          <a:bodyPr wrap="none"/>
+          <a:lstStyle/>
+          <a:p>
+            <a:pPr algn="l">
+              <a:spcBef>
+                <a:spcPts val="0"/>
+              </a:spcBef>
+              <a:spcAft>
+                <a:spcPts val="0"/>
+              </a:spcAft>
+            </a:pPr>
+            <a:r>
+              <a:rPr sz="975" b="0">
+                <a:solidFill>
+                  <a:srgbClr val="0078D4"/>
+                </a:solidFill>
+                <a:latin typeface="Inter"/>
+              </a:rPr>
+              <a:t>— ASO  ·  direct Azure control</a:t>
+            </a:r>
+          </a:p>
+        </p:txBody>
+      </p:sp>
+      <p:sp>
+        <p:nvSpPr>
+          <p:cNvPr id="24" name="TextBox 23"/>
+          <p:cNvSpPr txBox="1"/>
+          <p:nvPr/>
+        </p:nvSpPr>
+        <p:spPr>
+          <a:xfrm>
+            <a:off x="12233910" y="7440930"/>
+            <a:ext cx="4476750" cy="190499"/>
+          </a:xfrm>
+          <a:prstGeom prst="rect">
+            <a:avLst/>
+          </a:prstGeom>
+          <a:noFill/>
+        </p:spPr>
+        <p:txBody>
+          <a:bodyPr wrap="none"/>
+          <a:lstStyle/>
+          <a:p>
+            <a:pPr algn="l">
+              <a:spcBef>
+                <a:spcPts val="0"/>
+              </a:spcBef>
+              <a:spcAft>
+                <a:spcPts val="0"/>
+              </a:spcAft>
+            </a:pPr>
+            <a:r>
+              <a:rPr sz="975" b="0">
+                <a:solidFill>
+                  <a:srgbClr val="EF4444"/>
+                </a:solidFill>
+                <a:latin typeface="Inter"/>
+              </a:rPr>
+              <a:t>— Crossplane  ·  platform abstractions</a:t>
+            </a:r>
+          </a:p>
+        </p:txBody>
+      </p:sp>
+      <p:sp>
+        <p:nvSpPr>
+          <p:cNvPr id="25" name="TextBox 24"/>
+          <p:cNvSpPr txBox="1"/>
+          <p:nvPr/>
+        </p:nvSpPr>
+        <p:spPr>
+          <a:xfrm>
+            <a:off x="12233910" y="7669530"/>
+            <a:ext cx="4476750" cy="190499"/>
+          </a:xfrm>
+          <a:prstGeom prst="rect">
+            <a:avLst/>
+          </a:prstGeom>
+          <a:noFill/>
+        </p:spPr>
+        <p:txBody>
+          <a:bodyPr wrap="none"/>
+          <a:lstStyle/>
+          <a:p>
+            <a:pPr algn="l">
+              <a:spcBef>
+                <a:spcPts val="0"/>
+              </a:spcBef>
+              <a:spcAft>
+                <a:spcPts val="0"/>
+              </a:spcAft>
+            </a:pPr>
+            <a:r>
+              <a:rPr sz="975" b="0">
+                <a:solidFill>
+                  <a:srgbClr val="8B5CF6"/>
+                </a:solidFill>
+                <a:latin typeface="Inter"/>
+              </a:rPr>
+              <a:t>— KRO  ·  app bundles  ·  Terranetes  ·  Terraform</a:t>
+            </a:r>
+          </a:p>
+        </p:txBody>
+      </p:sp>
+      <p:sp>
+        <p:nvSpPr>
+          <p:cNvPr id="26" name="TextBox 25"/>
+          <p:cNvSpPr txBox="1"/>
+          <p:nvPr/>
+        </p:nvSpPr>
+        <p:spPr>
+          <a:xfrm>
+            <a:off x="6099810" y="7574280"/>
+            <a:ext cx="285750" cy="285750"/>
+          </a:xfrm>
+          <a:prstGeom prst="rect">
+            <a:avLst/>
+          </a:prstGeom>
+          <a:noFill/>
+        </p:spPr>
+        <p:txBody>
+          <a:bodyPr wrap="none"/>
+          <a:lstStyle/>
+          <a:p>
+            <a:pPr algn="l">
+              <a:spcBef>
+                <a:spcPts val="0"/>
+              </a:spcBef>
+              <a:spcAft>
+                <a:spcPts val="0"/>
+              </a:spcAft>
+            </a:pPr>
+            <a:r>
+              <a:rPr sz="1500" b="1">
+                <a:solidFill>
+                  <a:srgbClr val="444444"/>
+                </a:solidFill>
+                <a:latin typeface="Inter Bold"/>
+              </a:rPr>
+              <a:t>→</a:t>
+            </a:r>
+          </a:p>
+        </p:txBody>
+      </p:sp>
+      <p:sp>
+        <p:nvSpPr>
+          <p:cNvPr id="27" name="TextBox 26"/>
+          <p:cNvSpPr txBox="1"/>
+          <p:nvPr/>
+        </p:nvSpPr>
+        <p:spPr>
+          <a:xfrm>
+            <a:off x="11595735" y="7574280"/>
+            <a:ext cx="285750" cy="285750"/>
+          </a:xfrm>
+          <a:prstGeom prst="rect">
+            <a:avLst/>
+          </a:prstGeom>
+          <a:noFill/>
+        </p:spPr>
+        <p:txBody>
+          <a:bodyPr wrap="none"/>
+          <a:lstStyle/>
+          <a:p>
+            <a:pPr algn="l">
+              <a:spcBef>
+                <a:spcPts val="0"/>
+              </a:spcBef>
+              <a:spcAft>
+                <a:spcPts val="0"/>
+              </a:spcAft>
+            </a:pPr>
+            <a:r>
+              <a:rPr sz="1500" b="1">
+                <a:solidFill>
+                  <a:srgbClr val="444444"/>
+                </a:solidFill>
+                <a:latin typeface="Inter Bold"/>
+              </a:rPr>
+              <a:t>→</a:t>
+            </a:r>
+          </a:p>
+        </p:txBody>
+      </p:sp>
+    </p:spTree>
+  </p:cSld>
+  <p:clrMapOvr>
+    <a:masterClrMapping/>
+  </p:clrMapOvr>
+</p:sld>
+</file>
+
+<file path=ppt/slides/slide48.xml><?xml version="1.0" encoding="utf-8"?>
+<p:sld xmlns:a="http://schemas.openxmlformats.org/drawingml/2006/main" xmlns:p="http://schemas.openxmlformats.org/presentationml/2006/main" xmlns:r="http://schemas.openxmlformats.org/officeDocument/2006/relationships">
+  <p:cSld>
+    <p:spTree>
+      <p:nvGrpSpPr>
+        <p:cNvPr id="1" name=""/>
+        <p:cNvGrpSpPr/>
+        <p:nvPr/>
+      </p:nvGrpSpPr>
+      <p:grpSpPr/>
+      <p:sp>
+        <p:nvSpPr>
+          <p:cNvPr id="2" name="Rectangle 1"/>
+          <p:cNvSpPr/>
+          <p:nvPr/>
+        </p:nvSpPr>
+        <p:spPr>
+          <a:xfrm>
+            <a:off x="0" y="0"/>
+            <a:ext cx="18288000" cy="10287000"/>
+          </a:xfrm>
+          <a:prstGeom prst="rect">
+            <a:avLst/>
+          </a:prstGeom>
+          <a:solidFill>
+            <a:srgbClr val="000000"/>
+          </a:solidFill>
+          <a:ln>
+            <a:noFill/>
+          </a:ln>
+        </p:spPr>
+        <p:style>
+          <a:lnRef idx="1">
+            <a:schemeClr val="accent1"/>
+          </a:lnRef>
+          <a:fillRef idx="3">
+            <a:schemeClr val="accent1"/>
+          </a:fillRef>
+          <a:effectRef idx="2">
+            <a:schemeClr val="accent1"/>
+          </a:effectRef>
+          <a:fontRef idx="minor">
+            <a:schemeClr val="lt1"/>
+          </a:fontRef>
+        </p:style>
+        <p:txBody>
+          <a:bodyPr rtlCol="0" anchor="ctr"/>
+          <a:lstStyle/>
+          <a:p>
+            <a:pPr algn="ctr"/>
+          </a:p>
+        </p:txBody>
+      </p:sp>
+      <p:sp>
+        <p:nvSpPr>
+          <p:cNvPr id="3" name="Rectangle 2"/>
+          <p:cNvSpPr/>
+          <p:nvPr/>
+        </p:nvSpPr>
+        <p:spPr>
+          <a:xfrm>
+            <a:off x="0" y="0"/>
+            <a:ext cx="76200" cy="10287000"/>
+          </a:xfrm>
+          <a:prstGeom prst="rect">
+            <a:avLst/>
+          </a:prstGeom>
+          <a:solidFill>
+            <a:srgbClr val="FFFFFF"/>
+          </a:solidFill>
+          <a:ln>
+            <a:noFill/>
+          </a:ln>
+        </p:spPr>
+        <p:style>
+          <a:lnRef idx="1">
+            <a:schemeClr val="accent1"/>
+          </a:lnRef>
+          <a:fillRef idx="3">
+            <a:schemeClr val="accent1"/>
+          </a:fillRef>
+          <a:effectRef idx="2">
+            <a:schemeClr val="accent1"/>
+          </a:effectRef>
+          <a:fontRef idx="minor">
+            <a:schemeClr val="lt1"/>
+          </a:fontRef>
+        </p:style>
+        <p:txBody>
+          <a:bodyPr rtlCol="0" anchor="ctr"/>
+          <a:lstStyle/>
+          <a:p>
+            <a:pPr algn="ctr"/>
+          </a:p>
+        </p:txBody>
+      </p:sp>
+      <p:sp>
+        <p:nvSpPr>
+          <p:cNvPr id="4" name="Rectangle 3"/>
+          <p:cNvSpPr/>
+          <p:nvPr/>
+        </p:nvSpPr>
+        <p:spPr>
+          <a:xfrm>
+            <a:off x="16383000" y="10096500"/>
+            <a:ext cx="1905000" cy="76200"/>
+          </a:xfrm>
+          <a:prstGeom prst="rect">
+            <a:avLst/>
+          </a:prstGeom>
+          <a:solidFill>
+            <a:srgbClr val="FFFFFF"/>
+          </a:solidFill>
+          <a:ln>
+            <a:noFill/>
+          </a:ln>
+        </p:spPr>
+        <p:style>
+          <a:lnRef idx="1">
+            <a:schemeClr val="accent1"/>
+          </a:lnRef>
+          <a:fillRef idx="3">
+            <a:schemeClr val="accent1"/>
+          </a:fillRef>
+          <a:effectRef idx="2">
+            <a:schemeClr val="accent1"/>
+          </a:effectRef>
+          <a:fontRef idx="minor">
+            <a:schemeClr val="lt1"/>
+          </a:fontRef>
+        </p:style>
+        <p:txBody>
+          <a:bodyPr rtlCol="0" anchor="ctr"/>
+          <a:lstStyle/>
+          <a:p>
+            <a:pPr algn="ctr"/>
+          </a:p>
+        </p:txBody>
+      </p:sp>
+      <p:sp>
+        <p:nvSpPr>
+          <p:cNvPr id="5" name="Oval 4"/>
+          <p:cNvSpPr/>
+          <p:nvPr/>
+        </p:nvSpPr>
+        <p:spPr>
+          <a:xfrm>
+            <a:off x="16954500" y="1523999"/>
+            <a:ext cx="133350" cy="133350"/>
+          </a:xfrm>
+          <a:prstGeom prst="ellipse">
+            <a:avLst/>
+          </a:prstGeom>
+          <a:solidFill>
+            <a:srgbClr val="FFFFFF"/>
+          </a:solidFill>
+          <a:ln>
+            <a:noFill/>
+          </a:ln>
+        </p:spPr>
+        <p:style>
+          <a:lnRef idx="1">
+            <a:schemeClr val="accent1"/>
+          </a:lnRef>
+          <a:fillRef idx="3">
+            <a:schemeClr val="accent1"/>
+          </a:fillRef>
+          <a:effectRef idx="2">
+            <a:schemeClr val="accent1"/>
+          </a:effectRef>
+          <a:fontRef idx="minor">
+            <a:schemeClr val="lt1"/>
+          </a:fontRef>
+        </p:style>
+        <p:txBody>
+          <a:bodyPr rtlCol="0" anchor="ctr"/>
+          <a:lstStyle/>
+          <a:p>
+            <a:pPr algn="ctr"/>
+          </a:p>
+        </p:txBody>
+      </p:sp>
+      <p:sp>
+        <p:nvSpPr>
+          <p:cNvPr id="6" name="Oval 5"/>
+          <p:cNvSpPr/>
+          <p:nvPr/>
+        </p:nvSpPr>
+        <p:spPr>
+          <a:xfrm>
+            <a:off x="17335500" y="1523999"/>
+            <a:ext cx="133350" cy="133350"/>
+          </a:xfrm>
+          <a:prstGeom prst="ellipse">
+            <a:avLst/>
+          </a:prstGeom>
+          <a:solidFill>
+            <a:srgbClr val="FFFFFF">
+              <a:alpha val="40000"/>
+            </a:srgbClr>
+          </a:solidFill>
+          <a:ln>
+            <a:noFill/>
+          </a:ln>
+        </p:spPr>
+        <p:style>
+          <a:lnRef idx="1">
+            <a:schemeClr val="accent1"/>
+          </a:lnRef>
+          <a:fillRef idx="3">
+            <a:schemeClr val="accent1"/>
+          </a:fillRef>
+          <a:effectRef idx="2">
+            <a:schemeClr val="accent1"/>
+          </a:effectRef>
+          <a:fontRef idx="minor">
+            <a:schemeClr val="lt1"/>
+          </a:fontRef>
+        </p:style>
+        <p:txBody>
+          <a:bodyPr rtlCol="0" anchor="ctr"/>
+          <a:lstStyle/>
+          <a:p>
+            <a:pPr algn="ctr"/>
+          </a:p>
+        </p:txBody>
+      </p:sp>
+      <p:sp>
+        <p:nvSpPr>
+          <p:cNvPr id="7" name="Oval 6"/>
+          <p:cNvSpPr/>
+          <p:nvPr/>
+        </p:nvSpPr>
+        <p:spPr>
+          <a:xfrm>
+            <a:off x="17716500" y="1523999"/>
+            <a:ext cx="133350" cy="133350"/>
+          </a:xfrm>
+          <a:prstGeom prst="ellipse">
+            <a:avLst/>
+          </a:prstGeom>
+          <a:solidFill>
+            <a:srgbClr val="FFFFFF">
+              <a:alpha val="20000"/>
+            </a:srgbClr>
+          </a:solidFill>
+          <a:ln>
+            <a:noFill/>
+          </a:ln>
+        </p:spPr>
+        <p:style>
+          <a:lnRef idx="1">
+            <a:schemeClr val="accent1"/>
+          </a:lnRef>
+          <a:fillRef idx="3">
+            <a:schemeClr val="accent1"/>
+          </a:fillRef>
+          <a:effectRef idx="2">
+            <a:schemeClr val="accent1"/>
+          </a:effectRef>
+          <a:fontRef idx="minor">
+            <a:schemeClr val="lt1"/>
+          </a:fontRef>
+        </p:style>
+        <p:txBody>
+          <a:bodyPr rtlCol="0" anchor="ctr"/>
+          <a:lstStyle/>
+          <a:p>
+            <a:pPr algn="ctr"/>
+          </a:p>
+        </p:txBody>
+      </p:sp>
+      <p:sp>
+        <p:nvSpPr>
+          <p:cNvPr id="8" name="TextBox 7"/>
+          <p:cNvSpPr txBox="1"/>
+          <p:nvPr/>
+        </p:nvSpPr>
+        <p:spPr>
+          <a:xfrm>
+            <a:off x="4671060" y="2049780"/>
+            <a:ext cx="13525500" cy="6095999"/>
+          </a:xfrm>
+          <a:prstGeom prst="rect">
+            <a:avLst/>
+          </a:prstGeom>
+          <a:noFill/>
+        </p:spPr>
+        <p:txBody>
+          <a:bodyPr wrap="none"/>
+          <a:lstStyle/>
+          <a:p>
+            <a:pPr algn="l">
+              <a:spcBef>
+                <a:spcPts val="0"/>
+              </a:spcBef>
+              <a:spcAft>
+                <a:spcPts val="0"/>
+              </a:spcAft>
+            </a:pPr>
+            <a:r>
+              <a:rPr sz="37500" b="1">
+                <a:solidFill>
+                  <a:srgbClr val="FFFFFF">
+                    <a:alpha val="5000"/>
+                  </a:srgbClr>
+                </a:solidFill>
+                <a:latin typeface="Inter Black"/>
+              </a:rPr>
+              <a:t>SAFE</a:t>
+            </a:r>
+          </a:p>
+        </p:txBody>
+      </p:sp>
+      <p:sp>
+        <p:nvSpPr>
+          <p:cNvPr id="9" name="Rectangle 8"/>
+          <p:cNvSpPr/>
+          <p:nvPr/>
+        </p:nvSpPr>
+        <p:spPr>
+          <a:xfrm>
+            <a:off x="1143000" y="1143000"/>
+            <a:ext cx="133350" cy="133350"/>
+          </a:xfrm>
+          <a:prstGeom prst="rect">
+            <a:avLst/>
+          </a:prstGeom>
+          <a:solidFill>
+            <a:srgbClr val="FFFFFF"/>
+          </a:solidFill>
+          <a:ln>
+            <a:noFill/>
+          </a:ln>
+        </p:spPr>
+        <p:style>
+          <a:lnRef idx="1">
+            <a:schemeClr val="accent1"/>
+          </a:lnRef>
+          <a:fillRef idx="3">
+            <a:schemeClr val="accent1"/>
+          </a:fillRef>
+          <a:effectRef idx="2">
+            <a:schemeClr val="accent1"/>
+          </a:effectRef>
+          <a:fontRef idx="minor">
+            <a:schemeClr val="lt1"/>
+          </a:fontRef>
+        </p:style>
+        <p:txBody>
+          <a:bodyPr rtlCol="0" anchor="ctr"/>
+          <a:lstStyle/>
+          <a:p>
+            <a:pPr algn="ctr"/>
+          </a:p>
+        </p:txBody>
+      </p:sp>
+      <p:sp>
+        <p:nvSpPr>
+          <p:cNvPr id="10" name="TextBox 9"/>
+          <p:cNvSpPr txBox="1"/>
+          <p:nvPr/>
+        </p:nvSpPr>
+        <p:spPr>
+          <a:xfrm>
+            <a:off x="1337310" y="1049655"/>
+            <a:ext cx="5715000" cy="228600"/>
+          </a:xfrm>
+          <a:prstGeom prst="rect">
+            <a:avLst/>
+          </a:prstGeom>
+          <a:noFill/>
+        </p:spPr>
+        <p:txBody>
+          <a:bodyPr wrap="none"/>
+          <a:lstStyle/>
+          <a:p>
+            <a:pPr algn="l">
+              <a:spcBef>
+                <a:spcPts val="0"/>
+              </a:spcBef>
+              <a:spcAft>
+                <a:spcPts val="0"/>
+              </a:spcAft>
+            </a:pPr>
+            <a:r>
+              <a:rPr sz="1500" b="0" spc="300">
+                <a:solidFill>
+                  <a:srgbClr val="FFFFFF"/>
+                </a:solidFill>
+                <a:latin typeface="Inter SemiBold"/>
+              </a:rPr>
+              <a:t>11 / CLOSING</a:t>
+            </a:r>
+          </a:p>
+        </p:txBody>
+      </p:sp>
+      <p:sp>
+        <p:nvSpPr>
+          <p:cNvPr id="11" name="TextBox 10"/>
+          <p:cNvSpPr txBox="1"/>
+          <p:nvPr/>
+        </p:nvSpPr>
+        <p:spPr>
+          <a:xfrm>
+            <a:off x="1051560" y="7155180"/>
+            <a:ext cx="16002000" cy="1333500"/>
+          </a:xfrm>
+          <a:prstGeom prst="rect">
+            <a:avLst/>
+          </a:prstGeom>
+          <a:noFill/>
+        </p:spPr>
+        <p:txBody>
+          <a:bodyPr wrap="none"/>
+          <a:lstStyle/>
+          <a:p>
+            <a:pPr algn="l">
+              <a:spcBef>
+                <a:spcPts val="0"/>
+              </a:spcBef>
+              <a:spcAft>
+                <a:spcPts val="0"/>
+              </a:spcAft>
+            </a:pPr>
+            <a:r>
+              <a:rPr sz="12000" b="1">
+                <a:solidFill>
+                  <a:srgbClr val="FFFFFF"/>
+                </a:solidFill>
+                <a:latin typeface="Inter Black"/>
+              </a:rPr>
+              <a:t>MAKE YES SAFE.</a:t>
+            </a:r>
+          </a:p>
+        </p:txBody>
+      </p:sp>
+      <p:sp>
+        <p:nvSpPr>
+          <p:cNvPr id="12" name="TextBox 11"/>
+          <p:cNvSpPr txBox="1"/>
+          <p:nvPr/>
+        </p:nvSpPr>
+        <p:spPr>
+          <a:xfrm>
+            <a:off x="1051560" y="8564880"/>
+            <a:ext cx="16002000" cy="723900"/>
+          </a:xfrm>
+          <a:prstGeom prst="rect">
+            <a:avLst/>
+          </a:prstGeom>
+          <a:noFill/>
+        </p:spPr>
+        <p:txBody>
+          <a:bodyPr wrap="none"/>
+          <a:lstStyle/>
+          <a:p>
+            <a:pPr algn="l">
+              <a:spcBef>
+                <a:spcPts val="0"/>
+              </a:spcBef>
+              <a:spcAft>
+                <a:spcPts val="0"/>
+              </a:spcAft>
+            </a:pPr>
+            <a:r>
+              <a:rPr sz="6300" b="1">
+                <a:solidFill>
+                  <a:srgbClr val="666666"/>
+                </a:solidFill>
+                <a:latin typeface="Inter Black"/>
+              </a:rPr>
+              <a:t>THANK YOU.</a:t>
             </a:r>
           </a:p>
         </p:txBody>

</xml_diff>